<commit_message>
Assistente virtuale con Claude (funzione assistente, script 31, base di conoscenza, pulsante «Assistente»); documenti ufficiali del Programma nella Documentazione; barra a LED più fine; manuali, registro e presentazione 2.1
Co-Authored-By: Claude Opus 5.5 <noreply@anthropic.com>
Claude-Session: https://claude.ai/code/session_01E8XCbEeVHWVP3hntUZ6kZ1
</commit_message>
<xml_diff>
--- a/public/documentazione/Presentazione_Portale_CWP.pptx
+++ b/public/documentazione/Presentazione_Portale_CWP.pptx
@@ -120,39 +120,39 @@
   <p:extLst>
     <p:ext uri="{521415D9-36F7-43E2-AB2F-B90AF26B5E84}">
       <p14:sectionLst xmlns:p14="http://schemas.microsoft.com/office/powerpoint/2010/main">
-        <p14:section name="Apertura" id="{5fd3adc2-d005-ef74-6a75-76b19b437f57}">
+        <p14:section name="Apertura" id="{c020b8ea-75b7-6335-c8c0-5a126b74730d}">
           <p14:sldIdLst>
             <p14:sldId id="256"/>
           </p14:sldIdLst>
         </p14:section>
-        <p14:section name="Metodologia" id="{4841dc62-dec2-ee1f-a0c6-f183464f1a9b}">
+        <p14:section name="Metodologia" id="{e9b60671-3a7b-234a-646d-c71b1912a013}">
           <p14:sldIdLst>
             <p14:sldId id="257"/>
           </p14:sldIdLst>
         </p14:section>
-        <p14:section name="Analisi funzionale" id="{86a39a2f-6825-1ea3-bac4-a815e207d50c}">
+        <p14:section name="Analisi funzionale" id="{8b195e39-8bff-d44d-d9cc-0f703a0085c1}">
           <p14:sldIdLst>
             <p14:sldId id="258"/>
             <p14:sldId id="259"/>
           </p14:sldIdLst>
         </p14:section>
-        <p14:section name="Già realtà" id="{773cd932-d0ba-6695-1855-b666ad93beff}">
+        <p14:section name="Già realtà" id="{9b56cd69-9048-7630-76b0-733bfc305b53}">
           <p14:sldIdLst>
             <p14:sldId id="260"/>
           </p14:sldIdLst>
         </p14:section>
-        <p14:section name="Architettura e ruoli" id="{55ed6f73-40e1-bb33-fffb-ebc0d1911b17}">
+        <p14:section name="Architettura e ruoli" id="{06bacbb1-e841-4b26-c19f-af95044424e2}">
           <p14:sldIdLst>
             <p14:sldId id="261"/>
             <p14:sldId id="262"/>
           </p14:sldIdLst>
         </p14:section>
-        <p14:section name="Novità" id="{b299f576-8413-ffdc-6ccd-28aa51eb1917}">
+        <p14:section name="Novità" id="{2dd705d3-520c-8e0c-575e-dfbede3df265}">
           <p14:sldIdLst>
             <p14:sldId id="263"/>
           </p14:sldIdLst>
         </p14:section>
-        <p14:section name="Punti aperti" id="{fe634d0f-4ab1-b6fb-e180-4e3bb877269c}">
+        <p14:section name="Punti aperti" id="{463577cf-8950-f50b-2f6b-9e8c1290604f}">
           <p14:sldIdLst>
             <p14:sldId id="264"/>
             <p14:sldId id="265"/>
@@ -161,7 +161,7 @@
             <p14:sldId id="268"/>
           </p14:sldIdLst>
         </p14:section>
-        <p14:section name="Scelte da prendere" id="{1d176e96-c04f-b2d4-8db5-729fb5ac488c}">
+        <p14:section name="Scelte da prendere" id="{ac04c7dd-d479-52e7-bdf4-9be2552045b8}">
           <p14:sldIdLst>
             <p14:sldId id="269"/>
           </p14:sldIdLst>
@@ -570,7 +570,7 @@
           <a:p>
             <a:r>
               <a:rPr lang="en-US" dirty="0"/>
-              <a:t>Presentazione di riepilogo del portale, aggiornata al 19 ottobre 2026 (revisione 2.0): metodologia, funzioni realizzate, novità, punti aperti di sviluppo e scelte ancora da prendere. Si rigenera a ogni rilascio insieme agli altri documenti ed è disponibile agli Amministratori nella pagina Documentazione del portale.</a:t>
+              <a:t>Presentazione di riepilogo del portale, aggiornata al 19 ottobre 2026 (revisione 2.1): metodologia, funzioni realizzate, novità, punti aperti di sviluppo e scelte ancora da prendere. Si rigenera a ogni rilascio insieme agli altri documenti ed è disponibile agli Amministratori nella pagina Documentazione del portale.</a:t>
             </a:r>
             <a:endParaRPr lang="en-US" dirty="0"/>
           </a:p>
@@ -658,7 +658,7 @@
           <a:p>
             <a:r>
               <a:rPr lang="en-US" dirty="0"/>
-              <a:t>Due nuovi moduli entrano nel progetto e in tutti i documenti (Registro, backlog punti 37 e 21). Simulatore di scenari, richiesto da Luca il 19/10: per ogni Comune si creano più scenari; la durata si sceglie da un menu a tendina tra 7, 10 e 21 anni (Standard 4.3.8: periodo di 10 anni oppure 7 rinnovabili fino a 21); si acquisiscono i dati dell'anno base (popolazione, produzione totale e pro capite, raccolta differenziata, ripartizione per frazione, parametri del calcolo); per ogni anno si inseriscono gli obiettivi di produzione totale e pro capite e di secco residuo pro capite; il simulatore ricalcola la percentuale di differenziata e stima anno per anno i crediti che il Comune potrebbe generare, con due metodi: il bilancio del Comune (tutte le utenze insieme, il più prudente) e il metodo per utenza con le sole utenze virtuose e il buffer del Capitolo 7, lo stesso delle stime dell'Allegato A dei contratti EsaCom. È una stima ex ante utile a presentare il Programma ai Comuni: il modello semplificato va confermato dalla Fondazione. Assistente virtuale: basato sui modelli Claude di Anthropic, integrato nel portale, aiuta Comuni e Operatori ma non decide; costi d'uso e dati leggibili da definire.</a:t>
+              <a:t>Due nuovi moduli entrano nel progetto e in tutti i documenti (Registro, backlog punti 37 e 21). Simulatore di scenari, richiesto da Luca il 19/10: per ogni Comune si creano più scenari; la durata si sceglie da un menu a tendina tra 7, 10 e 21 anni (Standard 4.3.8: periodo di 10 anni oppure 7 rinnovabili fino a 21); si acquisiscono i dati dell'anno base (popolazione, produzione totale e pro capite, raccolta differenziata, ripartizione per frazione, parametri del calcolo); per ogni anno si inseriscono gli obiettivi di produzione totale e pro capite e di secco residuo pro capite; il simulatore ricalcola la percentuale di differenziata e stima anno per anno i crediti che il Comune potrebbe generare, con due metodi: il bilancio del Comune (tutte le utenze insieme, il più prudente) e il metodo per utenza con le sole utenze virtuose e il buffer del Capitolo 7, lo stesso delle stime dell'Allegato A dei contratti EsaCom. È una stima ex ante utile a presentare il Programma ai Comuni: il modello semplificato va confermato dalla Fondazione. Assistente virtuale (prima versione del 19/10, da attivare): pulsante «✦ Assistente» per Amministratori e utenti degli enti; risponde in italiano solo dalla base di conoscenza (Manuale Utente e tariffe per gli enti, in più Manuale Amministratore e note sul calcolo per gli Amministratori), non vede le pratiche, non salva i testi, limite di 40 domande al giorno per utente. Funziona con Claude Haiku 5.5 tramite la funzione del server «assistente»; la base di conoscenza resta nella cache dei prompt, quindi una domanda costa di solito meno di un centesimo di dollaro. Per attivarlo serve una chiave della Claude Console inserita da Luca nei segreti di Supabase: l'uso API è fatturato a parte rispetto ai piani claude.ai, ma con un piano Max o Team si possono collegare i crediti API mensili del piano all'organizzazione della Console. Passi successivi: Operatori e aiuto sulla singola pratica.</a:t>
             </a:r>
             <a:endParaRPr lang="en-US" dirty="0"/>
           </a:p>
@@ -1362,7 +1362,7 @@
           <a:p>
             <a:r>
               <a:rPr lang="en-US" dirty="0"/>
-              <a:t>Pagina «effetto sorpresa»: nessuno si aspetta che il portale sia già online. Il sistema è stato realizzato da Luca Moretti con l'ausilio di Claude Code ed è quasi terminato; i servizi sono già in produzione: GitHub (codice), Vercel (pubblicazione del portale), Supabase (database, utenti, documenti, funzioni) e Resend (email). Il portale è pubblicato su portale-cwp.vercel.app e funziona con dati di prova: si può aprire durante la presentazione (collegamento cliccabile) o inquadrare il codice QR con il telefono. La pagina pubblica /programma mostra già gli 8 documenti ufficiali del Programma, la Metodologia approvata, la PEC e il soggetto promotore. Lo sviluppo del portale vero è partito il 17 ottobre 2026: da allora sono state pubblicate 111 versioni, 30 script del database e 5 funzioni sul server. Restano i punti aperti delle prossime slide (servizi a pagamento, sicurezza, dati da inserire, collaudo con un Comune). Suggerimento: aprire il portale dal vivo con un utente di prova e mostrare la pagina pubblica.</a:t>
+              <a:t>Pagina «effetto sorpresa»: nessuno si aspetta che il portale sia già online. Il sistema è stato realizzato da Luca Moretti con l'ausilio di Claude Code ed è quasi terminato; i servizi sono già in produzione: GitHub (codice), Vercel (pubblicazione del portale), Supabase (database, utenti, documenti, funzioni) e Resend (email). Il portale è pubblicato su portale-cwp.vercel.app e funziona con dati di prova: si può aprire durante la presentazione (collegamento cliccabile) o inquadrare il codice QR con il telefono. La pagina pubblica /programma mostra già gli 8 documenti ufficiali del Programma, la Metodologia approvata, la PEC e il soggetto promotore. Lo sviluppo del portale vero è partito il 17 ottobre 2026: da allora sono state pubblicate 112 versioni, 31 script del database e 6 funzioni sul server. Restano i punti aperti delle prossime slide (servizi a pagamento, sicurezza, dati da inserire, collaudo con un Comune). Suggerimento: aprire il portale dal vivo con un utente di prova e mostrare la pagina pubblica.</a:t>
             </a:r>
             <a:endParaRPr lang="en-US" dirty="0"/>
           </a:p>
@@ -2073,7 +2073,7 @@
                   <a:schemeClr val="accent6"/>
                 </a:solidFill>
               </a:rPr>
-              <a:t>Portale Carbon WastePrint · Stato dei lavori e recap · 19 ottobre 2026 · rev. 2.0</a:t>
+              <a:t>Portale Carbon WastePrint · Stato dei lavori e recap · 19 ottobre 2026 · rev. 2.1</a:t>
             </a:r>
             <a:endParaRPr lang="en-US" sz="1000" dirty="0"/>
           </a:p>
@@ -2571,7 +2571,7 @@
                   <a:schemeClr val="accent3"/>
                 </a:solidFill>
               </a:rPr>
-              <a:t>Stato dei lavori e recap: metodologia, funzioni, novità, punti aperti e scelte da prendere · aggiornata al 19 ottobre 2026 · rev. 2.0</a:t>
+              <a:t>Stato dei lavori e recap: metodologia, funzioni, novità, punti aperti e scelte da prendere · aggiornata al 19 ottobre 2026 · rev. 2.1</a:t>
             </a:r>
             <a:endParaRPr lang="en-US" sz="1800" dirty="0"/>
           </a:p>
@@ -3778,14 +3778,14 @@
       </p:sp>
       <p:sp>
         <p:nvSpPr>
-          <p:cNvPr id="34" name="Badge in arrivo"/>
+          <p:cNvPr id="34" name="Badge pronto"/>
           <p:cNvSpPr/>
           <p:nvPr/>
         </p:nvSpPr>
         <p:spPr>
           <a:xfrm>
             <a:off x="8778240" y="2029968"/>
-            <a:ext cx="1188720" cy="256032"/>
+            <a:ext cx="2194560" cy="256032"/>
           </a:xfrm>
           <a:prstGeom prst="roundRect">
             <a:avLst>
@@ -3812,7 +3812,7 @@
         <p:spPr>
           <a:xfrm>
             <a:off x="8778240" y="2029968"/>
-            <a:ext cx="1188720" cy="256032"/>
+            <a:ext cx="2194560" cy="256032"/>
           </a:xfrm>
           <a:prstGeom prst="rect">
             <a:avLst/>
@@ -3833,7 +3833,7 @@
                   <a:schemeClr val="tx2"/>
                 </a:solidFill>
               </a:rPr>
-              <a:t>IN ARRIVO</a:t>
+              <a:t>PRONTO · DA ATTIVARE</a:t>
             </a:r>
             <a:endParaRPr lang="en-US" sz="950" dirty="0"/>
           </a:p>
@@ -3872,7 +3872,7 @@
                   <a:schemeClr val="tx2"/>
                 </a:solidFill>
               </a:rPr>
-              <a:t>Per i Comuni</a:t>
+              <a:t>Per enti e Amministratori</a:t>
             </a:r>
             <a:endParaRPr lang="en-US" sz="1250" dirty="0"/>
           </a:p>
@@ -3889,7 +3889,7 @@
                   <a:schemeClr val="tx1"/>
                 </a:solidFill>
               </a:rPr>
-              <a:t>come compilare, cosa manca nella pratica, come preparare il tracciato dati</a:t>
+              <a:t>pulsante «✦ Assistente»: come si fa un'operazione, fasi, costi; risponde dai manuali e dalle tariffe</a:t>
             </a:r>
             <a:endParaRPr lang="en-US" sz="1250" dirty="0"/>
           </a:p>
@@ -3906,7 +3906,7 @@
                   <a:schemeClr val="tx2"/>
                 </a:solidFill>
               </a:rPr>
-              <a:t>Per gli Operatori</a:t>
+              <a:t>Garanzie</a:t>
             </a:r>
             <a:endParaRPr lang="en-US" sz="1250" dirty="0"/>
           </a:p>
@@ -3923,7 +3923,7 @@
                   <a:schemeClr val="tx1"/>
                 </a:solidFill>
               </a:rPr>
-              <a:t>controllo dei documenti, bozze di richieste di integrazione e di risposte, spiegazione del calcolo</a:t>
+              <a:t>non vede le pratiche e non decide; nessun testo salvato; limite di domande al giorno</a:t>
             </a:r>
             <a:endParaRPr lang="en-US" sz="1250" dirty="0"/>
           </a:p>
@@ -3940,7 +3940,7 @@
                   <a:schemeClr val="tx2"/>
                 </a:solidFill>
               </a:rPr>
-              <a:t>Garanzie</a:t>
+              <a:t>Come funziona</a:t>
             </a:r>
             <a:endParaRPr lang="en-US" sz="1250" dirty="0"/>
           </a:p>
@@ -3957,7 +3957,7 @@
                   <a:schemeClr val="tx1"/>
                 </a:solidFill>
               </a:rPr>
-              <a:t>supporto, fuori dal flusso decisionale; legge solo i dati permessi; ogni azione nell'audit</a:t>
+              <a:t>Claude Haiku 5.5 tramite una funzione sul server; la chiave resta in Supabase; meno di un centesimo a domanda</a:t>
             </a:r>
             <a:endParaRPr lang="en-US" sz="1250" dirty="0"/>
           </a:p>
@@ -3974,7 +3974,7 @@
                   <a:schemeClr val="tx2"/>
                 </a:solidFill>
               </a:rPr>
-              <a:t>Come funziona</a:t>
+              <a:t>Prossimi passi</a:t>
             </a:r>
             <a:endParaRPr lang="en-US" sz="1250" dirty="0"/>
           </a:p>
@@ -3991,7 +3991,7 @@
                   <a:schemeClr val="tx1"/>
                 </a:solidFill>
               </a:rPr>
-              <a:t>modelli Claude di Anthropic tramite una funzione sul server; la chiave resta in Supabase</a:t>
+              <a:t>chiave della Console (crediti API mensili di un piano Max o Team); poi Operatori e aiuto sulla pratica</a:t>
             </a:r>
             <a:endParaRPr lang="en-US" sz="1250" dirty="0"/>
           </a:p>
@@ -12929,7 +12929,7 @@
                 <a:ea typeface="Cambria" pitchFamily="34" charset="-122"/>
                 <a:cs typeface="Cambria" pitchFamily="34" charset="-120"/>
               </a:rPr>
-              <a:t>30</a:t>
+              <a:t>31</a:t>
             </a:r>
             <a:endParaRPr lang="en-US" sz="3000" dirty="0"/>
           </a:p>
@@ -13031,7 +13031,7 @@
                 <a:ea typeface="Cambria" pitchFamily="34" charset="-122"/>
                 <a:cs typeface="Cambria" pitchFamily="34" charset="-120"/>
               </a:rPr>
-              <a:t>5</a:t>
+              <a:t>6</a:t>
             </a:r>
             <a:endParaRPr lang="en-US" sz="3000" dirty="0"/>
           </a:p>
@@ -13235,7 +13235,7 @@
                 <a:ea typeface="Cambria" pitchFamily="34" charset="-122"/>
                 <a:cs typeface="Cambria" pitchFamily="34" charset="-120"/>
               </a:rPr>
-              <a:t>≈28.600</a:t>
+              <a:t>≈29.200</a:t>
             </a:r>
             <a:endParaRPr lang="en-US" sz="3000" dirty="0"/>
           </a:p>
@@ -14022,7 +14022,7 @@
                 <a:ea typeface="Cambria" pitchFamily="34" charset="-122"/>
                 <a:cs typeface="Cambria" pitchFamily="34" charset="-120"/>
               </a:rPr>
-              <a:t>111</a:t>
+              <a:t>112</a:t>
             </a:r>
             <a:endParaRPr lang="en-US" sz="2400" dirty="0"/>
           </a:p>
@@ -14075,7 +14075,7 @@
                 <a:ea typeface="Cambria" pitchFamily="34" charset="-122"/>
                 <a:cs typeface="Cambria" pitchFamily="34" charset="-120"/>
               </a:rPr>
-              <a:t>30</a:t>
+              <a:t>31</a:t>
             </a:r>
             <a:endParaRPr lang="en-US" sz="2400" dirty="0"/>
           </a:p>
@@ -14128,7 +14128,7 @@
                 <a:ea typeface="Cambria" pitchFamily="34" charset="-122"/>
                 <a:cs typeface="Cambria" pitchFamily="34" charset="-120"/>
               </a:rPr>
-              <a:t>5</a:t>
+              <a:t>6</a:t>
             </a:r>
             <a:endParaRPr lang="en-US" sz="2400" dirty="0"/>
           </a:p>
@@ -14181,7 +14181,7 @@
                 <a:ea typeface="Cambria" pitchFamily="34" charset="-122"/>
                 <a:cs typeface="Cambria" pitchFamily="34" charset="-120"/>
               </a:rPr>
-              <a:t>≈28.600</a:t>
+              <a:t>≈29.200</a:t>
             </a:r>
             <a:endParaRPr lang="en-US" sz="2400" dirty="0"/>
           </a:p>
@@ -17506,7 +17506,7 @@
                   <a:schemeClr val="tx2"/>
                 </a:solidFill>
               </a:rPr>
-              <a:t>Notifiche</a:t>
+              <a:t>Assistente virtuale</a:t>
             </a:r>
             <a:endParaRPr lang="en-US" sz="1350" dirty="0"/>
           </a:p>
@@ -17523,7 +17523,7 @@
                   <a:schemeClr val="tx1"/>
                 </a:solidFill>
               </a:rPr>
-              <a:t>la tendina della campanella resta sempre nello schermo</a:t>
+              <a:t>«✦ Assistente» con Claude per enti e Amministratori, risponde dai manuali e dalle tariffe (da attivare)</a:t>
             </a:r>
             <a:endParaRPr lang="en-US" sz="1350" dirty="0"/>
           </a:p>
@@ -17574,7 +17574,7 @@
                   <a:schemeClr val="tx2"/>
                 </a:solidFill>
               </a:rPr>
-              <a:t>Decisione</a:t>
+              <a:t>Documentazione</a:t>
             </a:r>
             <a:endParaRPr lang="en-US" sz="1350" dirty="0"/>
           </a:p>
@@ -17591,7 +17591,41 @@
                   <a:schemeClr val="tx1"/>
                 </a:solidFill>
               </a:rPr>
-              <a:t>qualificazione ACN non necessaria: il portale qualifica il modello, il Comune non acquista un servizio (parere legale da confermare)</a:t>
+              <a:t>gli 8 documenti ufficiali del Programma v1.2 e questa presentazione, per gli Amministratori</a:t>
+            </a:r>
+            <a:endParaRPr lang="en-US" sz="1350" dirty="0"/>
+          </a:p>
+          <a:p>
+            <a:pPr indent="0" marL="0">
+              <a:spcAft>
+                <a:spcPts val="500"/>
+              </a:spcAft>
+              <a:buNone/>
+            </a:pPr>
+            <a:r>
+              <a:rPr lang="en-US" sz="1350" b="1" dirty="0">
+                <a:solidFill>
+                  <a:schemeClr val="tx2"/>
+                </a:solidFill>
+              </a:rPr>
+              <a:t>Decisione</a:t>
+            </a:r>
+            <a:endParaRPr lang="en-US" sz="1350" dirty="0"/>
+          </a:p>
+          <a:p>
+            <a:pPr indent="0" marL="0">
+              <a:spcAft>
+                <a:spcPts val="500"/>
+              </a:spcAft>
+              <a:buNone/>
+            </a:pPr>
+            <a:r>
+              <a:rPr lang="en-US" sz="1200" dirty="0">
+                <a:solidFill>
+                  <a:schemeClr val="tx1"/>
+                </a:solidFill>
+              </a:rPr>
+              <a:t>qualificazione ACN non necessaria (parere legale da confermare)</a:t>
             </a:r>
             <a:endParaRPr lang="en-US" sz="1350" dirty="0"/>
           </a:p>
@@ -18374,7 +18408,7 @@
                   <a:schemeClr val="tx1"/>
                 </a:solidFill>
               </a:rPr>
-              <a:t>Nuovi moduli: simulatore (online, due metodi di stima), assistente virtuale Claude; utenti online per l'amministratore principale (in sviluppo)</a:t>
+              <a:t>Nuovi moduli: simulatore (online, due metodi), assistente virtuale (pronto, da attivare con la chiave); utenti online per l'amministratore principale (in sviluppo)</a:t>
             </a:r>
             <a:endParaRPr lang="en-US" sz="1350" dirty="0"/>
           </a:p>

</xml_diff>

<commit_message>
Assistente virtuale attivo: corsivo nelle risposte; Registro 4.2, Manuale Amministratore 3.6, Manuale Test 3.2, Ripristino 1.1, Presentazione 2.2
Co-Authored-By: Claude Opus 5.5 <noreply@anthropic.com>
Claude-Session: https://claude.ai/code/session_01E8XCbEeVHWVP3hntUZ6kZ1
</commit_message>
<xml_diff>
--- a/public/documentazione/Presentazione_Portale_CWP.pptx
+++ b/public/documentazione/Presentazione_Portale_CWP.pptx
@@ -120,39 +120,39 @@
   <p:extLst>
     <p:ext uri="{521415D9-36F7-43E2-AB2F-B90AF26B5E84}">
       <p14:sectionLst xmlns:p14="http://schemas.microsoft.com/office/powerpoint/2010/main">
-        <p14:section name="Apertura" id="{c020b8ea-75b7-6335-c8c0-5a126b74730d}">
+        <p14:section name="Apertura" id="{181f59b5-1b41-3cf4-b12f-46ef4763a50c}">
           <p14:sldIdLst>
             <p14:sldId id="256"/>
           </p14:sldIdLst>
         </p14:section>
-        <p14:section name="Metodologia" id="{e9b60671-3a7b-234a-646d-c71b1912a013}">
+        <p14:section name="Metodologia" id="{6d85eec5-92c5-f15d-59c1-e46479db9ab7}">
           <p14:sldIdLst>
             <p14:sldId id="257"/>
           </p14:sldIdLst>
         </p14:section>
-        <p14:section name="Analisi funzionale" id="{8b195e39-8bff-d44d-d9cc-0f703a0085c1}">
+        <p14:section name="Analisi funzionale" id="{52821a7b-8d4c-b913-ed9e-fbefab313b56}">
           <p14:sldIdLst>
             <p14:sldId id="258"/>
             <p14:sldId id="259"/>
           </p14:sldIdLst>
         </p14:section>
-        <p14:section name="Già realtà" id="{9b56cd69-9048-7630-76b0-733bfc305b53}">
+        <p14:section name="Già realtà" id="{6c387520-900e-4abc-a9eb-4b995ad2b702}">
           <p14:sldIdLst>
             <p14:sldId id="260"/>
           </p14:sldIdLst>
         </p14:section>
-        <p14:section name="Architettura e ruoli" id="{06bacbb1-e841-4b26-c19f-af95044424e2}">
+        <p14:section name="Architettura e ruoli" id="{d48ae69c-de18-6727-cb30-bbc23bd27bb9}">
           <p14:sldIdLst>
             <p14:sldId id="261"/>
             <p14:sldId id="262"/>
           </p14:sldIdLst>
         </p14:section>
-        <p14:section name="Novità" id="{2dd705d3-520c-8e0c-575e-dfbede3df265}">
+        <p14:section name="Novità" id="{d8ebbb0e-922c-e772-8742-af1629613ddd}">
           <p14:sldIdLst>
             <p14:sldId id="263"/>
           </p14:sldIdLst>
         </p14:section>
-        <p14:section name="Punti aperti" id="{463577cf-8950-f50b-2f6b-9e8c1290604f}">
+        <p14:section name="Punti aperti" id="{dc7ef810-b2f9-2400-413b-d14bd0df313c}">
           <p14:sldIdLst>
             <p14:sldId id="264"/>
             <p14:sldId id="265"/>
@@ -161,7 +161,7 @@
             <p14:sldId id="268"/>
           </p14:sldIdLst>
         </p14:section>
-        <p14:section name="Scelte da prendere" id="{ac04c7dd-d479-52e7-bdf4-9be2552045b8}">
+        <p14:section name="Scelte da prendere" id="{ba012493-ff0e-5567-6048-5763374e7ee0}">
           <p14:sldIdLst>
             <p14:sldId id="269"/>
           </p14:sldIdLst>
@@ -570,7 +570,7 @@
           <a:p>
             <a:r>
               <a:rPr lang="en-US" dirty="0"/>
-              <a:t>Presentazione di riepilogo del portale, aggiornata al 19 ottobre 2026 (revisione 2.1): metodologia, funzioni realizzate, novità, punti aperti di sviluppo e scelte ancora da prendere. Si rigenera a ogni rilascio insieme agli altri documenti ed è disponibile agli Amministratori nella pagina Documentazione del portale.</a:t>
+              <a:t>Presentazione di riepilogo del portale, aggiornata al 19 ottobre 2026 (revisione 2.2): metodologia, funzioni realizzate, novità, punti aperti di sviluppo e scelte ancora da prendere. Si rigenera a ogni rilascio insieme agli altri documenti ed è disponibile agli Amministratori nella pagina Documentazione del portale.</a:t>
             </a:r>
             <a:endParaRPr lang="en-US" dirty="0"/>
           </a:p>
@@ -658,7 +658,7 @@
           <a:p>
             <a:r>
               <a:rPr lang="en-US" dirty="0"/>
-              <a:t>Due nuovi moduli entrano nel progetto e in tutti i documenti (Registro, backlog punti 37 e 21). Simulatore di scenari, richiesto da Luca il 19/10: per ogni Comune si creano più scenari; la durata si sceglie da un menu a tendina tra 7, 10 e 21 anni (Standard 4.3.8: periodo di 10 anni oppure 7 rinnovabili fino a 21); si acquisiscono i dati dell'anno base (popolazione, produzione totale e pro capite, raccolta differenziata, ripartizione per frazione, parametri del calcolo); per ogni anno si inseriscono gli obiettivi di produzione totale e pro capite e di secco residuo pro capite; il simulatore ricalcola la percentuale di differenziata e stima anno per anno i crediti che il Comune potrebbe generare, con due metodi: il bilancio del Comune (tutte le utenze insieme, il più prudente) e il metodo per utenza con le sole utenze virtuose e il buffer del Capitolo 7, lo stesso delle stime dell'Allegato A dei contratti EsaCom. È una stima ex ante utile a presentare il Programma ai Comuni: il modello semplificato va confermato dalla Fondazione. Assistente virtuale (prima versione del 19/10, da attivare): pulsante «✦ Assistente» per Amministratori e utenti degli enti; risponde in italiano solo dalla base di conoscenza (Manuale Utente e tariffe per gli enti, in più Manuale Amministratore e note sul calcolo per gli Amministratori), non vede le pratiche, non salva i testi, limite di 40 domande al giorno per utente. Funziona con Claude Haiku 5.5 tramite la funzione del server «assistente»; la base di conoscenza resta nella cache dei prompt, quindi una domanda costa di solito meno di un centesimo di dollaro. Per attivarlo serve una chiave della Claude Console inserita da Luca nei segreti di Supabase: l'uso API è fatturato a parte rispetto ai piani claude.ai, ma con un piano Max o Team si possono collegare i crediti API mensili del piano all'organizzazione della Console. Passi successivi: Operatori e aiuto sulla singola pratica.</a:t>
+              <a:t>Due nuovi moduli entrano nel progetto e in tutti i documenti (Registro, backlog punti 37 e 21). Simulatore di scenari, richiesto da Luca il 19/10: per ogni Comune si creano più scenari; la durata si sceglie da un menu a tendina tra 7, 10 e 21 anni (Standard 4.3.8: periodo di 10 anni oppure 7 rinnovabili fino a 21); si acquisiscono i dati dell'anno base (popolazione, produzione totale e pro capite, raccolta differenziata, ripartizione per frazione, parametri del calcolo); per ogni anno si inseriscono gli obiettivi di produzione totale e pro capite e di secco residuo pro capite; il simulatore ricalcola la percentuale di differenziata e stima anno per anno i crediti che il Comune potrebbe generare, con due metodi: il bilancio del Comune (tutte le utenze insieme, il più prudente) e il metodo per utenza con le sole utenze virtuose e il buffer del Capitolo 7, lo stesso delle stime dell'Allegato A dei contratti EsaCom. È una stima ex ante utile a presentare il Programma ai Comuni: il modello semplificato va confermato dalla Fondazione. Assistente virtuale (prima versione del 19/10, attiva dallo stesso giorno): pulsante «✦ Assistente» per Amministratori e utenti degli enti; risponde in italiano solo dalla base di conoscenza (Manuale Utente e tariffe per gli enti, in più Manuale Amministratore e note sul calcolo per gli Amministratori), non vede le pratiche, non salva i testi, limite di 40 domande al giorno per utente. Funziona con Claude Haiku 5.5 tramite la funzione del server «assistente»; la base di conoscenza resta nella cache dei prompt, quindi una domanda costa di solito meno di un centesimo di dollaro. Funziona con una chiave della Claude Console, legata a un solo spazio di lavoro, inserita da Luca nei segreti di Supabase: l'uso API è fatturato a parte rispetto ai piani claude.ai; Luca ha collegato i crediti API mensili del piano Max e acquistato 100 dollari di crediti. Prova dal vivo del 19/10: risposte corrette su creazione utenti e costi del Caso 1. Passi successivi: Operatori e aiuto sulla singola pratica.</a:t>
             </a:r>
             <a:endParaRPr lang="en-US" dirty="0"/>
           </a:p>
@@ -1362,7 +1362,7 @@
           <a:p>
             <a:r>
               <a:rPr lang="en-US" dirty="0"/>
-              <a:t>Pagina «effetto sorpresa»: nessuno si aspetta che il portale sia già online. Il sistema è stato realizzato da Luca Moretti con l'ausilio di Claude Code ed è quasi terminato; i servizi sono già in produzione: GitHub (codice), Vercel (pubblicazione del portale), Supabase (database, utenti, documenti, funzioni) e Resend (email). Il portale è pubblicato su portale-cwp.vercel.app e funziona con dati di prova: si può aprire durante la presentazione (collegamento cliccabile) o inquadrare il codice QR con il telefono. La pagina pubblica /programma mostra già gli 8 documenti ufficiali del Programma, la Metodologia approvata, la PEC e il soggetto promotore. Lo sviluppo del portale vero è partito il 17 ottobre 2026: da allora sono state pubblicate 112 versioni, 31 script del database e 6 funzioni sul server. Restano i punti aperti delle prossime slide (servizi a pagamento, sicurezza, dati da inserire, collaudo con un Comune). Suggerimento: aprire il portale dal vivo con un utente di prova e mostrare la pagina pubblica.</a:t>
+              <a:t>Pagina «effetto sorpresa»: nessuno si aspetta che il portale sia già online. Il sistema è stato realizzato da Luca Moretti con l'ausilio di Claude Code ed è quasi terminato; i servizi sono già in produzione: GitHub (codice), Vercel (pubblicazione del portale), Supabase (database, utenti, documenti, funzioni) e Resend (email). Il portale è pubblicato su portale-cwp.vercel.app e funziona con dati di prova: si può aprire durante la presentazione (collegamento cliccabile) o inquadrare il codice QR con il telefono. La pagina pubblica /programma mostra già gli 8 documenti ufficiali del Programma, la Metodologia approvata, la PEC e il soggetto promotore. Lo sviluppo del portale vero è partito il 17 ottobre 2026: da allora sono state pubblicate 114 versioni, 31 script del database e 6 funzioni sul server. Restano i punti aperti delle prossime slide (servizi a pagamento, sicurezza, dati da inserire, collaudo con un Comune). Suggerimento: aprire il portale dal vivo con un utente di prova e mostrare la pagina pubblica.</a:t>
             </a:r>
             <a:endParaRPr lang="en-US" dirty="0"/>
           </a:p>
@@ -2073,7 +2073,7 @@
                   <a:schemeClr val="accent6"/>
                 </a:solidFill>
               </a:rPr>
-              <a:t>Portale Carbon WastePrint · Stato dei lavori e recap · 19 ottobre 2026 · rev. 2.1</a:t>
+              <a:t>Portale Carbon WastePrint · Stato dei lavori e recap · 19 ottobre 2026 · rev. 2.2</a:t>
             </a:r>
             <a:endParaRPr lang="en-US" sz="1000" dirty="0"/>
           </a:p>
@@ -2571,7 +2571,7 @@
                   <a:schemeClr val="accent3"/>
                 </a:solidFill>
               </a:rPr>
-              <a:t>Stato dei lavori e recap: metodologia, funzioni, novità, punti aperti e scelte da prendere · aggiornata al 19 ottobre 2026 · rev. 2.1</a:t>
+              <a:t>Stato dei lavori e recap: metodologia, funzioni, novità, punti aperti e scelte da prendere · aggiornata al 19 ottobre 2026 · rev. 2.2</a:t>
             </a:r>
             <a:endParaRPr lang="en-US" sz="1800" dirty="0"/>
           </a:p>
@@ -3778,7 +3778,7 @@
       </p:sp>
       <p:sp>
         <p:nvSpPr>
-          <p:cNvPr id="34" name="Badge pronto"/>
+          <p:cNvPr id="34" name="Badge attivo"/>
           <p:cNvSpPr/>
           <p:nvPr/>
         </p:nvSpPr>
@@ -3833,7 +3833,7 @@
                   <a:schemeClr val="tx2"/>
                 </a:solidFill>
               </a:rPr>
-              <a:t>PRONTO · DA ATTIVARE</a:t>
+              <a:t>ATTIVO DAL 19/10</a:t>
             </a:r>
             <a:endParaRPr lang="en-US" sz="950" dirty="0"/>
           </a:p>
@@ -3991,7 +3991,7 @@
                   <a:schemeClr val="tx1"/>
                 </a:solidFill>
               </a:rPr>
-              <a:t>chiave della Console (crediti API mensili di un piano Max o Team); poi Operatori e aiuto sulla pratica</a:t>
+              <a:t>estensione agli Operatori e aiuto sulla singola pratica, con regole sulla privacy</a:t>
             </a:r>
             <a:endParaRPr lang="en-US" sz="1250" dirty="0"/>
           </a:p>
@@ -13235,7 +13235,7 @@
                 <a:ea typeface="Cambria" pitchFamily="34" charset="-122"/>
                 <a:cs typeface="Cambria" pitchFamily="34" charset="-120"/>
               </a:rPr>
-              <a:t>≈29.200</a:t>
+              <a:t>≈29.900</a:t>
             </a:r>
             <a:endParaRPr lang="en-US" sz="3000" dirty="0"/>
           </a:p>
@@ -14022,7 +14022,7 @@
                 <a:ea typeface="Cambria" pitchFamily="34" charset="-122"/>
                 <a:cs typeface="Cambria" pitchFamily="34" charset="-120"/>
               </a:rPr>
-              <a:t>112</a:t>
+              <a:t>114</a:t>
             </a:r>
             <a:endParaRPr lang="en-US" sz="2400" dirty="0"/>
           </a:p>
@@ -14181,7 +14181,7 @@
                 <a:ea typeface="Cambria" pitchFamily="34" charset="-122"/>
                 <a:cs typeface="Cambria" pitchFamily="34" charset="-120"/>
               </a:rPr>
-              <a:t>≈29.200</a:t>
+              <a:t>≈29.900</a:t>
             </a:r>
             <a:endParaRPr lang="en-US" sz="2400" dirty="0"/>
           </a:p>
@@ -17523,7 +17523,7 @@
                   <a:schemeClr val="tx1"/>
                 </a:solidFill>
               </a:rPr>
-              <a:t>«✦ Assistente» con Claude per enti e Amministratori, risponde dai manuali e dalle tariffe (da attivare)</a:t>
+              <a:t>«✦ Assistente» con Claude per enti e Amministratori, risponde dai manuali e dalle tariffe (attivo dal 19/10)</a:t>
             </a:r>
             <a:endParaRPr lang="en-US" sz="1350" dirty="0"/>
           </a:p>
@@ -18408,7 +18408,7 @@
                   <a:schemeClr val="tx1"/>
                 </a:solidFill>
               </a:rPr>
-              <a:t>Nuovi moduli: simulatore (online, due metodi), assistente virtuale (pronto, da attivare con la chiave); utenti online per l'amministratore principale (in sviluppo)</a:t>
+              <a:t>Nuovi moduli: simulatore (online, due metodi), assistente virtuale (attivo dal 19/10, poi Operatori e aiuto sulla pratica); utenti online per l'amministratore principale (in sviluppo)</a:t>
             </a:r>
             <a:endParaRPr lang="en-US" sz="1350" dirty="0"/>
           </a:p>

</xml_diff>

<commit_message>
Assistente: messaggio d'attesa «Un attimo…»; backlog con riepilogo «Da fare subito» e punti 38-39; Manuale Utente 2.7, Amministratore 3.7, Test 3.3, Registro 4.3, Presentazione 2.3
Co-Authored-By: Claude Opus 5.5 <noreply@anthropic.com>
Claude-Session: https://claude.ai/code/session_01E8XCbEeVHWVP3hntUZ6kZ1
</commit_message>
<xml_diff>
--- a/public/documentazione/Presentazione_Portale_CWP.pptx
+++ b/public/documentazione/Presentazione_Portale_CWP.pptx
@@ -120,39 +120,39 @@
   <p:extLst>
     <p:ext uri="{521415D9-36F7-43E2-AB2F-B90AF26B5E84}">
       <p14:sectionLst xmlns:p14="http://schemas.microsoft.com/office/powerpoint/2010/main">
-        <p14:section name="Apertura" id="{181f59b5-1b41-3cf4-b12f-46ef4763a50c}">
+        <p14:section name="Apertura" id="{8a570d48-dd66-debe-3a99-4b5460175aee}">
           <p14:sldIdLst>
             <p14:sldId id="256"/>
           </p14:sldIdLst>
         </p14:section>
-        <p14:section name="Metodologia" id="{6d85eec5-92c5-f15d-59c1-e46479db9ab7}">
+        <p14:section name="Metodologia" id="{b6edd4c9-3ec2-d8b9-3107-43776607cae8}">
           <p14:sldIdLst>
             <p14:sldId id="257"/>
           </p14:sldIdLst>
         </p14:section>
-        <p14:section name="Analisi funzionale" id="{52821a7b-8d4c-b913-ed9e-fbefab313b56}">
+        <p14:section name="Analisi funzionale" id="{6e52da88-0a01-2687-a589-a1ef96b02993}">
           <p14:sldIdLst>
             <p14:sldId id="258"/>
             <p14:sldId id="259"/>
           </p14:sldIdLst>
         </p14:section>
-        <p14:section name="Già realtà" id="{6c387520-900e-4abc-a9eb-4b995ad2b702}">
+        <p14:section name="Già realtà" id="{cbb81de3-b1f4-d2ae-2e1e-671212067a3a}">
           <p14:sldIdLst>
             <p14:sldId id="260"/>
           </p14:sldIdLst>
         </p14:section>
-        <p14:section name="Architettura e ruoli" id="{d48ae69c-de18-6727-cb30-bbc23bd27bb9}">
+        <p14:section name="Architettura e ruoli" id="{883b6f21-bda6-3bb8-fe0f-d6ad51280ed9}">
           <p14:sldIdLst>
             <p14:sldId id="261"/>
             <p14:sldId id="262"/>
           </p14:sldIdLst>
         </p14:section>
-        <p14:section name="Novità" id="{d8ebbb0e-922c-e772-8742-af1629613ddd}">
+        <p14:section name="Novità" id="{f5127522-d178-ffaf-84f3-6163f8e220f2}">
           <p14:sldIdLst>
             <p14:sldId id="263"/>
           </p14:sldIdLst>
         </p14:section>
-        <p14:section name="Punti aperti" id="{dc7ef810-b2f9-2400-413b-d14bd0df313c}">
+        <p14:section name="Punti aperti" id="{2f7c5d5e-2df6-6df4-e27e-307c5435a3ab}">
           <p14:sldIdLst>
             <p14:sldId id="264"/>
             <p14:sldId id="265"/>
@@ -161,7 +161,7 @@
             <p14:sldId id="268"/>
           </p14:sldIdLst>
         </p14:section>
-        <p14:section name="Scelte da prendere" id="{ba012493-ff0e-5567-6048-5763374e7ee0}">
+        <p14:section name="Scelte da prendere" id="{ea175a21-2a88-6b78-f7ef-5356118c6534}">
           <p14:sldIdLst>
             <p14:sldId id="269"/>
           </p14:sldIdLst>
@@ -570,7 +570,7 @@
           <a:p>
             <a:r>
               <a:rPr lang="en-US" dirty="0"/>
-              <a:t>Presentazione di riepilogo del portale, aggiornata al 19 ottobre 2026 (revisione 2.2): metodologia, funzioni realizzate, novità, punti aperti di sviluppo e scelte ancora da prendere. Si rigenera a ogni rilascio insieme agli altri documenti ed è disponibile agli Amministratori nella pagina Documentazione del portale.</a:t>
+              <a:t>Presentazione di riepilogo del portale, aggiornata al 19 ottobre 2026 (revisione 2.3): metodologia, funzioni realizzate, novità, punti aperti di sviluppo e scelte ancora da prendere. Si rigenera a ogni rilascio insieme agli altri documenti ed è disponibile agli Amministratori nella pagina Documentazione del portale.</a:t>
             </a:r>
             <a:endParaRPr lang="en-US" dirty="0"/>
           </a:p>
@@ -1362,7 +1362,7 @@
           <a:p>
             <a:r>
               <a:rPr lang="en-US" dirty="0"/>
-              <a:t>Pagina «effetto sorpresa»: nessuno si aspetta che il portale sia già online. Il sistema è stato realizzato da Luca Moretti con l'ausilio di Claude Code ed è quasi terminato; i servizi sono già in produzione: GitHub (codice), Vercel (pubblicazione del portale), Supabase (database, utenti, documenti, funzioni) e Resend (email). Il portale è pubblicato su portale-cwp.vercel.app e funziona con dati di prova: si può aprire durante la presentazione (collegamento cliccabile) o inquadrare il codice QR con il telefono. La pagina pubblica /programma mostra già gli 8 documenti ufficiali del Programma, la Metodologia approvata, la PEC e il soggetto promotore. Lo sviluppo del portale vero è partito il 17 ottobre 2026: da allora sono state pubblicate 114 versioni, 31 script del database e 6 funzioni sul server. Restano i punti aperti delle prossime slide (servizi a pagamento, sicurezza, dati da inserire, collaudo con un Comune). Suggerimento: aprire il portale dal vivo con un utente di prova e mostrare la pagina pubblica.</a:t>
+              <a:t>Pagina «effetto sorpresa»: nessuno si aspetta che il portale sia già online. Il sistema è stato realizzato da Luca Moretti con l'ausilio di Claude Code ed è quasi terminato; i servizi sono già in produzione: GitHub (codice), Vercel (pubblicazione del portale), Supabase (database, utenti, documenti, funzioni) e Resend (email). Il portale è pubblicato su portale-cwp.vercel.app e funziona con dati di prova: si può aprire durante la presentazione (collegamento cliccabile) o inquadrare il codice QR con il telefono. La pagina pubblica /programma mostra già gli 8 documenti ufficiali del Programma, la Metodologia approvata, la PEC e il soggetto promotore. Lo sviluppo del portale vero è partito il 17 ottobre 2026: da allora sono state pubblicate 115 versioni, 31 script del database e 6 funzioni sul server. Restano i punti aperti delle prossime slide (servizi a pagamento, sicurezza, dati da inserire, collaudo con un Comune). Suggerimento: aprire il portale dal vivo con un utente di prova e mostrare la pagina pubblica.</a:t>
             </a:r>
             <a:endParaRPr lang="en-US" dirty="0"/>
           </a:p>
@@ -1714,7 +1714,7 @@
           <a:p>
             <a:r>
               <a:rPr lang="en-US" dirty="0"/>
-              <a:t>La parte funzionale dei requisiti del 15/09 è chiusa e dal 18/10 sera il portale segue anche i documenti ufficiali del Programma. Restano tre gruppi. 1) Requisiti tecnici e di sicurezza (sezioni 13-15 dei requisiti); il 19/10 sono stati fatti l'archivio di backup completo e le Istruzioni di ripristino, mancano le copie automatiche di database e file. 2) Avvio della piattaforma pubblica (Guida 3.7): la pagina /programma è attiva e pubblica già gli otto documenti ufficiali v1.2 (Guida, Definizioni, Normativa, Standard, Metodologia, Politica di reclamo, Schema tariffario, Gestione qualità dei dati) e la Metodologia approvata; la PEC del Programma per i reclami è operate@pec.it; vanno aggiunti gli enti di validazione e verifica e i registri riconosciuti e la modulistica quando disponibile. L'accesso con SPID, CIE o CNS (Guida 3.9) richiede l'adesione della Fondazione come fornitore di servizi (AgID o aggregatore accreditato): fino ad allora resta l'email confermata. 3) Qualità dei dati e completamenti: i controlli del documento Gestione della qualità dei dati sono nel calcolo (Tabella 3 dello Standard ±30% con motivazione obbligatoria, completezza, unicità, letture a buon fine, tempestività) e servono popolazione e cluster SOSE ufficiali di ogni Comune; poi privacy, accessibilità, collaudo con dati reali. L'assistente AI resta un supporto al back-office, come previsto dai requisiti (sezione 17).</a:t>
+              <a:t>La parte funzionale dei requisiti del 15/09 è chiusa e dal 18/10 sera il portale segue anche i documenti ufficiali del Programma. Restano tre gruppi. 1) Requisiti tecnici e di sicurezza (sezioni 13-15 dei requisiti); il 19/10 sono stati fatti l'archivio di backup completo e le Istruzioni di ripristino, mancano le copie automatiche di database e file. 2) Avvio della piattaforma pubblica (Guida 3.7): la pagina /programma è attiva e pubblica già gli otto documenti ufficiali v1.2 (Guida, Definizioni, Normativa, Standard, Metodologia, Politica di reclamo, Schema tariffario, Gestione qualità dei dati) e la Metodologia approvata; la PEC del Programma per i reclami è operate@pec.it; vanno aggiunti gli enti di validazione e verifica e i registri riconosciuti e la modulistica quando disponibile. L'accesso con SPID, CIE o CNS (Guida 3.9) richiede l'adesione della Fondazione come fornitore di servizi (AgID o aggregatore accreditato): fino ad allora resta l'email confermata. 3) Qualità dei dati e completamenti: i controlli del documento Gestione della qualità dei dati sono nel calcolo (Tabella 3 dello Standard ±30% con motivazione obbligatoria, completezza, unicità, letture a buon fine, tempestività) e servono popolazione e cluster SOSE ufficiali di ogni Comune; poi privacy, accessibilità, collaudo con dati reali. L'assistente AI resta un supporto al back-office, come previsto dai requisiti (sezione 17). Da fare subito (19/10 sera). Azioni di Luca: ripubblicare le funzioni crea-utente e reimposta-password (email delle credenziali), rieseguire la funzione utente_mai_attivo dello script 30, verificare il dominio email su Resend, decidere se intestare alla Fondazione la fatturazione dell'assistente. Sviluppo: utenti online per l'amministratore principale, messaggi d'errore dell'assistente in italiano (proposta), stampa PDF del simulatore, sicurezza e piani a pagamento, collaudo con dati reali.</a:t>
             </a:r>
             <a:endParaRPr lang="en-US" dirty="0"/>
           </a:p>
@@ -2073,7 +2073,7 @@
                   <a:schemeClr val="accent6"/>
                 </a:solidFill>
               </a:rPr>
-              <a:t>Portale Carbon WastePrint · Stato dei lavori e recap · 19 ottobre 2026 · rev. 2.2</a:t>
+              <a:t>Portale Carbon WastePrint · Stato dei lavori e recap · 19 ottobre 2026 · rev. 2.3</a:t>
             </a:r>
             <a:endParaRPr lang="en-US" sz="1000" dirty="0"/>
           </a:p>
@@ -2571,7 +2571,7 @@
                   <a:schemeClr val="accent3"/>
                 </a:solidFill>
               </a:rPr>
-              <a:t>Stato dei lavori e recap: metodologia, funzioni, novità, punti aperti e scelte da prendere · aggiornata al 19 ottobre 2026 · rev. 2.2</a:t>
+              <a:t>Stato dei lavori e recap: metodologia, funzioni, novità, punti aperti e scelte da prendere · aggiornata al 19 ottobre 2026 · rev. 2.3</a:t>
             </a:r>
             <a:endParaRPr lang="en-US" sz="1800" dirty="0"/>
           </a:p>
@@ -14022,7 +14022,7 @@
                 <a:ea typeface="Cambria" pitchFamily="34" charset="-122"/>
                 <a:cs typeface="Cambria" pitchFamily="34" charset="-120"/>
               </a:rPr>
-              <a:t>114</a:t>
+              <a:t>115</a:t>
             </a:r>
             <a:endParaRPr lang="en-US" sz="2400" dirty="0"/>
           </a:p>
@@ -18408,7 +18408,7 @@
                   <a:schemeClr val="tx1"/>
                 </a:solidFill>
               </a:rPr>
-              <a:t>Nuovi moduli: simulatore (online, due metodi), assistente virtuale (attivo dal 19/10, poi Operatori e aiuto sulla pratica); utenti online per l'amministratore principale (in sviluppo)</a:t>
+              <a:t>Nuovi moduli: simulatore (online, due metodi), assistente virtuale (attivo dal 19/10; poi messaggi d'errore in italiano, Operatori e aiuto sulla pratica); utenti online per l'amministratore principale (in sviluppo)</a:t>
             </a:r>
             <a:endParaRPr lang="en-US" sz="1350" dirty="0"/>
           </a:p>

</xml_diff>

<commit_message>
Utenti online (script 32, pannello per l'Amministratore principale); errori dell'assistente in italiano; simulatore con PDF impaginato ed export Excel, pagina senza scorrimento laterale sul telefono; Manuale Utente 2.8, Amministratore 3.8, Test 3.4, Registro 4.4, Ripristino 1.2, Presentazione 2.4
Co-Authored-By: Claude Opus 5.5 <noreply@anthropic.com>
Claude-Session: https://claude.ai/code/session_01E8XCbEeVHWVP3hntUZ6kZ1
</commit_message>
<xml_diff>
--- a/public/documentazione/Presentazione_Portale_CWP.pptx
+++ b/public/documentazione/Presentazione_Portale_CWP.pptx
@@ -120,39 +120,39 @@
   <p:extLst>
     <p:ext uri="{521415D9-36F7-43E2-AB2F-B90AF26B5E84}">
       <p14:sectionLst xmlns:p14="http://schemas.microsoft.com/office/powerpoint/2010/main">
-        <p14:section name="Apertura" id="{8a570d48-dd66-debe-3a99-4b5460175aee}">
+        <p14:section name="Apertura" id="{586038c2-e6bc-34c1-1572-aecc7d68e041}">
           <p14:sldIdLst>
             <p14:sldId id="256"/>
           </p14:sldIdLst>
         </p14:section>
-        <p14:section name="Metodologia" id="{b6edd4c9-3ec2-d8b9-3107-43776607cae8}">
+        <p14:section name="Metodologia" id="{8339a078-da6a-7b9b-7c10-52885fbc96ca}">
           <p14:sldIdLst>
             <p14:sldId id="257"/>
           </p14:sldIdLst>
         </p14:section>
-        <p14:section name="Analisi funzionale" id="{6e52da88-0a01-2687-a589-a1ef96b02993}">
+        <p14:section name="Analisi funzionale" id="{7e151900-7bc4-5dd0-54e7-9b5af9a7cdee}">
           <p14:sldIdLst>
             <p14:sldId id="258"/>
             <p14:sldId id="259"/>
           </p14:sldIdLst>
         </p14:section>
-        <p14:section name="Già realtà" id="{cbb81de3-b1f4-d2ae-2e1e-671212067a3a}">
+        <p14:section name="Già realtà" id="{020f0b95-6fea-3afc-8ac0-1208eb709dea}">
           <p14:sldIdLst>
             <p14:sldId id="260"/>
           </p14:sldIdLst>
         </p14:section>
-        <p14:section name="Architettura e ruoli" id="{883b6f21-bda6-3bb8-fe0f-d6ad51280ed9}">
+        <p14:section name="Architettura e ruoli" id="{75c8600f-d362-adac-6fd3-336154ea39ab}">
           <p14:sldIdLst>
             <p14:sldId id="261"/>
             <p14:sldId id="262"/>
           </p14:sldIdLst>
         </p14:section>
-        <p14:section name="Novità" id="{f5127522-d178-ffaf-84f3-6163f8e220f2}">
+        <p14:section name="Novità" id="{d5073bfe-1d4e-6caa-4263-0fa0591b3026}">
           <p14:sldIdLst>
             <p14:sldId id="263"/>
           </p14:sldIdLst>
         </p14:section>
-        <p14:section name="Punti aperti" id="{2f7c5d5e-2df6-6df4-e27e-307c5435a3ab}">
+        <p14:section name="Punti aperti" id="{99a768f6-4d6d-1680-7195-4431f2d79c25}">
           <p14:sldIdLst>
             <p14:sldId id="264"/>
             <p14:sldId id="265"/>
@@ -161,7 +161,7 @@
             <p14:sldId id="268"/>
           </p14:sldIdLst>
         </p14:section>
-        <p14:section name="Scelte da prendere" id="{ea175a21-2a88-6b78-f7ef-5356118c6534}">
+        <p14:section name="Scelte da prendere" id="{7723507d-81b1-9ee5-cff8-ed1c8a3a6b68}">
           <p14:sldIdLst>
             <p14:sldId id="269"/>
           </p14:sldIdLst>
@@ -570,7 +570,7 @@
           <a:p>
             <a:r>
               <a:rPr lang="en-US" dirty="0"/>
-              <a:t>Presentazione di riepilogo del portale, aggiornata al 19 ottobre 2026 (revisione 2.3): metodologia, funzioni realizzate, novità, punti aperti di sviluppo e scelte ancora da prendere. Si rigenera a ogni rilascio insieme agli altri documenti ed è disponibile agli Amministratori nella pagina Documentazione del portale.</a:t>
+              <a:t>Presentazione di riepilogo del portale, aggiornata al 20 ottobre 2026 (revisione 2.4): metodologia, funzioni realizzate, novità, punti aperti di sviluppo e scelte ancora da prendere. Si rigenera a ogni rilascio insieme agli altri documenti ed è disponibile agli Amministratori nella pagina Documentazione del portale.</a:t>
             </a:r>
             <a:endParaRPr lang="en-US" dirty="0"/>
           </a:p>
@@ -1362,7 +1362,7 @@
           <a:p>
             <a:r>
               <a:rPr lang="en-US" dirty="0"/>
-              <a:t>Pagina «effetto sorpresa»: nessuno si aspetta che il portale sia già online. Il sistema è stato realizzato da Luca Moretti con l'ausilio di Claude Code ed è quasi terminato; i servizi sono già in produzione: GitHub (codice), Vercel (pubblicazione del portale), Supabase (database, utenti, documenti, funzioni) e Resend (email). Il portale è pubblicato su portale-cwp.vercel.app e funziona con dati di prova: si può aprire durante la presentazione (collegamento cliccabile) o inquadrare il codice QR con il telefono. La pagina pubblica /programma mostra già gli 8 documenti ufficiali del Programma, la Metodologia approvata, la PEC e il soggetto promotore. Lo sviluppo del portale vero è partito il 17 ottobre 2026: da allora sono state pubblicate 115 versioni, 31 script del database e 6 funzioni sul server. Restano i punti aperti delle prossime slide (servizi a pagamento, sicurezza, dati da inserire, collaudo con un Comune). Suggerimento: aprire il portale dal vivo con un utente di prova e mostrare la pagina pubblica.</a:t>
+              <a:t>Pagina «effetto sorpresa»: nessuno si aspetta che il portale sia già online. Il sistema è stato realizzato da Luca Moretti con l'ausilio di Claude Code ed è quasi terminato; i servizi sono già in produzione: GitHub (codice), Vercel (pubblicazione del portale), Supabase (database, utenti, documenti, funzioni) e Resend (email). Il portale è pubblicato su portale-cwp.vercel.app e funziona con dati di prova: si può aprire durante la presentazione (collegamento cliccabile) o inquadrare il codice QR con il telefono. La pagina pubblica /programma mostra già gli 8 documenti ufficiali del Programma, la Metodologia approvata, la PEC e il soggetto promotore. Lo sviluppo del portale vero è partito il 17 ottobre 2026: da allora sono state pubblicate 116 versioni, 32 script del database e 6 funzioni sul server. Restano i punti aperti delle prossime slide (servizi a pagamento, sicurezza, dati da inserire, collaudo con un Comune). Suggerimento: aprire il portale dal vivo con un utente di prova e mostrare la pagina pubblica.</a:t>
             </a:r>
             <a:endParaRPr lang="en-US" dirty="0"/>
           </a:p>
@@ -1626,7 +1626,7 @@
           <a:p>
             <a:r>
               <a:rPr lang="en-US" dirty="0"/>
-              <a:t>Novità pubblicate il 19 ottobre pomeriggio, su richiesta di Luca. Dashboard (prima «Cruscotto»): per ogni pratica una barra di 7 luci, una per fase, accese le fasi completate e spente quelle da fare, la settima verde; la fase in corso ha il contorno. Ordinamento: ogni tabella del portale si ordina per qualsiasi colonna e gli elenchi a schede hanno il menu «Ordina per». Utenti: un Amministratore può nominare altri Amministratori, tutti con accesso completo; l'Amministratore principale luca.moretti@operate.it è protetto dal database (non si declassa, non si disattiva, non si cancella, nemmeno dal pannello di Supabase); si possono eliminare solo gli utenti che non hanno mai operato (nessuna voce nell'audit e nessun dato a loro nome). Email: il nuovo utente riceve indirizzo del portale, email e password temporanea, con l'obbligo di sceglierne una personale al primo accesso; finché il dominio operate.it non è verificato su Resend le email arrivano solo al titolare dell'account. Simulatore: oltre al bilancio del Comune c'è il metodo per utenza con le sole utenze virtuose (formula 32 con buffer), lo stesso delle stime dell'Allegato A dei contratti EsaCom; il buffer si calcola dalle Tabelle 15-16. Decisione: il portale non va qualificato ACN come servizio cloud per la PA, perché serve a qualificare il modello e il Comune vi riversa dati senza acquistare un servizio; restano GDPR, dati in UE e sicurezza; da confermare con un parere legale.</a:t>
+              <a:t>Novità pubblicate il 19 ottobre pomeriggio, su richiesta di Luca. Dashboard (prima «Cruscotto»): per ogni pratica una barra di 7 luci, una per fase, accese le fasi completate e spente quelle da fare, la settima verde; la fase in corso ha il contorno. Ordinamento: ogni tabella del portale si ordina per qualsiasi colonna e gli elenchi a schede hanno il menu «Ordina per». Utenti: un Amministratore può nominare altri Amministratori, tutti con accesso completo; l'Amministratore principale luca.moretti@operate.it è protetto dal database (non si declassa, non si disattiva, non si cancella, nemmeno dal pannello di Supabase); si possono eliminare solo gli utenti che non hanno mai operato (nessuna voce nell'audit e nessun dato a loro nome). Email: il nuovo utente riceve indirizzo del portale, email e password temporanea, con l'obbligo di sceglierne una personale al primo accesso; finché il dominio operate.it non è verificato su Resend le email arrivano solo al titolare dell'account. Simulatore: oltre al bilancio del Comune c'è il metodo per utenza con le sole utenze virtuose (formula 32 con buffer), lo stesso delle stime dell'Allegato A dei contratti EsaCom; il buffer si calcola dalle Tabelle 15-16. Decisione: il portale non va qualificato ACN come servizio cloud per la PA, perché serve a qualificare il modello e il Comune vi riversa dati senza acquistare un servizio; restano GDPR, dati in UE e sicurezza; da confermare con un parere legale. Il 20 ottobre: utenti online per l'Amministratore principale (chi è collegato adesso, pagina aperta, da quanto, e chi è stato visto nelle ultime 24 ore; si conserva solo l'ultimo collegamento, gli utenti ne sono informati nel Manuale Utente); messaggi d'errore dell'assistente in italiano semplice, con la causa per gli Amministratori; simulatore con PDF impaginato in A4 orizzontale ed export Excel con i fogli Sintesi, Anni, Economia e Costi.</a:t>
             </a:r>
             <a:endParaRPr lang="en-US" dirty="0"/>
           </a:p>
@@ -2073,7 +2073,7 @@
                   <a:schemeClr val="accent6"/>
                 </a:solidFill>
               </a:rPr>
-              <a:t>Portale Carbon WastePrint · Stato dei lavori e recap · 19 ottobre 2026 · rev. 2.3</a:t>
+              <a:t>Portale Carbon WastePrint · Stato dei lavori e recap · 20 ottobre 2026 · rev. 2.4</a:t>
             </a:r>
             <a:endParaRPr lang="en-US" sz="1000" dirty="0"/>
           </a:p>
@@ -2571,7 +2571,7 @@
                   <a:schemeClr val="accent3"/>
                 </a:solidFill>
               </a:rPr>
-              <a:t>Stato dei lavori e recap: metodologia, funzioni, novità, punti aperti e scelte da prendere · aggiornata al 19 ottobre 2026 · rev. 2.3</a:t>
+              <a:t>Stato dei lavori e recap: metodologia, funzioni, novità, punti aperti e scelte da prendere · aggiornata al 20 ottobre 2026 · rev. 2.4</a:t>
             </a:r>
             <a:endParaRPr lang="en-US" sz="1800" dirty="0"/>
           </a:p>
@@ -12929,7 +12929,7 @@
                 <a:ea typeface="Cambria" pitchFamily="34" charset="-122"/>
                 <a:cs typeface="Cambria" pitchFamily="34" charset="-120"/>
               </a:rPr>
-              <a:t>31</a:t>
+              <a:t>32</a:t>
             </a:r>
             <a:endParaRPr lang="en-US" sz="3000" dirty="0"/>
           </a:p>
@@ -13235,7 +13235,7 @@
                 <a:ea typeface="Cambria" pitchFamily="34" charset="-122"/>
                 <a:cs typeface="Cambria" pitchFamily="34" charset="-120"/>
               </a:rPr>
-              <a:t>≈29.900</a:t>
+              <a:t>≈31.000</a:t>
             </a:r>
             <a:endParaRPr lang="en-US" sz="3000" dirty="0"/>
           </a:p>
@@ -14022,7 +14022,7 @@
                 <a:ea typeface="Cambria" pitchFamily="34" charset="-122"/>
                 <a:cs typeface="Cambria" pitchFamily="34" charset="-120"/>
               </a:rPr>
-              <a:t>115</a:t>
+              <a:t>116</a:t>
             </a:r>
             <a:endParaRPr lang="en-US" sz="2400" dirty="0"/>
           </a:p>
@@ -14075,7 +14075,7 @@
                 <a:ea typeface="Cambria" pitchFamily="34" charset="-122"/>
                 <a:cs typeface="Cambria" pitchFamily="34" charset="-120"/>
               </a:rPr>
-              <a:t>31</a:t>
+              <a:t>32</a:t>
             </a:r>
             <a:endParaRPr lang="en-US" sz="2400" dirty="0"/>
           </a:p>
@@ -14181,7 +14181,7 @@
                 <a:ea typeface="Cambria" pitchFamily="34" charset="-122"/>
                 <a:cs typeface="Cambria" pitchFamily="34" charset="-120"/>
               </a:rPr>
-              <a:t>≈29.900</a:t>
+              <a:t>≈31.000</a:t>
             </a:r>
             <a:endParaRPr lang="en-US" sz="2400" dirty="0"/>
           </a:p>
@@ -17007,7 +17007,7 @@
                 <a:ea typeface="Cambria" pitchFamily="34" charset="-122"/>
                 <a:cs typeface="Cambria" pitchFamily="34" charset="-120"/>
               </a:rPr>
-              <a:t>Novità del 19 ottobre</a:t>
+              <a:t>Novità del 19 e 20 ottobre</a:t>
             </a:r>
             <a:endParaRPr lang="en-US" sz="3000" dirty="0"/>
           </a:p>
@@ -17455,7 +17455,7 @@
                   <a:schemeClr val="tx1"/>
                 </a:solidFill>
               </a:rPr>
-              <a:t>più amministratori con accesso completo; luca.moretti@operate.it è il principale e non si modifica né si cancella; si eliminano solo gli utenti mai attivi</a:t>
+              <a:t>più amministratori; luca.moretti@operate.it è il principale, non si modifica né si cancella, e vede chi è online, su quale pagina e da quanto (20/10)</a:t>
             </a:r>
             <a:endParaRPr lang="en-US" sz="1350" dirty="0"/>
           </a:p>
@@ -17523,7 +17523,7 @@
                   <a:schemeClr val="tx1"/>
                 </a:solidFill>
               </a:rPr>
-              <a:t>«✦ Assistente» con Claude per enti e Amministratori, risponde dai manuali e dalle tariffe (attivo dal 19/10)</a:t>
+              <a:t>«✦ Assistente» con Claude per enti e Amministratori, dai manuali e dalle tariffe; attivo dal 19/10, errori in italiano dal 20/10</a:t>
             </a:r>
             <a:endParaRPr lang="en-US" sz="1350" dirty="0"/>
           </a:p>
@@ -17557,7 +17557,7 @@
                   <a:schemeClr val="tx1"/>
                 </a:solidFill>
               </a:rPr>
-              <a:t>secondo metodo «per utenza, solo utenze virtuose», come nell'Allegato A EsaCom, con buffer del Capitolo 7</a:t>
+              <a:t>metodo «per utenza, solo utenze virtuose» come nell'Allegato A EsaCom; dal 20/10 PDF impaginato ed export Excel</a:t>
             </a:r>
             <a:endParaRPr lang="en-US" sz="1350" dirty="0"/>
           </a:p>

</xml_diff>

<commit_message>
Registro 4.5: funzioni assistente, crea-utente e reimposta-password ripubblicate
Co-Authored-By: Claude Opus 5.5 <noreply@anthropic.com>
Claude-Session: https://claude.ai/code/session_01E8XCbEeVHWVP3hntUZ6kZ1
</commit_message>
<xml_diff>
--- a/public/documentazione/Presentazione_Portale_CWP.pptx
+++ b/public/documentazione/Presentazione_Portale_CWP.pptx
@@ -120,39 +120,39 @@
   <p:extLst>
     <p:ext uri="{521415D9-36F7-43E2-AB2F-B90AF26B5E84}">
       <p14:sectionLst xmlns:p14="http://schemas.microsoft.com/office/powerpoint/2010/main">
-        <p14:section name="Apertura" id="{586038c2-e6bc-34c1-1572-aecc7d68e041}">
+        <p14:section name="Apertura" id="{749521ab-567c-edc4-f20c-d2c28398f0f4}">
           <p14:sldIdLst>
             <p14:sldId id="256"/>
           </p14:sldIdLst>
         </p14:section>
-        <p14:section name="Metodologia" id="{8339a078-da6a-7b9b-7c10-52885fbc96ca}">
+        <p14:section name="Metodologia" id="{a561608e-bdf1-5d59-a9fe-28c01bf7f31b}">
           <p14:sldIdLst>
             <p14:sldId id="257"/>
           </p14:sldIdLst>
         </p14:section>
-        <p14:section name="Analisi funzionale" id="{7e151900-7bc4-5dd0-54e7-9b5af9a7cdee}">
+        <p14:section name="Analisi funzionale" id="{ef9a5f01-c515-ff03-49f9-cb0a93ff5cd0}">
           <p14:sldIdLst>
             <p14:sldId id="258"/>
             <p14:sldId id="259"/>
           </p14:sldIdLst>
         </p14:section>
-        <p14:section name="Già realtà" id="{020f0b95-6fea-3afc-8ac0-1208eb709dea}">
+        <p14:section name="Già realtà" id="{2675d8c3-0239-e770-547f-96f1b65c4183}">
           <p14:sldIdLst>
             <p14:sldId id="260"/>
           </p14:sldIdLst>
         </p14:section>
-        <p14:section name="Architettura e ruoli" id="{75c8600f-d362-adac-6fd3-336154ea39ab}">
+        <p14:section name="Architettura e ruoli" id="{7a4812b8-7665-6757-eb0e-9a62f20c2e53}">
           <p14:sldIdLst>
             <p14:sldId id="261"/>
             <p14:sldId id="262"/>
           </p14:sldIdLst>
         </p14:section>
-        <p14:section name="Novità" id="{d5073bfe-1d4e-6caa-4263-0fa0591b3026}">
+        <p14:section name="Novità" id="{41139592-fbdb-1487-7d71-b015d452ce0c}">
           <p14:sldIdLst>
             <p14:sldId id="263"/>
           </p14:sldIdLst>
         </p14:section>
-        <p14:section name="Punti aperti" id="{99a768f6-4d6d-1680-7195-4431f2d79c25}">
+        <p14:section name="Punti aperti" id="{6f0005d9-7549-9279-6ec2-5141289bbf90}">
           <p14:sldIdLst>
             <p14:sldId id="264"/>
             <p14:sldId id="265"/>
@@ -161,7 +161,7 @@
             <p14:sldId id="268"/>
           </p14:sldIdLst>
         </p14:section>
-        <p14:section name="Scelte da prendere" id="{7723507d-81b1-9ee5-cff8-ed1c8a3a6b68}">
+        <p14:section name="Scelte da prendere" id="{7ac91522-762e-148b-3756-2c7dbf672ccc}">
           <p14:sldIdLst>
             <p14:sldId id="269"/>
           </p14:sldIdLst>
@@ -1362,7 +1362,7 @@
           <a:p>
             <a:r>
               <a:rPr lang="en-US" dirty="0"/>
-              <a:t>Pagina «effetto sorpresa»: nessuno si aspetta che il portale sia già online. Il sistema è stato realizzato da Luca Moretti con l'ausilio di Claude Code ed è quasi terminato; i servizi sono già in produzione: GitHub (codice), Vercel (pubblicazione del portale), Supabase (database, utenti, documenti, funzioni) e Resend (email). Il portale è pubblicato su portale-cwp.vercel.app e funziona con dati di prova: si può aprire durante la presentazione (collegamento cliccabile) o inquadrare il codice QR con il telefono. La pagina pubblica /programma mostra già gli 8 documenti ufficiali del Programma, la Metodologia approvata, la PEC e il soggetto promotore. Lo sviluppo del portale vero è partito il 17 ottobre 2026: da allora sono state pubblicate 116 versioni, 32 script del database e 6 funzioni sul server. Restano i punti aperti delle prossime slide (servizi a pagamento, sicurezza, dati da inserire, collaudo con un Comune). Suggerimento: aprire il portale dal vivo con un utente di prova e mostrare la pagina pubblica.</a:t>
+              <a:t>Pagina «effetto sorpresa»: nessuno si aspetta che il portale sia già online. Il sistema è stato realizzato da Luca Moretti con l'ausilio di Claude Code ed è quasi terminato; i servizi sono già in produzione: GitHub (codice), Vercel (pubblicazione del portale), Supabase (database, utenti, documenti, funzioni) e Resend (email). Il portale è pubblicato su portale-cwp.vercel.app e funziona con dati di prova: si può aprire durante la presentazione (collegamento cliccabile) o inquadrare il codice QR con il telefono. La pagina pubblica /programma mostra già gli 8 documenti ufficiali del Programma, la Metodologia approvata, la PEC e il soggetto promotore. Lo sviluppo del portale vero è partito il 17 ottobre 2026: da allora sono state pubblicate 117 versioni, 32 script del database e 6 funzioni sul server. Restano i punti aperti delle prossime slide (servizi a pagamento, sicurezza, dati da inserire, collaudo con un Comune). Suggerimento: aprire il portale dal vivo con un utente di prova e mostrare la pagina pubblica.</a:t>
             </a:r>
             <a:endParaRPr lang="en-US" dirty="0"/>
           </a:p>
@@ -14022,7 +14022,7 @@
                 <a:ea typeface="Cambria" pitchFamily="34" charset="-122"/>
                 <a:cs typeface="Cambria" pitchFamily="34" charset="-120"/>
               </a:rPr>
-              <a:t>116</a:t>
+              <a:t>117</a:t>
             </a:r>
             <a:endParaRPr lang="en-US" sz="2400" dirty="0"/>
           </a:p>

</xml_diff>

<commit_message>
Audit trail user: sezione riservata all'Amministratore principale con utenti online, registro degli accessi (entrate, uscite, tentativi non riusciti) e operazioni per utente, download dei documenti nell'audit (script 33); Registro 4.6, Manuale Utente 2.9, Amministratore 3.9, Test 3.5, Ripristino 1.3, Presentazione 2.5
Co-Authored-By: Claude Opus 5.5 <noreply@anthropic.com>
Claude-Session: https://claude.ai/code/session_01E8XCbEeVHWVP3hntUZ6kZ1
</commit_message>
<xml_diff>
--- a/public/documentazione/Presentazione_Portale_CWP.pptx
+++ b/public/documentazione/Presentazione_Portale_CWP.pptx
@@ -120,39 +120,39 @@
   <p:extLst>
     <p:ext uri="{521415D9-36F7-43E2-AB2F-B90AF26B5E84}">
       <p14:sectionLst xmlns:p14="http://schemas.microsoft.com/office/powerpoint/2010/main">
-        <p14:section name="Apertura" id="{749521ab-567c-edc4-f20c-d2c28398f0f4}">
+        <p14:section name="Apertura" id="{d3283bdd-b4ed-302a-deb0-b9442ddeecd9}">
           <p14:sldIdLst>
             <p14:sldId id="256"/>
           </p14:sldIdLst>
         </p14:section>
-        <p14:section name="Metodologia" id="{a561608e-bdf1-5d59-a9fe-28c01bf7f31b}">
+        <p14:section name="Metodologia" id="{42dcc5b8-6dc8-6780-6ab4-2522678b9a03}">
           <p14:sldIdLst>
             <p14:sldId id="257"/>
           </p14:sldIdLst>
         </p14:section>
-        <p14:section name="Analisi funzionale" id="{ef9a5f01-c515-ff03-49f9-cb0a93ff5cd0}">
+        <p14:section name="Analisi funzionale" id="{7e921f03-fbfc-167f-e7f9-fd38ad486983}">
           <p14:sldIdLst>
             <p14:sldId id="258"/>
             <p14:sldId id="259"/>
           </p14:sldIdLst>
         </p14:section>
-        <p14:section name="Già realtà" id="{2675d8c3-0239-e770-547f-96f1b65c4183}">
+        <p14:section name="Già realtà" id="{e467d7b6-0a51-6511-6496-3caa113fbce3}">
           <p14:sldIdLst>
             <p14:sldId id="260"/>
           </p14:sldIdLst>
         </p14:section>
-        <p14:section name="Architettura e ruoli" id="{7a4812b8-7665-6757-eb0e-9a62f20c2e53}">
+        <p14:section name="Architettura e ruoli" id="{ed1a7542-5e02-3ad9-391c-d5212335e3d9}">
           <p14:sldIdLst>
             <p14:sldId id="261"/>
             <p14:sldId id="262"/>
           </p14:sldIdLst>
         </p14:section>
-        <p14:section name="Novità" id="{41139592-fbdb-1487-7d71-b015d452ce0c}">
+        <p14:section name="Novità" id="{2a0def76-db1d-2765-11db-42c9c1a75aa4}">
           <p14:sldIdLst>
             <p14:sldId id="263"/>
           </p14:sldIdLst>
         </p14:section>
-        <p14:section name="Punti aperti" id="{6f0005d9-7549-9279-6ec2-5141289bbf90}">
+        <p14:section name="Punti aperti" id="{b1eb82c0-1da0-dfc7-1785-056cf8103f18}">
           <p14:sldIdLst>
             <p14:sldId id="264"/>
             <p14:sldId id="265"/>
@@ -161,7 +161,7 @@
             <p14:sldId id="268"/>
           </p14:sldIdLst>
         </p14:section>
-        <p14:section name="Scelte da prendere" id="{7ac91522-762e-148b-3756-2c7dbf672ccc}">
+        <p14:section name="Scelte da prendere" id="{f3cfbc14-ff56-e0a6-2b0c-35d1f6592e59}">
           <p14:sldIdLst>
             <p14:sldId id="269"/>
           </p14:sldIdLst>
@@ -570,7 +570,7 @@
           <a:p>
             <a:r>
               <a:rPr lang="en-US" dirty="0"/>
-              <a:t>Presentazione di riepilogo del portale, aggiornata al 20 ottobre 2026 (revisione 2.4): metodologia, funzioni realizzate, novità, punti aperti di sviluppo e scelte ancora da prendere. Si rigenera a ogni rilascio insieme agli altri documenti ed è disponibile agli Amministratori nella pagina Documentazione del portale.</a:t>
+              <a:t>Presentazione di riepilogo del portale, aggiornata al 20 ottobre 2026 (revisione 2.5): metodologia, funzioni realizzate, novità, punti aperti di sviluppo e scelte ancora da prendere. Si rigenera a ogni rilascio insieme agli altri documenti ed è disponibile agli Amministratori nella pagina Documentazione del portale.</a:t>
             </a:r>
             <a:endParaRPr lang="en-US" dirty="0"/>
           </a:p>
@@ -1362,7 +1362,7 @@
           <a:p>
             <a:r>
               <a:rPr lang="en-US" dirty="0"/>
-              <a:t>Pagina «effetto sorpresa»: nessuno si aspetta che il portale sia già online. Il sistema è stato realizzato da Luca Moretti con l'ausilio di Claude Code ed è quasi terminato; i servizi sono già in produzione: GitHub (codice), Vercel (pubblicazione del portale), Supabase (database, utenti, documenti, funzioni) e Resend (email). Il portale è pubblicato su portale-cwp.vercel.app e funziona con dati di prova: si può aprire durante la presentazione (collegamento cliccabile) o inquadrare il codice QR con il telefono. La pagina pubblica /programma mostra già gli 8 documenti ufficiali del Programma, la Metodologia approvata, la PEC e il soggetto promotore. Lo sviluppo del portale vero è partito il 17 ottobre 2026: da allora sono state pubblicate 117 versioni, 32 script del database e 6 funzioni sul server. Restano i punti aperti delle prossime slide (servizi a pagamento, sicurezza, dati da inserire, collaudo con un Comune). Suggerimento: aprire il portale dal vivo con un utente di prova e mostrare la pagina pubblica.</a:t>
+              <a:t>Pagina «effetto sorpresa»: nessuno si aspetta che il portale sia già online. Il sistema è stato realizzato da Luca Moretti con l'ausilio di Claude Code ed è quasi terminato; i servizi sono già in produzione: GitHub (codice), Vercel (pubblicazione del portale), Supabase (database, utenti, documenti, funzioni) e Resend (email). Il portale è pubblicato su portale-cwp.vercel.app e funziona con dati di prova: si può aprire durante la presentazione (collegamento cliccabile) o inquadrare il codice QR con il telefono. La pagina pubblica /programma mostra già gli 8 documenti ufficiali del Programma, la Metodologia approvata, la PEC e il soggetto promotore. Lo sviluppo del portale vero è partito il 17 ottobre 2026: da allora sono state pubblicate 118 versioni, 33 script del database e 6 funzioni sul server. Restano i punti aperti delle prossime slide (servizi a pagamento, sicurezza, dati da inserire, collaudo con un Comune). Suggerimento: aprire il portale dal vivo con un utente di prova e mostrare la pagina pubblica.</a:t>
             </a:r>
             <a:endParaRPr lang="en-US" dirty="0"/>
           </a:p>
@@ -1626,7 +1626,7 @@
           <a:p>
             <a:r>
               <a:rPr lang="en-US" dirty="0"/>
-              <a:t>Novità pubblicate il 19 ottobre pomeriggio, su richiesta di Luca. Dashboard (prima «Cruscotto»): per ogni pratica una barra di 7 luci, una per fase, accese le fasi completate e spente quelle da fare, la settima verde; la fase in corso ha il contorno. Ordinamento: ogni tabella del portale si ordina per qualsiasi colonna e gli elenchi a schede hanno il menu «Ordina per». Utenti: un Amministratore può nominare altri Amministratori, tutti con accesso completo; l'Amministratore principale luca.moretti@operate.it è protetto dal database (non si declassa, non si disattiva, non si cancella, nemmeno dal pannello di Supabase); si possono eliminare solo gli utenti che non hanno mai operato (nessuna voce nell'audit e nessun dato a loro nome). Email: il nuovo utente riceve indirizzo del portale, email e password temporanea, con l'obbligo di sceglierne una personale al primo accesso; finché il dominio operate.it non è verificato su Resend le email arrivano solo al titolare dell'account. Simulatore: oltre al bilancio del Comune c'è il metodo per utenza con le sole utenze virtuose (formula 32 con buffer), lo stesso delle stime dell'Allegato A dei contratti EsaCom; il buffer si calcola dalle Tabelle 15-16. Decisione: il portale non va qualificato ACN come servizio cloud per la PA, perché serve a qualificare il modello e il Comune vi riversa dati senza acquistare un servizio; restano GDPR, dati in UE e sicurezza; da confermare con un parere legale. Il 20 ottobre: utenti online per l'Amministratore principale (chi è collegato adesso, pagina aperta, da quanto, e chi è stato visto nelle ultime 24 ore; si conserva solo l'ultimo collegamento, gli utenti ne sono informati nel Manuale Utente); messaggi d'errore dell'assistente in italiano semplice, con la causa per gli Amministratori; simulatore con PDF impaginato in A4 orizzontale ed export Excel con i fogli Sintesi, Anni, Economia e Costi.</a:t>
+              <a:t>Novità pubblicate il 19 ottobre pomeriggio, su richiesta di Luca. Dashboard (prima «Cruscotto»): per ogni pratica una barra di 7 luci, una per fase, accese le fasi completate e spente quelle da fare, la settima verde; la fase in corso ha il contorno. Ordinamento: ogni tabella del portale si ordina per qualsiasi colonna e gli elenchi a schede hanno il menu «Ordina per». Utenti: un Amministratore può nominare altri Amministratori, tutti con accesso completo; l'Amministratore principale luca.moretti@operate.it è protetto dal database (non si declassa, non si disattiva, non si cancella, nemmeno dal pannello di Supabase); si possono eliminare solo gli utenti che non hanno mai operato (nessuna voce nell'audit e nessun dato a loro nome). Email: il nuovo utente riceve indirizzo del portale, email e password temporanea, con l'obbligo di sceglierne una personale al primo accesso; finché il dominio operate.it non è verificato su Resend le email arrivano solo al titolare dell'account. Simulatore: oltre al bilancio del Comune c'è il metodo per utenza con le sole utenze virtuose (formula 32 con buffer), lo stesso delle stime dell'Allegato A dei contratti EsaCom; il buffer si calcola dalle Tabelle 15-16. Decisione: il portale non va qualificato ACN come servizio cloud per la PA, perché serve a qualificare il modello e il Comune vi riversa dati senza acquistare un servizio; restano GDPR, dati in UE e sicurezza; da confermare con un parere legale. Il 20 ottobre: sezione «Audit trail user» per l'Amministratore principale, con tutti gli utenti online o no, il registro degli accessi (entrate, uscite, tentativi non riusciti, senza indirizzi IP) e le operazioni dell'audit trail per utente, compreso lo scaricamento dei documenti; utenti online per l'Amministratore principale (chi è collegato adesso, pagina aperta, da quanto, e chi è stato visto nelle ultime 24 ore; si conserva solo l'ultimo collegamento, gli utenti ne sono informati nel Manuale Utente); messaggi d'errore dell'assistente in italiano semplice, con la causa per gli Amministratori; simulatore con PDF impaginato in A4 orizzontale ed export Excel con i fogli Sintesi, Anni, Economia e Costi.</a:t>
             </a:r>
             <a:endParaRPr lang="en-US" dirty="0"/>
           </a:p>
@@ -2073,7 +2073,7 @@
                   <a:schemeClr val="accent6"/>
                 </a:solidFill>
               </a:rPr>
-              <a:t>Portale Carbon WastePrint · Stato dei lavori e recap · 20 ottobre 2026 · rev. 2.4</a:t>
+              <a:t>Portale Carbon WastePrint · Stato dei lavori e recap · 20 ottobre 2026 · rev. 2.5</a:t>
             </a:r>
             <a:endParaRPr lang="en-US" sz="1000" dirty="0"/>
           </a:p>
@@ -2571,7 +2571,7 @@
                   <a:schemeClr val="accent3"/>
                 </a:solidFill>
               </a:rPr>
-              <a:t>Stato dei lavori e recap: metodologia, funzioni, novità, punti aperti e scelte da prendere · aggiornata al 20 ottobre 2026 · rev. 2.4</a:t>
+              <a:t>Stato dei lavori e recap: metodologia, funzioni, novità, punti aperti e scelte da prendere · aggiornata al 20 ottobre 2026 · rev. 2.5</a:t>
             </a:r>
             <a:endParaRPr lang="en-US" sz="1800" dirty="0"/>
           </a:p>
@@ -12929,7 +12929,7 @@
                 <a:ea typeface="Cambria" pitchFamily="34" charset="-122"/>
                 <a:cs typeface="Cambria" pitchFamily="34" charset="-120"/>
               </a:rPr>
-              <a:t>32</a:t>
+              <a:t>33</a:t>
             </a:r>
             <a:endParaRPr lang="en-US" sz="3000" dirty="0"/>
           </a:p>
@@ -13235,7 +13235,7 @@
                 <a:ea typeface="Cambria" pitchFamily="34" charset="-122"/>
                 <a:cs typeface="Cambria" pitchFamily="34" charset="-120"/>
               </a:rPr>
-              <a:t>≈31.000</a:t>
+              <a:t>≈31.800</a:t>
             </a:r>
             <a:endParaRPr lang="en-US" sz="3000" dirty="0"/>
           </a:p>
@@ -14022,7 +14022,7 @@
                 <a:ea typeface="Cambria" pitchFamily="34" charset="-122"/>
                 <a:cs typeface="Cambria" pitchFamily="34" charset="-120"/>
               </a:rPr>
-              <a:t>117</a:t>
+              <a:t>118</a:t>
             </a:r>
             <a:endParaRPr lang="en-US" sz="2400" dirty="0"/>
           </a:p>
@@ -14075,7 +14075,7 @@
                 <a:ea typeface="Cambria" pitchFamily="34" charset="-122"/>
                 <a:cs typeface="Cambria" pitchFamily="34" charset="-120"/>
               </a:rPr>
-              <a:t>32</a:t>
+              <a:t>33</a:t>
             </a:r>
             <a:endParaRPr lang="en-US" sz="2400" dirty="0"/>
           </a:p>
@@ -14181,7 +14181,7 @@
                 <a:ea typeface="Cambria" pitchFamily="34" charset="-122"/>
                 <a:cs typeface="Cambria" pitchFamily="34" charset="-120"/>
               </a:rPr>
-              <a:t>≈31.000</a:t>
+              <a:t>≈31.800</a:t>
             </a:r>
             <a:endParaRPr lang="en-US" sz="2400" dirty="0"/>
           </a:p>
@@ -17455,7 +17455,7 @@
                   <a:schemeClr val="tx1"/>
                 </a:solidFill>
               </a:rPr>
-              <a:t>più amministratori; luca.moretti@operate.it è il principale, non si modifica né si cancella, e vede chi è online, su quale pagina e da quanto (20/10)</a:t>
+              <a:t>più amministratori; luca.moretti@operate.it è il principale e ha la sezione «Audit trail user»: chi è online, accessi e operazioni di ogni utente (20/10)</a:t>
             </a:r>
             <a:endParaRPr lang="en-US" sz="1350" dirty="0"/>
           </a:p>

</xml_diff>

<commit_message>
Registro 4.7: script 30, 32 e 33 eseguiti in produzione
Co-Authored-By: Claude Opus 5.5 <noreply@anthropic.com>
Claude-Session: https://claude.ai/code/session_01E8XCbEeVHWVP3hntUZ6kZ1
</commit_message>
<xml_diff>
--- a/public/documentazione/Presentazione_Portale_CWP.pptx
+++ b/public/documentazione/Presentazione_Portale_CWP.pptx
@@ -120,39 +120,39 @@
   <p:extLst>
     <p:ext uri="{521415D9-36F7-43E2-AB2F-B90AF26B5E84}">
       <p14:sectionLst xmlns:p14="http://schemas.microsoft.com/office/powerpoint/2010/main">
-        <p14:section name="Apertura" id="{d3283bdd-b4ed-302a-deb0-b9442ddeecd9}">
+        <p14:section name="Apertura" id="{7b5144d2-74f2-e3ab-cf0f-e7cddbd27c5e}">
           <p14:sldIdLst>
             <p14:sldId id="256"/>
           </p14:sldIdLst>
         </p14:section>
-        <p14:section name="Metodologia" id="{42dcc5b8-6dc8-6780-6ab4-2522678b9a03}">
+        <p14:section name="Metodologia" id="{a0dc6646-49fd-2ee6-6290-d6726692d872}">
           <p14:sldIdLst>
             <p14:sldId id="257"/>
           </p14:sldIdLst>
         </p14:section>
-        <p14:section name="Analisi funzionale" id="{7e921f03-fbfc-167f-e7f9-fd38ad486983}">
+        <p14:section name="Analisi funzionale" id="{30ae77b1-4745-f38c-3e52-f65d4c537037}">
           <p14:sldIdLst>
             <p14:sldId id="258"/>
             <p14:sldId id="259"/>
           </p14:sldIdLst>
         </p14:section>
-        <p14:section name="Già realtà" id="{e467d7b6-0a51-6511-6496-3caa113fbce3}">
+        <p14:section name="Già realtà" id="{a794d5d6-764c-3997-d34b-f99339f21297}">
           <p14:sldIdLst>
             <p14:sldId id="260"/>
           </p14:sldIdLst>
         </p14:section>
-        <p14:section name="Architettura e ruoli" id="{ed1a7542-5e02-3ad9-391c-d5212335e3d9}">
+        <p14:section name="Architettura e ruoli" id="{a50949e0-a8bf-49ba-3a11-6fead275abdb}">
           <p14:sldIdLst>
             <p14:sldId id="261"/>
             <p14:sldId id="262"/>
           </p14:sldIdLst>
         </p14:section>
-        <p14:section name="Novità" id="{2a0def76-db1d-2765-11db-42c9c1a75aa4}">
+        <p14:section name="Novità" id="{3de1da05-bfe0-49c6-3ba1-003f910e3910}">
           <p14:sldIdLst>
             <p14:sldId id="263"/>
           </p14:sldIdLst>
         </p14:section>
-        <p14:section name="Punti aperti" id="{b1eb82c0-1da0-dfc7-1785-056cf8103f18}">
+        <p14:section name="Punti aperti" id="{7fb34208-b5ef-854d-f814-3d173e8a9a0a}">
           <p14:sldIdLst>
             <p14:sldId id="264"/>
             <p14:sldId id="265"/>
@@ -161,7 +161,7 @@
             <p14:sldId id="268"/>
           </p14:sldIdLst>
         </p14:section>
-        <p14:section name="Scelte da prendere" id="{f3cfbc14-ff56-e0a6-2b0c-35d1f6592e59}">
+        <p14:section name="Scelte da prendere" id="{1c1f436d-a61c-d96e-7ff0-dd60b7f3c82b}">
           <p14:sldIdLst>
             <p14:sldId id="269"/>
           </p14:sldIdLst>
@@ -1362,7 +1362,7 @@
           <a:p>
             <a:r>
               <a:rPr lang="en-US" dirty="0"/>
-              <a:t>Pagina «effetto sorpresa»: nessuno si aspetta che il portale sia già online. Il sistema è stato realizzato da Luca Moretti con l'ausilio di Claude Code ed è quasi terminato; i servizi sono già in produzione: GitHub (codice), Vercel (pubblicazione del portale), Supabase (database, utenti, documenti, funzioni) e Resend (email). Il portale è pubblicato su portale-cwp.vercel.app e funziona con dati di prova: si può aprire durante la presentazione (collegamento cliccabile) o inquadrare il codice QR con il telefono. La pagina pubblica /programma mostra già gli 8 documenti ufficiali del Programma, la Metodologia approvata, la PEC e il soggetto promotore. Lo sviluppo del portale vero è partito il 17 ottobre 2026: da allora sono state pubblicate 118 versioni, 33 script del database e 6 funzioni sul server. Restano i punti aperti delle prossime slide (servizi a pagamento, sicurezza, dati da inserire, collaudo con un Comune). Suggerimento: aprire il portale dal vivo con un utente di prova e mostrare la pagina pubblica.</a:t>
+              <a:t>Pagina «effetto sorpresa»: nessuno si aspetta che il portale sia già online. Il sistema è stato realizzato da Luca Moretti con l'ausilio di Claude Code ed è quasi terminato; i servizi sono già in produzione: GitHub (codice), Vercel (pubblicazione del portale), Supabase (database, utenti, documenti, funzioni) e Resend (email). Il portale è pubblicato su portale-cwp.vercel.app e funziona con dati di prova: si può aprire durante la presentazione (collegamento cliccabile) o inquadrare il codice QR con il telefono. La pagina pubblica /programma mostra già gli 8 documenti ufficiali del Programma, la Metodologia approvata, la PEC e il soggetto promotore. Lo sviluppo del portale vero è partito il 17 ottobre 2026: da allora sono state pubblicate 119 versioni, 33 script del database e 6 funzioni sul server. Restano i punti aperti delle prossime slide (servizi a pagamento, sicurezza, dati da inserire, collaudo con un Comune). Suggerimento: aprire il portale dal vivo con un utente di prova e mostrare la pagina pubblica.</a:t>
             </a:r>
             <a:endParaRPr lang="en-US" dirty="0"/>
           </a:p>
@@ -14022,7 +14022,7 @@
                 <a:ea typeface="Cambria" pitchFamily="34" charset="-122"/>
                 <a:cs typeface="Cambria" pitchFamily="34" charset="-120"/>
               </a:rPr>
-              <a:t>118</a:t>
+              <a:t>119</a:t>
             </a:r>
             <a:endParaRPr lang="en-US" sz="2400" dirty="0"/>
           </a:p>

</xml_diff>

<commit_message>
Menu degli Amministratori riordinato, sezione rinominata «Audit User», voce «Marketplaces» in arrivo (grigia) per Amministratori ed enti; Registro 4.8, Manuale Utente 3.0, Amministratore 4.0, Test 3.6, Presentazione 2.6
Co-Authored-By: Claude Opus 5.5 <noreply@anthropic.com>
Claude-Session: https://claude.ai/code/session_01E8XCbEeVHWVP3hntUZ6kZ1
</commit_message>
<xml_diff>
--- a/public/documentazione/Presentazione_Portale_CWP.pptx
+++ b/public/documentazione/Presentazione_Portale_CWP.pptx
@@ -120,39 +120,39 @@
   <p:extLst>
     <p:ext uri="{521415D9-36F7-43E2-AB2F-B90AF26B5E84}">
       <p14:sectionLst xmlns:p14="http://schemas.microsoft.com/office/powerpoint/2010/main">
-        <p14:section name="Apertura" id="{7b5144d2-74f2-e3ab-cf0f-e7cddbd27c5e}">
+        <p14:section name="Apertura" id="{7badf330-8c82-931e-b6ea-c154d1688cc5}">
           <p14:sldIdLst>
             <p14:sldId id="256"/>
           </p14:sldIdLst>
         </p14:section>
-        <p14:section name="Metodologia" id="{a0dc6646-49fd-2ee6-6290-d6726692d872}">
+        <p14:section name="Metodologia" id="{ee330bf9-3fe7-0dfb-20cd-2468adbd0b7a}">
           <p14:sldIdLst>
             <p14:sldId id="257"/>
           </p14:sldIdLst>
         </p14:section>
-        <p14:section name="Analisi funzionale" id="{30ae77b1-4745-f38c-3e52-f65d4c537037}">
+        <p14:section name="Analisi funzionale" id="{8effcfb4-12e1-cb6f-337b-a39d3d85ab22}">
           <p14:sldIdLst>
             <p14:sldId id="258"/>
             <p14:sldId id="259"/>
           </p14:sldIdLst>
         </p14:section>
-        <p14:section name="Già realtà" id="{a794d5d6-764c-3997-d34b-f99339f21297}">
+        <p14:section name="Già realtà" id="{ff607424-2aa8-e681-db0d-c62bccc430f3}">
           <p14:sldIdLst>
             <p14:sldId id="260"/>
           </p14:sldIdLst>
         </p14:section>
-        <p14:section name="Architettura e ruoli" id="{a50949e0-a8bf-49ba-3a11-6fead275abdb}">
+        <p14:section name="Architettura e ruoli" id="{deada2b8-c2c2-a923-c19a-54e7363b41b3}">
           <p14:sldIdLst>
             <p14:sldId id="261"/>
             <p14:sldId id="262"/>
           </p14:sldIdLst>
         </p14:section>
-        <p14:section name="Novità" id="{3de1da05-bfe0-49c6-3ba1-003f910e3910}">
+        <p14:section name="Novità" id="{295c91df-45bb-2604-db48-ee18cbdb7b04}">
           <p14:sldIdLst>
             <p14:sldId id="263"/>
           </p14:sldIdLst>
         </p14:section>
-        <p14:section name="Punti aperti" id="{7fb34208-b5ef-854d-f814-3d173e8a9a0a}">
+        <p14:section name="Punti aperti" id="{547655a9-b4da-7483-8cae-df0562c11704}">
           <p14:sldIdLst>
             <p14:sldId id="264"/>
             <p14:sldId id="265"/>
@@ -161,7 +161,7 @@
             <p14:sldId id="268"/>
           </p14:sldIdLst>
         </p14:section>
-        <p14:section name="Scelte da prendere" id="{1c1f436d-a61c-d96e-7ff0-dd60b7f3c82b}">
+        <p14:section name="Scelte da prendere" id="{9dd471d7-9fbc-7fd6-7eff-8b51722599ef}">
           <p14:sldIdLst>
             <p14:sldId id="269"/>
           </p14:sldIdLst>
@@ -570,7 +570,7 @@
           <a:p>
             <a:r>
               <a:rPr lang="en-US" dirty="0"/>
-              <a:t>Presentazione di riepilogo del portale, aggiornata al 20 ottobre 2026 (revisione 2.5): metodologia, funzioni realizzate, novità, punti aperti di sviluppo e scelte ancora da prendere. Si rigenera a ogni rilascio insieme agli altri documenti ed è disponibile agli Amministratori nella pagina Documentazione del portale.</a:t>
+              <a:t>Presentazione di riepilogo del portale, aggiornata al 20 ottobre 2026 (revisione 2.6): metodologia, funzioni realizzate, novità, punti aperti di sviluppo e scelte ancora da prendere. Si rigenera a ogni rilascio insieme agli altri documenti ed è disponibile agli Amministratori nella pagina Documentazione del portale.</a:t>
             </a:r>
             <a:endParaRPr lang="en-US" dirty="0"/>
           </a:p>
@@ -1362,7 +1362,7 @@
           <a:p>
             <a:r>
               <a:rPr lang="en-US" dirty="0"/>
-              <a:t>Pagina «effetto sorpresa»: nessuno si aspetta che il portale sia già online. Il sistema è stato realizzato da Luca Moretti con l'ausilio di Claude Code ed è quasi terminato; i servizi sono già in produzione: GitHub (codice), Vercel (pubblicazione del portale), Supabase (database, utenti, documenti, funzioni) e Resend (email). Il portale è pubblicato su portale-cwp.vercel.app e funziona con dati di prova: si può aprire durante la presentazione (collegamento cliccabile) o inquadrare il codice QR con il telefono. La pagina pubblica /programma mostra già gli 8 documenti ufficiali del Programma, la Metodologia approvata, la PEC e il soggetto promotore. Lo sviluppo del portale vero è partito il 17 ottobre 2026: da allora sono state pubblicate 119 versioni, 33 script del database e 6 funzioni sul server. Restano i punti aperti delle prossime slide (servizi a pagamento, sicurezza, dati da inserire, collaudo con un Comune). Suggerimento: aprire il portale dal vivo con un utente di prova e mostrare la pagina pubblica.</a:t>
+              <a:t>Pagina «effetto sorpresa»: nessuno si aspetta che il portale sia già online. Il sistema è stato realizzato da Luca Moretti con l'ausilio di Claude Code ed è quasi terminato; i servizi sono già in produzione: GitHub (codice), Vercel (pubblicazione del portale), Supabase (database, utenti, documenti, funzioni) e Resend (email). Il portale è pubblicato su portale-cwp.vercel.app e funziona con dati di prova: si può aprire durante la presentazione (collegamento cliccabile) o inquadrare il codice QR con il telefono. La pagina pubblica /programma mostra già gli 8 documenti ufficiali del Programma, la Metodologia approvata, la PEC e il soggetto promotore. Lo sviluppo del portale vero è partito il 17 ottobre 2026: da allora sono state pubblicate 120 versioni, 33 script del database e 6 funzioni sul server. Restano i punti aperti delle prossime slide (servizi a pagamento, sicurezza, dati da inserire, collaudo con un Comune). Suggerimento: aprire il portale dal vivo con un utente di prova e mostrare la pagina pubblica.</a:t>
             </a:r>
             <a:endParaRPr lang="en-US" dirty="0"/>
           </a:p>
@@ -1626,7 +1626,7 @@
           <a:p>
             <a:r>
               <a:rPr lang="en-US" dirty="0"/>
-              <a:t>Novità pubblicate il 19 ottobre pomeriggio, su richiesta di Luca. Dashboard (prima «Cruscotto»): per ogni pratica una barra di 7 luci, una per fase, accese le fasi completate e spente quelle da fare, la settima verde; la fase in corso ha il contorno. Ordinamento: ogni tabella del portale si ordina per qualsiasi colonna e gli elenchi a schede hanno il menu «Ordina per». Utenti: un Amministratore può nominare altri Amministratori, tutti con accesso completo; l'Amministratore principale luca.moretti@operate.it è protetto dal database (non si declassa, non si disattiva, non si cancella, nemmeno dal pannello di Supabase); si possono eliminare solo gli utenti che non hanno mai operato (nessuna voce nell'audit e nessun dato a loro nome). Email: il nuovo utente riceve indirizzo del portale, email e password temporanea, con l'obbligo di sceglierne una personale al primo accesso; finché il dominio operate.it non è verificato su Resend le email arrivano solo al titolare dell'account. Simulatore: oltre al bilancio del Comune c'è il metodo per utenza con le sole utenze virtuose (formula 32 con buffer), lo stesso delle stime dell'Allegato A dei contratti EsaCom; il buffer si calcola dalle Tabelle 15-16. Decisione: il portale non va qualificato ACN come servizio cloud per la PA, perché serve a qualificare il modello e il Comune vi riversa dati senza acquistare un servizio; restano GDPR, dati in UE e sicurezza; da confermare con un parere legale. Il 20 ottobre: sezione «Audit trail user» per l'Amministratore principale, con tutti gli utenti online o no, il registro degli accessi (entrate, uscite, tentativi non riusciti, senza indirizzi IP) e le operazioni dell'audit trail per utente, compreso lo scaricamento dei documenti; utenti online per l'Amministratore principale (chi è collegato adesso, pagina aperta, da quanto, e chi è stato visto nelle ultime 24 ore; si conserva solo l'ultimo collegamento, gli utenti ne sono informati nel Manuale Utente); messaggi d'errore dell'assistente in italiano semplice, con la causa per gli Amministratori; simulatore con PDF impaginato in A4 orizzontale ed export Excel con i fogli Sintesi, Anni, Economia e Costi.</a:t>
+              <a:t>Novità pubblicate il 19 ottobre pomeriggio, su richiesta di Luca. Dashboard (prima «Cruscotto»): per ogni pratica una barra di 7 luci, una per fase, accese le fasi completate e spente quelle da fare, la settima verde; la fase in corso ha il contorno. Ordinamento: ogni tabella del portale si ordina per qualsiasi colonna e gli elenchi a schede hanno il menu «Ordina per». Utenti: un Amministratore può nominare altri Amministratori, tutti con accesso completo; l'Amministratore principale luca.moretti@operate.it è protetto dal database (non si declassa, non si disattiva, non si cancella, nemmeno dal pannello di Supabase); si possono eliminare solo gli utenti che non hanno mai operato (nessuna voce nell'audit e nessun dato a loro nome). Email: il nuovo utente riceve indirizzo del portale, email e password temporanea, con l'obbligo di sceglierne una personale al primo accesso; finché il dominio operate.it non è verificato su Resend le email arrivano solo al titolare dell'account. Simulatore: oltre al bilancio del Comune c'è il metodo per utenza con le sole utenze virtuose (formula 32 con buffer), lo stesso delle stime dell'Allegato A dei contratti EsaCom; il buffer si calcola dalle Tabelle 15-16. Decisione: il portale non va qualificato ACN come servizio cloud per la PA, perché serve a qualificare il modello e il Comune vi riversa dati senza acquistare un servizio; restano GDPR, dati in UE e sicurezza; da confermare con un parere legale. Il 20 ottobre: sezione «Audit User» per l'Amministratore principale, con tutti gli utenti online o no, il registro degli accessi (entrate, uscite, tentativi non riusciti, senza indirizzi IP) e le operazioni dell'audit trail per utente, compreso lo scaricamento dei documenti; utenti online per l'Amministratore principale (chi è collegato adesso, pagina aperta, da quanto, e chi è stato visto nelle ultime 24 ore; si conserva solo l'ultimo collegamento, gli utenti ne sono informati nel Manuale Utente); messaggi d'errore dell'assistente in italiano semplice, con la causa per gli Amministratori; simulatore con PDF impaginato in A4 orizzontale ed export Excel con i fogli Sintesi, Anni, Economia e Costi.</a:t>
             </a:r>
             <a:endParaRPr lang="en-US" dirty="0"/>
           </a:p>
@@ -2073,7 +2073,7 @@
                   <a:schemeClr val="accent6"/>
                 </a:solidFill>
               </a:rPr>
-              <a:t>Portale Carbon WastePrint · Stato dei lavori e recap · 20 ottobre 2026 · rev. 2.5</a:t>
+              <a:t>Portale Carbon WastePrint · Stato dei lavori e recap · 20 ottobre 2026 · rev. 2.6</a:t>
             </a:r>
             <a:endParaRPr lang="en-US" sz="1000" dirty="0"/>
           </a:p>
@@ -2571,7 +2571,7 @@
                   <a:schemeClr val="accent3"/>
                 </a:solidFill>
               </a:rPr>
-              <a:t>Stato dei lavori e recap: metodologia, funzioni, novità, punti aperti e scelte da prendere · aggiornata al 20 ottobre 2026 · rev. 2.5</a:t>
+              <a:t>Stato dei lavori e recap: metodologia, funzioni, novità, punti aperti e scelte da prendere · aggiornata al 20 ottobre 2026 · rev. 2.6</a:t>
             </a:r>
             <a:endParaRPr lang="en-US" sz="1800" dirty="0"/>
           </a:p>
@@ -13235,7 +13235,7 @@
                 <a:ea typeface="Cambria" pitchFamily="34" charset="-122"/>
                 <a:cs typeface="Cambria" pitchFamily="34" charset="-120"/>
               </a:rPr>
-              <a:t>≈31.800</a:t>
+              <a:t>≈31.900</a:t>
             </a:r>
             <a:endParaRPr lang="en-US" sz="3000" dirty="0"/>
           </a:p>
@@ -14022,7 +14022,7 @@
                 <a:ea typeface="Cambria" pitchFamily="34" charset="-122"/>
                 <a:cs typeface="Cambria" pitchFamily="34" charset="-120"/>
               </a:rPr>
-              <a:t>119</a:t>
+              <a:t>120</a:t>
             </a:r>
             <a:endParaRPr lang="en-US" sz="2400" dirty="0"/>
           </a:p>
@@ -14181,7 +14181,7 @@
                 <a:ea typeface="Cambria" pitchFamily="34" charset="-122"/>
                 <a:cs typeface="Cambria" pitchFamily="34" charset="-120"/>
               </a:rPr>
-              <a:t>≈31.800</a:t>
+              <a:t>≈31.900</a:t>
             </a:r>
             <a:endParaRPr lang="en-US" sz="2400" dirty="0"/>
           </a:p>
@@ -17455,7 +17455,7 @@
                   <a:schemeClr val="tx1"/>
                 </a:solidFill>
               </a:rPr>
-              <a:t>più amministratori; luca.moretti@operate.it è il principale e ha la sezione «Audit trail user»: chi è online, accessi e operazioni di ogni utente (20/10)</a:t>
+              <a:t>più amministratori; luca.moretti@operate.it è il principale e ha la sezione «Audit User»: chi è online, accessi e operazioni di ogni utente (20/10)</a:t>
             </a:r>
             <a:endParaRPr lang="en-US" sz="1350" dirty="0"/>
           </a:p>

</xml_diff>

<commit_message>
Menu degli enti riordinato (Il Programma CWP, Manuali); documenti allineati: Registro 4.9 (pagine, menu per ruolo, struttura del codice, stato per area), Manuale Utente 3.1, Amministratore 4.1, Test 3.7, Ripristino 1.4, Presentazione 2.7, base di conoscenza
Co-Authored-By: Claude Opus 5.5 <noreply@anthropic.com>
Claude-Session: https://claude.ai/code/session_01E8XCbEeVHWVP3hntUZ6kZ1
</commit_message>
<xml_diff>
--- a/public/documentazione/Presentazione_Portale_CWP.pptx
+++ b/public/documentazione/Presentazione_Portale_CWP.pptx
@@ -120,39 +120,39 @@
   <p:extLst>
     <p:ext uri="{521415D9-36F7-43E2-AB2F-B90AF26B5E84}">
       <p14:sectionLst xmlns:p14="http://schemas.microsoft.com/office/powerpoint/2010/main">
-        <p14:section name="Apertura" id="{7badf330-8c82-931e-b6ea-c154d1688cc5}">
+        <p14:section name="Apertura" id="{ad2d5afb-f8ed-3ce6-a5aa-40f860059c4c}">
           <p14:sldIdLst>
             <p14:sldId id="256"/>
           </p14:sldIdLst>
         </p14:section>
-        <p14:section name="Metodologia" id="{ee330bf9-3fe7-0dfb-20cd-2468adbd0b7a}">
+        <p14:section name="Metodologia" id="{ddb77900-f72e-8402-9c45-4de499384ba1}">
           <p14:sldIdLst>
             <p14:sldId id="257"/>
           </p14:sldIdLst>
         </p14:section>
-        <p14:section name="Analisi funzionale" id="{8effcfb4-12e1-cb6f-337b-a39d3d85ab22}">
+        <p14:section name="Analisi funzionale" id="{00922fe4-b224-0cf0-e05d-32d6a814251d}">
           <p14:sldIdLst>
             <p14:sldId id="258"/>
             <p14:sldId id="259"/>
           </p14:sldIdLst>
         </p14:section>
-        <p14:section name="Già realtà" id="{ff607424-2aa8-e681-db0d-c62bccc430f3}">
+        <p14:section name="Già realtà" id="{e295eebb-c702-6b17-e76d-270eaa1c86d6}">
           <p14:sldIdLst>
             <p14:sldId id="260"/>
           </p14:sldIdLst>
         </p14:section>
-        <p14:section name="Architettura e ruoli" id="{deada2b8-c2c2-a923-c19a-54e7363b41b3}">
+        <p14:section name="Architettura e ruoli" id="{0bb06659-4a27-0c9f-13d5-29b0968cdb29}">
           <p14:sldIdLst>
             <p14:sldId id="261"/>
             <p14:sldId id="262"/>
           </p14:sldIdLst>
         </p14:section>
-        <p14:section name="Novità" id="{295c91df-45bb-2604-db48-ee18cbdb7b04}">
+        <p14:section name="Novità" id="{2e182f74-96d2-2099-8183-8deb2d564a14}">
           <p14:sldIdLst>
             <p14:sldId id="263"/>
           </p14:sldIdLst>
         </p14:section>
-        <p14:section name="Punti aperti" id="{547655a9-b4da-7483-8cae-df0562c11704}">
+        <p14:section name="Punti aperti" id="{2b073e29-81e8-e57d-1771-e6cfd2680291}">
           <p14:sldIdLst>
             <p14:sldId id="264"/>
             <p14:sldId id="265"/>
@@ -161,7 +161,7 @@
             <p14:sldId id="268"/>
           </p14:sldIdLst>
         </p14:section>
-        <p14:section name="Scelte da prendere" id="{9dd471d7-9fbc-7fd6-7eff-8b51722599ef}">
+        <p14:section name="Scelte da prendere" id="{bd5d5a38-1213-1843-15bf-3d8cee1a3cc7}">
           <p14:sldIdLst>
             <p14:sldId id="269"/>
           </p14:sldIdLst>
@@ -570,7 +570,7 @@
           <a:p>
             <a:r>
               <a:rPr lang="en-US" dirty="0"/>
-              <a:t>Presentazione di riepilogo del portale, aggiornata al 20 ottobre 2026 (revisione 2.6): metodologia, funzioni realizzate, novità, punti aperti di sviluppo e scelte ancora da prendere. Si rigenera a ogni rilascio insieme agli altri documenti ed è disponibile agli Amministratori nella pagina Documentazione del portale.</a:t>
+              <a:t>Presentazione di riepilogo del portale, aggiornata al 20 ottobre 2026 (revisione 2.7): metodologia, funzioni realizzate, novità, punti aperti di sviluppo e scelte ancora da prendere. Si rigenera a ogni rilascio insieme agli altri documenti ed è disponibile agli Amministratori nella pagina Documentazione del portale.</a:t>
             </a:r>
             <a:endParaRPr lang="en-US" dirty="0"/>
           </a:p>
@@ -1362,7 +1362,7 @@
           <a:p>
             <a:r>
               <a:rPr lang="en-US" dirty="0"/>
-              <a:t>Pagina «effetto sorpresa»: nessuno si aspetta che il portale sia già online. Il sistema è stato realizzato da Luca Moretti con l'ausilio di Claude Code ed è quasi terminato; i servizi sono già in produzione: GitHub (codice), Vercel (pubblicazione del portale), Supabase (database, utenti, documenti, funzioni) e Resend (email). Il portale è pubblicato su portale-cwp.vercel.app e funziona con dati di prova: si può aprire durante la presentazione (collegamento cliccabile) o inquadrare il codice QR con il telefono. La pagina pubblica /programma mostra già gli 8 documenti ufficiali del Programma, la Metodologia approvata, la PEC e il soggetto promotore. Lo sviluppo del portale vero è partito il 17 ottobre 2026: da allora sono state pubblicate 120 versioni, 33 script del database e 6 funzioni sul server. Restano i punti aperti delle prossime slide (servizi a pagamento, sicurezza, dati da inserire, collaudo con un Comune). Suggerimento: aprire il portale dal vivo con un utente di prova e mostrare la pagina pubblica.</a:t>
+              <a:t>Pagina «effetto sorpresa»: nessuno si aspetta che il portale sia già online. Il sistema è stato realizzato da Luca Moretti con l'ausilio di Claude Code ed è quasi terminato; i servizi sono già in produzione: GitHub (codice), Vercel (pubblicazione del portale), Supabase (database, utenti, documenti, funzioni) e Resend (email). Il portale è pubblicato su portale-cwp.vercel.app e funziona con dati di prova: si può aprire durante la presentazione (collegamento cliccabile) o inquadrare il codice QR con il telefono. La pagina pubblica /programma mostra già gli 8 documenti ufficiali del Programma, la Metodologia approvata, la PEC e il soggetto promotore. Lo sviluppo del portale vero è partito il 17 ottobre 2026: da allora sono state pubblicate 121 versioni, 33 script del database e 6 funzioni sul server. Restano i punti aperti delle prossime slide (servizi a pagamento, sicurezza, dati da inserire, collaudo con un Comune). Suggerimento: aprire il portale dal vivo con un utente di prova e mostrare la pagina pubblica.</a:t>
             </a:r>
             <a:endParaRPr lang="en-US" dirty="0"/>
           </a:p>
@@ -1626,7 +1626,7 @@
           <a:p>
             <a:r>
               <a:rPr lang="en-US" dirty="0"/>
-              <a:t>Novità pubblicate il 19 ottobre pomeriggio, su richiesta di Luca. Dashboard (prima «Cruscotto»): per ogni pratica una barra di 7 luci, una per fase, accese le fasi completate e spente quelle da fare, la settima verde; la fase in corso ha il contorno. Ordinamento: ogni tabella del portale si ordina per qualsiasi colonna e gli elenchi a schede hanno il menu «Ordina per». Utenti: un Amministratore può nominare altri Amministratori, tutti con accesso completo; l'Amministratore principale luca.moretti@operate.it è protetto dal database (non si declassa, non si disattiva, non si cancella, nemmeno dal pannello di Supabase); si possono eliminare solo gli utenti che non hanno mai operato (nessuna voce nell'audit e nessun dato a loro nome). Email: il nuovo utente riceve indirizzo del portale, email e password temporanea, con l'obbligo di sceglierne una personale al primo accesso; finché il dominio operate.it non è verificato su Resend le email arrivano solo al titolare dell'account. Simulatore: oltre al bilancio del Comune c'è il metodo per utenza con le sole utenze virtuose (formula 32 con buffer), lo stesso delle stime dell'Allegato A dei contratti EsaCom; il buffer si calcola dalle Tabelle 15-16. Decisione: il portale non va qualificato ACN come servizio cloud per la PA, perché serve a qualificare il modello e il Comune vi riversa dati senza acquistare un servizio; restano GDPR, dati in UE e sicurezza; da confermare con un parere legale. Il 20 ottobre: sezione «Audit User» per l'Amministratore principale, con tutti gli utenti online o no, il registro degli accessi (entrate, uscite, tentativi non riusciti, senza indirizzi IP) e le operazioni dell'audit trail per utente, compreso lo scaricamento dei documenti; utenti online per l'Amministratore principale (chi è collegato adesso, pagina aperta, da quanto, e chi è stato visto nelle ultime 24 ore; si conserva solo l'ultimo collegamento, gli utenti ne sono informati nel Manuale Utente); messaggi d'errore dell'assistente in italiano semplice, con la causa per gli Amministratori; simulatore con PDF impaginato in A4 orizzontale ed export Excel con i fogli Sintesi, Anni, Economia e Costi.</a:t>
+              <a:t>Novità pubblicate il 19 ottobre pomeriggio, su richiesta di Luca. Dashboard (prima «Cruscotto»): per ogni pratica una barra di 7 luci, una per fase, accese le fasi completate e spente quelle da fare, la settima verde; la fase in corso ha il contorno. Ordinamento: ogni tabella del portale si ordina per qualsiasi colonna e gli elenchi a schede hanno il menu «Ordina per». Utenti: un Amministratore può nominare altri Amministratori, tutti con accesso completo; l'Amministratore principale luca.moretti@operate.it è protetto dal database (non si declassa, non si disattiva, non si cancella, nemmeno dal pannello di Supabase); si possono eliminare solo gli utenti che non hanno mai operato (nessuna voce nell'audit e nessun dato a loro nome). Email: il nuovo utente riceve indirizzo del portale, email e password temporanea, con l'obbligo di sceglierne una personale al primo accesso; finché il dominio operate.it non è verificato su Resend le email arrivano solo al titolare dell'account. Simulatore: oltre al bilancio del Comune c'è il metodo per utenza con le sole utenze virtuose (formula 32 con buffer), lo stesso delle stime dell'Allegato A dei contratti EsaCom; il buffer si calcola dalle Tabelle 15-16. Decisione: il portale non va qualificato ACN come servizio cloud per la PA, perché serve a qualificare il modello e il Comune vi riversa dati senza acquistare un servizio; restano GDPR, dati in UE e sicurezza; da confermare con un parere legale. Il 20 ottobre: sezione «Audit User» per l'Amministratore principale, con tutti gli utenti online o no, il registro degli accessi (entrate, uscite, tentativi non riusciti, senza indirizzi IP) e le operazioni dell'audit trail per utente, compreso lo scaricamento dei documenti; utenti online per l'Amministratore principale (chi è collegato adesso, pagina aperta, da quanto, e chi è stato visto nelle ultime 24 ore; si conserva solo l'ultimo collegamento, gli utenti ne sono informati nel Manuale Utente); messaggi d'errore dell'assistente in italiano semplice, con la causa per gli Amministratori; simulatore con PDF impaginato in A4 orizzontale ed export Excel con i fogli Sintesi, Anni, Economia e Costi. Menu riordinati da Luca il 20/10: Amministratori Dashboard, Anagrafiche, Simulatore, Pratiche, Reclami, Calcolo crediti, Crediti emessi, Impostazioni, Utenti, Audit, Audit User (solo il principale), Documentazione; enti Le mie pratiche, I tuoi documenti, Reclami, Formato dati, Il Programma CWP, Manuali; per entrambi la voce Marketplaces in grigio, sezione in arrivo da definire.</a:t>
             </a:r>
             <a:endParaRPr lang="en-US" dirty="0"/>
           </a:p>
@@ -2073,7 +2073,7 @@
                   <a:schemeClr val="accent6"/>
                 </a:solidFill>
               </a:rPr>
-              <a:t>Portale Carbon WastePrint · Stato dei lavori e recap · 20 ottobre 2026 · rev. 2.6</a:t>
+              <a:t>Portale Carbon WastePrint · Stato dei lavori e recap · 20 ottobre 2026 · rev. 2.7</a:t>
             </a:r>
             <a:endParaRPr lang="en-US" sz="1000" dirty="0"/>
           </a:p>
@@ -2571,7 +2571,7 @@
                   <a:schemeClr val="accent3"/>
                 </a:solidFill>
               </a:rPr>
-              <a:t>Stato dei lavori e recap: metodologia, funzioni, novità, punti aperti e scelte da prendere · aggiornata al 20 ottobre 2026 · rev. 2.6</a:t>
+              <a:t>Stato dei lavori e recap: metodologia, funzioni, novità, punti aperti e scelte da prendere · aggiornata al 20 ottobre 2026 · rev. 2.7</a:t>
             </a:r>
             <a:endParaRPr lang="en-US" sz="1800" dirty="0"/>
           </a:p>
@@ -14022,7 +14022,7 @@
                 <a:ea typeface="Cambria" pitchFamily="34" charset="-122"/>
                 <a:cs typeface="Cambria" pitchFamily="34" charset="-120"/>
               </a:rPr>
-              <a:t>120</a:t>
+              <a:t>121</a:t>
             </a:r>
             <a:endParaRPr lang="en-US" sz="2400" dirty="0"/>
           </a:p>
@@ -17574,7 +17574,7 @@
                   <a:schemeClr val="tx2"/>
                 </a:solidFill>
               </a:rPr>
-              <a:t>Documentazione</a:t>
+              <a:t>Menu e documenti</a:t>
             </a:r>
             <a:endParaRPr lang="en-US" sz="1350" dirty="0"/>
           </a:p>
@@ -17591,7 +17591,7 @@
                   <a:schemeClr val="tx1"/>
                 </a:solidFill>
               </a:rPr>
-              <a:t>gli 8 documenti ufficiali del Programma v1.2 e questa presentazione, per gli Amministratori</a:t>
+              <a:t>menu riordinati per ruolo, «Marketplaces» in arrivo; 8 documenti ufficiali v1.2 e questa presentazione per gli Amministratori</a:t>
             </a:r>
             <a:endParaRPr lang="en-US" sz="1350" dirty="0"/>
           </a:p>

</xml_diff>

<commit_message>
Sicurezza: Content-Security-Policy obbligatoria; documenti aggiornati (Registro 5.0, Manuale Utente 3.2, Amministratore 4.2 con capitolo Sicurezza, Test 3.8, Ripristino 1.5, Presentazione 2.8, base di conoscenza)
Co-Authored-By: Claude Opus 5.5 <noreply@anthropic.com>
Claude-Session: https://claude.ai/code/session_01E8XCbEeVHWVP3hntUZ6kZ1
</commit_message>
<xml_diff>
--- a/public/documentazione/Presentazione_Portale_CWP.pptx
+++ b/public/documentazione/Presentazione_Portale_CWP.pptx
@@ -120,39 +120,39 @@
   <p:extLst>
     <p:ext uri="{521415D9-36F7-43E2-AB2F-B90AF26B5E84}">
       <p14:sectionLst xmlns:p14="http://schemas.microsoft.com/office/powerpoint/2010/main">
-        <p14:section name="Apertura" id="{ad2d5afb-f8ed-3ce6-a5aa-40f860059c4c}">
+        <p14:section name="Apertura" id="{88254153-624b-6dd5-9050-9b26aec9a4fc}">
           <p14:sldIdLst>
             <p14:sldId id="256"/>
           </p14:sldIdLst>
         </p14:section>
-        <p14:section name="Metodologia" id="{ddb77900-f72e-8402-9c45-4de499384ba1}">
+        <p14:section name="Metodologia" id="{f125ed4a-ee58-21e0-ece2-9e5403fbb52b}">
           <p14:sldIdLst>
             <p14:sldId id="257"/>
           </p14:sldIdLst>
         </p14:section>
-        <p14:section name="Analisi funzionale" id="{00922fe4-b224-0cf0-e05d-32d6a814251d}">
+        <p14:section name="Analisi funzionale" id="{c83395c9-64d0-9d18-6c54-c1f6a049e5b8}">
           <p14:sldIdLst>
             <p14:sldId id="258"/>
             <p14:sldId id="259"/>
           </p14:sldIdLst>
         </p14:section>
-        <p14:section name="Già realtà" id="{e295eebb-c702-6b17-e76d-270eaa1c86d6}">
+        <p14:section name="Già realtà" id="{0d8ece12-01b9-8d9c-2a94-04da554c68c7}">
           <p14:sldIdLst>
             <p14:sldId id="260"/>
           </p14:sldIdLst>
         </p14:section>
-        <p14:section name="Architettura e ruoli" id="{0bb06659-4a27-0c9f-13d5-29b0968cdb29}">
+        <p14:section name="Architettura e ruoli" id="{d3ac0727-ef34-b629-21f0-84233058cb3f}">
           <p14:sldIdLst>
             <p14:sldId id="261"/>
             <p14:sldId id="262"/>
           </p14:sldIdLst>
         </p14:section>
-        <p14:section name="Novità" id="{2e182f74-96d2-2099-8183-8deb2d564a14}">
+        <p14:section name="Novità" id="{c87d1bcf-1c12-3be8-b7f8-fee18b377f8d}">
           <p14:sldIdLst>
             <p14:sldId id="263"/>
           </p14:sldIdLst>
         </p14:section>
-        <p14:section name="Punti aperti" id="{2b073e29-81e8-e57d-1771-e6cfd2680291}">
+        <p14:section name="Punti aperti" id="{041e1814-a862-34e8-698a-a6dfb7987d48}">
           <p14:sldIdLst>
             <p14:sldId id="264"/>
             <p14:sldId id="265"/>
@@ -161,7 +161,7 @@
             <p14:sldId id="268"/>
           </p14:sldIdLst>
         </p14:section>
-        <p14:section name="Scelte da prendere" id="{bd5d5a38-1213-1843-15bf-3d8cee1a3cc7}">
+        <p14:section name="Scelte da prendere" id="{9ebeba5e-36ed-6eaa-3399-280f2f217a99}">
           <p14:sldIdLst>
             <p14:sldId id="269"/>
           </p14:sldIdLst>
@@ -570,7 +570,7 @@
           <a:p>
             <a:r>
               <a:rPr lang="en-US" dirty="0"/>
-              <a:t>Presentazione di riepilogo del portale, aggiornata al 20 ottobre 2026 (revisione 2.7): metodologia, funzioni realizzate, novità, punti aperti di sviluppo e scelte ancora da prendere. Si rigenera a ogni rilascio insieme agli altri documenti ed è disponibile agli Amministratori nella pagina Documentazione del portale.</a:t>
+              <a:t>Presentazione di riepilogo del portale, aggiornata al 20 ottobre 2026 (revisione 2.8): metodologia, funzioni realizzate, novità, punti aperti di sviluppo e scelte ancora da prendere. Si rigenera a ogni rilascio insieme agli altri documenti ed è disponibile agli Amministratori nella pagina Documentazione del portale.</a:t>
             </a:r>
             <a:endParaRPr lang="en-US" dirty="0"/>
           </a:p>
@@ -1362,7 +1362,7 @@
           <a:p>
             <a:r>
               <a:rPr lang="en-US" dirty="0"/>
-              <a:t>Pagina «effetto sorpresa»: nessuno si aspetta che il portale sia già online. Il sistema è stato realizzato da Luca Moretti con l'ausilio di Claude Code ed è quasi terminato; i servizi sono già in produzione: GitHub (codice), Vercel (pubblicazione del portale), Supabase (database, utenti, documenti, funzioni) e Resend (email). Il portale è pubblicato su portale-cwp.vercel.app e funziona con dati di prova: si può aprire durante la presentazione (collegamento cliccabile) o inquadrare il codice QR con il telefono. La pagina pubblica /programma mostra già gli 8 documenti ufficiali del Programma, la Metodologia approvata, la PEC e il soggetto promotore. Lo sviluppo del portale vero è partito il 17 ottobre 2026: da allora sono state pubblicate 121 versioni, 33 script del database e 6 funzioni sul server. Restano i punti aperti delle prossime slide (servizi a pagamento, sicurezza, dati da inserire, collaudo con un Comune). Suggerimento: aprire il portale dal vivo con un utente di prova e mostrare la pagina pubblica.</a:t>
+              <a:t>Pagina «effetto sorpresa»: nessuno si aspetta che il portale sia già online. Il sistema è stato realizzato da Luca Moretti con l'ausilio di Claude Code ed è quasi terminato; i servizi sono già in produzione: GitHub (codice), Vercel (pubblicazione del portale), Supabase (database, utenti, documenti, funzioni) e Resend (email). Il portale è pubblicato su portale-cwp.vercel.app e funziona con dati di prova: si può aprire durante la presentazione (collegamento cliccabile) o inquadrare il codice QR con il telefono. La pagina pubblica /programma mostra già gli 8 documenti ufficiali del Programma, la Metodologia approvata, la PEC e il soggetto promotore. Lo sviluppo del portale vero è partito il 17 ottobre 2026: da allora sono state pubblicate 123 versioni, 34 script del database e 6 funzioni sul server. Restano i punti aperti delle prossime slide (servizi a pagamento, sicurezza, dati da inserire, collaudo con un Comune). Suggerimento: aprire il portale dal vivo con un utente di prova e mostrare la pagina pubblica.</a:t>
             </a:r>
             <a:endParaRPr lang="en-US" dirty="0"/>
           </a:p>
@@ -2073,7 +2073,7 @@
                   <a:schemeClr val="accent6"/>
                 </a:solidFill>
               </a:rPr>
-              <a:t>Portale Carbon WastePrint · Stato dei lavori e recap · 20 ottobre 2026 · rev. 2.7</a:t>
+              <a:t>Portale Carbon WastePrint · Stato dei lavori e recap · 20 ottobre 2026 · rev. 2.8</a:t>
             </a:r>
             <a:endParaRPr lang="en-US" sz="1000" dirty="0"/>
           </a:p>
@@ -2571,7 +2571,7 @@
                   <a:schemeClr val="accent3"/>
                 </a:solidFill>
               </a:rPr>
-              <a:t>Stato dei lavori e recap: metodologia, funzioni, novità, punti aperti e scelte da prendere · aggiornata al 20 ottobre 2026 · rev. 2.7</a:t>
+              <a:t>Stato dei lavori e recap: metodologia, funzioni, novità, punti aperti e scelte da prendere · aggiornata al 20 ottobre 2026 · rev. 2.8</a:t>
             </a:r>
             <a:endParaRPr lang="en-US" sz="1800" dirty="0"/>
           </a:p>
@@ -12929,7 +12929,7 @@
                 <a:ea typeface="Cambria" pitchFamily="34" charset="-122"/>
                 <a:cs typeface="Cambria" pitchFamily="34" charset="-120"/>
               </a:rPr>
-              <a:t>33</a:t>
+              <a:t>34</a:t>
             </a:r>
             <a:endParaRPr lang="en-US" sz="3000" dirty="0"/>
           </a:p>
@@ -13235,7 +13235,7 @@
                 <a:ea typeface="Cambria" pitchFamily="34" charset="-122"/>
                 <a:cs typeface="Cambria" pitchFamily="34" charset="-120"/>
               </a:rPr>
-              <a:t>≈31.900</a:t>
+              <a:t>≈32.300</a:t>
             </a:r>
             <a:endParaRPr lang="en-US" sz="3000" dirty="0"/>
           </a:p>
@@ -14022,7 +14022,7 @@
                 <a:ea typeface="Cambria" pitchFamily="34" charset="-122"/>
                 <a:cs typeface="Cambria" pitchFamily="34" charset="-120"/>
               </a:rPr>
-              <a:t>121</a:t>
+              <a:t>123</a:t>
             </a:r>
             <a:endParaRPr lang="en-US" sz="2400" dirty="0"/>
           </a:p>
@@ -14075,7 +14075,7 @@
                 <a:ea typeface="Cambria" pitchFamily="34" charset="-122"/>
                 <a:cs typeface="Cambria" pitchFamily="34" charset="-120"/>
               </a:rPr>
-              <a:t>33</a:t>
+              <a:t>34</a:t>
             </a:r>
             <a:endParaRPr lang="en-US" sz="2400" dirty="0"/>
           </a:p>
@@ -14181,7 +14181,7 @@
                 <a:ea typeface="Cambria" pitchFamily="34" charset="-122"/>
                 <a:cs typeface="Cambria" pitchFamily="34" charset="-120"/>
               </a:rPr>
-              <a:t>≈31.900</a:t>
+              <a:t>≈32.300</a:t>
             </a:r>
             <a:endParaRPr lang="en-US" sz="2400" dirty="0"/>
           </a:p>
@@ -17888,7 +17888,7 @@
                   <a:schemeClr val="tx1"/>
                 </a:solidFill>
               </a:rPr>
-              <a:t>Registro di sicurezza: accessi, tentativi falliti, cambi di permessi</a:t>
+              <a:t>Fatto il 20/10: registro degli accessi e avvisi di sicurezza, uscita per inattività, intestazioni del sito, librerie aggiornate (0 vulnerabilità)</a:t>
             </a:r>
             <a:endParaRPr lang="en-US" sz="1350" dirty="0"/>
           </a:p>
@@ -17906,7 +17906,7 @@
                   <a:schemeClr val="tx1"/>
                 </a:solidFill>
               </a:rPr>
-              <a:t>Verifica in due passaggi per lo staff (pronta, spenta) e scadenza delle sessioni</a:t>
+              <a:t>Verifica in due passaggi per lo staff (pronta, spenta); CAPTCHA sulle pagine pubbliche</a:t>
             </a:r>
             <a:endParaRPr lang="en-US" sz="1350" dirty="0"/>
           </a:p>
@@ -17924,7 +17924,7 @@
                   <a:schemeClr val="tx1"/>
                 </a:solidFill>
               </a:rPr>
-              <a:t>Antivirus sui file; verifica OWASP, test di intrusione, librerie aggiornate</a:t>
+              <a:t>Antivirus sui file; verifica OWASP, test di intrusione a fine sviluppo</a:t>
             </a:r>
             <a:endParaRPr lang="en-US" sz="1350" dirty="0"/>
           </a:p>
@@ -18408,7 +18408,7 @@
                   <a:schemeClr val="tx1"/>
                 </a:solidFill>
               </a:rPr>
-              <a:t>Nuovi moduli: simulatore (online, due metodi), assistente virtuale (attivo dal 19/10; poi messaggi d'errore in italiano, Operatori e aiuto sulla pratica); utenti online per l'amministratore principale (in sviluppo)</a:t>
+              <a:t>Nuovi moduli: simulatore con PDF ed Excel, assistente virtuale (poi Operatori e aiuto sulla pratica), Audit User e utenti online (fatti il 20/10); Marketplaces da definire</a:t>
             </a:r>
             <a:endParaRPr lang="en-US" sz="1350" dirty="0"/>
           </a:p>

</xml_diff>

<commit_message>
Documentazione aggiornata dopo il collaudo V05: manuali, Registro, ripristino (script 01-35), presentazione 2.9, base di conoscenza
Co-Authored-By: Claude Opus 5.5 <noreply@anthropic.com>
Claude-Session: https://claude.ai/code/session_01E8XCbEeVHWVP3hntUZ6kZ1
</commit_message>
<xml_diff>
--- a/public/documentazione/Presentazione_Portale_CWP.pptx
+++ b/public/documentazione/Presentazione_Portale_CWP.pptx
@@ -120,39 +120,39 @@
   <p:extLst>
     <p:ext uri="{521415D9-36F7-43E2-AB2F-B90AF26B5E84}">
       <p14:sectionLst xmlns:p14="http://schemas.microsoft.com/office/powerpoint/2010/main">
-        <p14:section name="Apertura" id="{88254153-624b-6dd5-9050-9b26aec9a4fc}">
+        <p14:section name="Apertura" id="{08b5b8a3-577e-4694-29e7-d68217e0397e}">
           <p14:sldIdLst>
             <p14:sldId id="256"/>
           </p14:sldIdLst>
         </p14:section>
-        <p14:section name="Metodologia" id="{f125ed4a-ee58-21e0-ece2-9e5403fbb52b}">
+        <p14:section name="Metodologia" id="{71dd3b6a-d988-f802-58f8-780ca9a6d8a0}">
           <p14:sldIdLst>
             <p14:sldId id="257"/>
           </p14:sldIdLst>
         </p14:section>
-        <p14:section name="Analisi funzionale" id="{c83395c9-64d0-9d18-6c54-c1f6a049e5b8}">
+        <p14:section name="Analisi funzionale" id="{de280729-42a7-46eb-1e90-66910664146d}">
           <p14:sldIdLst>
             <p14:sldId id="258"/>
             <p14:sldId id="259"/>
           </p14:sldIdLst>
         </p14:section>
-        <p14:section name="Già realtà" id="{0d8ece12-01b9-8d9c-2a94-04da554c68c7}">
+        <p14:section name="Già realtà" id="{8faed5e3-c08c-f923-8f36-2040ea1e071e}">
           <p14:sldIdLst>
             <p14:sldId id="260"/>
           </p14:sldIdLst>
         </p14:section>
-        <p14:section name="Architettura e ruoli" id="{d3ac0727-ef34-b629-21f0-84233058cb3f}">
+        <p14:section name="Architettura e ruoli" id="{1792b304-afff-8fd4-d50c-751f2da792c1}">
           <p14:sldIdLst>
             <p14:sldId id="261"/>
             <p14:sldId id="262"/>
           </p14:sldIdLst>
         </p14:section>
-        <p14:section name="Novità" id="{c87d1bcf-1c12-3be8-b7f8-fee18b377f8d}">
+        <p14:section name="Novità" id="{70933325-4b36-24bc-0999-c50e391f4f37}">
           <p14:sldIdLst>
             <p14:sldId id="263"/>
           </p14:sldIdLst>
         </p14:section>
-        <p14:section name="Punti aperti" id="{041e1814-a862-34e8-698a-a6dfb7987d48}">
+        <p14:section name="Punti aperti" id="{b3562030-f347-b82b-6483-8bce1791db54}">
           <p14:sldIdLst>
             <p14:sldId id="264"/>
             <p14:sldId id="265"/>
@@ -161,7 +161,7 @@
             <p14:sldId id="268"/>
           </p14:sldIdLst>
         </p14:section>
-        <p14:section name="Scelte da prendere" id="{9ebeba5e-36ed-6eaa-3399-280f2f217a99}">
+        <p14:section name="Scelte da prendere" id="{5c501d7a-bb8c-dc65-eda5-e591f2e31d50}">
           <p14:sldIdLst>
             <p14:sldId id="269"/>
           </p14:sldIdLst>
@@ -570,7 +570,7 @@
           <a:p>
             <a:r>
               <a:rPr lang="en-US" dirty="0"/>
-              <a:t>Presentazione di riepilogo del portale, aggiornata al 20 ottobre 2026 (revisione 2.8): metodologia, funzioni realizzate, novità, punti aperti di sviluppo e scelte ancora da prendere. Si rigenera a ogni rilascio insieme agli altri documenti ed è disponibile agli Amministratori nella pagina Documentazione del portale.</a:t>
+              <a:t>Presentazione di riepilogo del portale, aggiornata al 21 ottobre 2026 (revisione 2.9): metodologia, funzioni realizzate, novità, punti aperti di sviluppo e scelte ancora da prendere. Si rigenera a ogni rilascio insieme agli altri documenti ed è disponibile agli Amministratori nella pagina Documentazione del portale.</a:t>
             </a:r>
             <a:endParaRPr lang="en-US" dirty="0"/>
           </a:p>
@@ -1362,7 +1362,7 @@
           <a:p>
             <a:r>
               <a:rPr lang="en-US" dirty="0"/>
-              <a:t>Pagina «effetto sorpresa»: nessuno si aspetta che il portale sia già online. Il sistema è stato realizzato da Luca Moretti con l'ausilio di Claude Code ed è quasi terminato; i servizi sono già in produzione: GitHub (codice), Vercel (pubblicazione del portale), Supabase (database, utenti, documenti, funzioni) e Resend (email). Il portale è pubblicato su portale-cwp.vercel.app e funziona con dati di prova: si può aprire durante la presentazione (collegamento cliccabile) o inquadrare il codice QR con il telefono. La pagina pubblica /programma mostra già gli 8 documenti ufficiali del Programma, la Metodologia approvata, la PEC e il soggetto promotore. Lo sviluppo del portale vero è partito il 17 ottobre 2026: da allora sono state pubblicate 123 versioni, 34 script del database e 6 funzioni sul server. Restano i punti aperti delle prossime slide (servizi a pagamento, sicurezza, dati da inserire, collaudo con un Comune). Suggerimento: aprire il portale dal vivo con un utente di prova e mostrare la pagina pubblica.</a:t>
+              <a:t>Pagina «effetto sorpresa»: nessuno si aspetta che il portale sia già online. Il sistema è stato realizzato da Luca Moretti con l'ausilio di Claude Code ed è quasi terminato; i servizi sono già in produzione: GitHub (codice), Vercel (pubblicazione del portale), Supabase (database, utenti, documenti, funzioni) e Resend (email). Il portale è pubblicato su portale-cwp.vercel.app e funziona con dati di prova: si può aprire durante la presentazione (collegamento cliccabile) o inquadrare il codice QR con il telefono. La pagina pubblica /programma mostra già gli 8 documenti ufficiali del Programma, la Metodologia approvata, la PEC e il soggetto promotore. Lo sviluppo del portale vero è partito il 17 ottobre 2026: da allora sono state pubblicate 130 versioni, 35 script del database e 6 funzioni sul server. Restano i punti aperti delle prossime slide (servizi a pagamento, sicurezza, dati da inserire, collaudo con un Comune). Suggerimento: aprire il portale dal vivo con un utente di prova e mostrare la pagina pubblica.</a:t>
             </a:r>
             <a:endParaRPr lang="en-US" dirty="0"/>
           </a:p>
@@ -2073,7 +2073,7 @@
                   <a:schemeClr val="accent6"/>
                 </a:solidFill>
               </a:rPr>
-              <a:t>Portale Carbon WastePrint · Stato dei lavori e recap · 20 ottobre 2026 · rev. 2.8</a:t>
+              <a:t>Portale Carbon WastePrint · Stato dei lavori e recap · 21 ottobre 2026 · rev. 2.9</a:t>
             </a:r>
             <a:endParaRPr lang="en-US" sz="1000" dirty="0"/>
           </a:p>
@@ -2571,7 +2571,7 @@
                   <a:schemeClr val="accent3"/>
                 </a:solidFill>
               </a:rPr>
-              <a:t>Stato dei lavori e recap: metodologia, funzioni, novità, punti aperti e scelte da prendere · aggiornata al 20 ottobre 2026 · rev. 2.8</a:t>
+              <a:t>Stato dei lavori e recap: metodologia, funzioni, novità, punti aperti e scelte da prendere · aggiornata al 21 ottobre 2026 · rev. 2.9</a:t>
             </a:r>
             <a:endParaRPr lang="en-US" sz="1800" dirty="0"/>
           </a:p>
@@ -12929,7 +12929,7 @@
                 <a:ea typeface="Cambria" pitchFamily="34" charset="-122"/>
                 <a:cs typeface="Cambria" pitchFamily="34" charset="-120"/>
               </a:rPr>
-              <a:t>34</a:t>
+              <a:t>35</a:t>
             </a:r>
             <a:endParaRPr lang="en-US" sz="3000" dirty="0"/>
           </a:p>
@@ -13235,7 +13235,7 @@
                 <a:ea typeface="Cambria" pitchFamily="34" charset="-122"/>
                 <a:cs typeface="Cambria" pitchFamily="34" charset="-120"/>
               </a:rPr>
-              <a:t>≈32.300</a:t>
+              <a:t>≈33.700</a:t>
             </a:r>
             <a:endParaRPr lang="en-US" sz="3000" dirty="0"/>
           </a:p>
@@ -14022,7 +14022,7 @@
                 <a:ea typeface="Cambria" pitchFamily="34" charset="-122"/>
                 <a:cs typeface="Cambria" pitchFamily="34" charset="-120"/>
               </a:rPr>
-              <a:t>123</a:t>
+              <a:t>130</a:t>
             </a:r>
             <a:endParaRPr lang="en-US" sz="2400" dirty="0"/>
           </a:p>
@@ -14075,7 +14075,7 @@
                 <a:ea typeface="Cambria" pitchFamily="34" charset="-122"/>
                 <a:cs typeface="Cambria" pitchFamily="34" charset="-120"/>
               </a:rPr>
-              <a:t>34</a:t>
+              <a:t>35</a:t>
             </a:r>
             <a:endParaRPr lang="en-US" sz="2400" dirty="0"/>
           </a:p>
@@ -14181,7 +14181,7 @@
                 <a:ea typeface="Cambria" pitchFamily="34" charset="-122"/>
                 <a:cs typeface="Cambria" pitchFamily="34" charset="-120"/>
               </a:rPr>
-              <a:t>≈32.300</a:t>
+              <a:t>≈33.700</a:t>
             </a:r>
             <a:endParaRPr lang="en-US" sz="2400" dirty="0"/>
           </a:p>
@@ -18184,7 +18184,7 @@
                   <a:schemeClr val="tx1"/>
                 </a:solidFill>
               </a:rPr>
-              <a:t>Collaudo completo delle nuove funzioni (crediti emessi, reclami, tariffe)</a:t>
+              <a:t>Collaudo in corso con 5 Amministratori: correzioni dei rapporti V01 e V05 in produzione il 20-21/10; restano le regole metodologiche da confermare</a:t>
             </a:r>
             <a:endParaRPr lang="en-US" sz="1350" dirty="0"/>
           </a:p>

</xml_diff>

<commit_message>
Backup automatico su Google Drive (Apps Script, 13 e 21) e strumenti di ripristino provati; R08 nei documenti; Ripristino 1.7, Registro 5.5, Registro issue 1.1, presentazione 3.0
Co-Authored-By: Claude Opus 5.5 <noreply@anthropic.com>
Claude-Session: https://claude.ai/code/session_01E8XCbEeVHWVP3hntUZ6kZ1
</commit_message>
<xml_diff>
--- a/public/documentazione/Presentazione_Portale_CWP.pptx
+++ b/public/documentazione/Presentazione_Portale_CWP.pptx
@@ -120,39 +120,39 @@
   <p:extLst>
     <p:ext uri="{521415D9-36F7-43E2-AB2F-B90AF26B5E84}">
       <p14:sectionLst xmlns:p14="http://schemas.microsoft.com/office/powerpoint/2010/main">
-        <p14:section name="Apertura" id="{08b5b8a3-577e-4694-29e7-d68217e0397e}">
+        <p14:section name="Apertura" id="{6202eb85-d8c3-ce69-b2e5-3f289672d84f}">
           <p14:sldIdLst>
             <p14:sldId id="256"/>
           </p14:sldIdLst>
         </p14:section>
-        <p14:section name="Metodologia" id="{71dd3b6a-d988-f802-58f8-780ca9a6d8a0}">
+        <p14:section name="Metodologia" id="{bd24c1bc-173b-a2e8-ffde-fb8cae318fa9}">
           <p14:sldIdLst>
             <p14:sldId id="257"/>
           </p14:sldIdLst>
         </p14:section>
-        <p14:section name="Analisi funzionale" id="{de280729-42a7-46eb-1e90-66910664146d}">
+        <p14:section name="Analisi funzionale" id="{df2e04a7-02ec-d846-ef84-9fc4154153e7}">
           <p14:sldIdLst>
             <p14:sldId id="258"/>
             <p14:sldId id="259"/>
           </p14:sldIdLst>
         </p14:section>
-        <p14:section name="Già realtà" id="{8faed5e3-c08c-f923-8f36-2040ea1e071e}">
+        <p14:section name="Già realtà" id="{2ae0751a-399c-447a-89ca-5155b5341819}">
           <p14:sldIdLst>
             <p14:sldId id="260"/>
           </p14:sldIdLst>
         </p14:section>
-        <p14:section name="Architettura e ruoli" id="{1792b304-afff-8fd4-d50c-751f2da792c1}">
+        <p14:section name="Architettura e ruoli" id="{9d864373-5df9-aab3-d0c4-6f5bbd212da5}">
           <p14:sldIdLst>
             <p14:sldId id="261"/>
             <p14:sldId id="262"/>
           </p14:sldIdLst>
         </p14:section>
-        <p14:section name="Novità" id="{70933325-4b36-24bc-0999-c50e391f4f37}">
+        <p14:section name="Novità" id="{2f75082e-3656-a624-a4fa-eed0fb408a26}">
           <p14:sldIdLst>
             <p14:sldId id="263"/>
           </p14:sldIdLst>
         </p14:section>
-        <p14:section name="Punti aperti" id="{b3562030-f347-b82b-6483-8bce1791db54}">
+        <p14:section name="Punti aperti" id="{b417c3ce-90b3-5746-dc07-2b3b12952897}">
           <p14:sldIdLst>
             <p14:sldId id="264"/>
             <p14:sldId id="265"/>
@@ -161,7 +161,7 @@
             <p14:sldId id="268"/>
           </p14:sldIdLst>
         </p14:section>
-        <p14:section name="Scelte da prendere" id="{5c501d7a-bb8c-dc65-eda5-e591f2e31d50}">
+        <p14:section name="Scelte da prendere" id="{7ec79774-36da-2bd9-db7a-2d095fa8c686}">
           <p14:sldIdLst>
             <p14:sldId id="269"/>
           </p14:sldIdLst>
@@ -570,7 +570,7 @@
           <a:p>
             <a:r>
               <a:rPr lang="en-US" dirty="0"/>
-              <a:t>Presentazione di riepilogo del portale, aggiornata al 21 ottobre 2026 (revisione 2.9): metodologia, funzioni realizzate, novità, punti aperti di sviluppo e scelte ancora da prendere. Si rigenera a ogni rilascio insieme agli altri documenti ed è disponibile agli Amministratori nella pagina Documentazione del portale.</a:t>
+              <a:t>Presentazione di riepilogo del portale, aggiornata al 21 ottobre 2026 (revisione 3.0): metodologia, funzioni realizzate, novità, punti aperti di sviluppo e scelte ancora da prendere. Si rigenera a ogni rilascio insieme agli altri documenti ed è disponibile agli Amministratori nella pagina Documentazione del portale.</a:t>
             </a:r>
             <a:endParaRPr lang="en-US" dirty="0"/>
           </a:p>
@@ -1362,7 +1362,7 @@
           <a:p>
             <a:r>
               <a:rPr lang="en-US" dirty="0"/>
-              <a:t>Pagina «effetto sorpresa»: nessuno si aspetta che il portale sia già online. Il sistema è stato realizzato da Luca Moretti con l'ausilio di Claude Code ed è quasi terminato; i servizi sono già in produzione: GitHub (codice), Vercel (pubblicazione del portale), Supabase (database, utenti, documenti, funzioni) e Resend (email). Il portale è pubblicato su portale-cwp.vercel.app e funziona con dati di prova: si può aprire durante la presentazione (collegamento cliccabile) o inquadrare il codice QR con il telefono. La pagina pubblica /programma mostra già gli 8 documenti ufficiali del Programma, la Metodologia approvata, la PEC e il soggetto promotore. Lo sviluppo del portale vero è partito il 17 ottobre 2026: da allora sono state pubblicate 130 versioni, 35 script del database e 6 funzioni sul server. Restano i punti aperti delle prossime slide (servizi a pagamento, sicurezza, dati da inserire, collaudo con un Comune). Suggerimento: aprire il portale dal vivo con un utente di prova e mostrare la pagina pubblica.</a:t>
+              <a:t>Pagina «effetto sorpresa»: nessuno si aspetta che il portale sia già online. Il sistema è stato realizzato da Luca Moretti con l'ausilio di Claude Code ed è quasi terminato; i servizi sono già in produzione: GitHub (codice), Vercel (pubblicazione del portale), Supabase (database, utenti, documenti, funzioni) e Resend (email). Il portale è pubblicato su portale-cwp.vercel.app e funziona con dati di prova: si può aprire durante la presentazione (collegamento cliccabile) o inquadrare il codice QR con il telefono. La pagina pubblica /programma mostra già gli 8 documenti ufficiali del Programma, la Metodologia approvata, la PEC e il soggetto promotore. Lo sviluppo del portale vero è partito il 17 ottobre 2026: da allora sono state pubblicate 133 versioni, 35 script del database e 6 funzioni sul server. Restano i punti aperti delle prossime slide (servizi a pagamento, sicurezza, dati da inserire, collaudo con un Comune). Suggerimento: aprire il portale dal vivo con un utente di prova e mostrare la pagina pubblica.</a:t>
             </a:r>
             <a:endParaRPr lang="en-US" dirty="0"/>
           </a:p>
@@ -2073,7 +2073,7 @@
                   <a:schemeClr val="accent6"/>
                 </a:solidFill>
               </a:rPr>
-              <a:t>Portale Carbon WastePrint · Stato dei lavori e recap · 21 ottobre 2026 · rev. 2.9</a:t>
+              <a:t>Portale Carbon WastePrint · Stato dei lavori e recap · 21 ottobre 2026 · rev. 3.0</a:t>
             </a:r>
             <a:endParaRPr lang="en-US" sz="1000" dirty="0"/>
           </a:p>
@@ -2571,7 +2571,7 @@
                   <a:schemeClr val="accent3"/>
                 </a:solidFill>
               </a:rPr>
-              <a:t>Stato dei lavori e recap: metodologia, funzioni, novità, punti aperti e scelte da prendere · aggiornata al 21 ottobre 2026 · rev. 2.9</a:t>
+              <a:t>Stato dei lavori e recap: metodologia, funzioni, novità, punti aperti e scelte da prendere · aggiornata al 21 ottobre 2026 · rev. 3.0</a:t>
             </a:r>
             <a:endParaRPr lang="en-US" sz="1800" dirty="0"/>
           </a:p>
@@ -13235,7 +13235,7 @@
                 <a:ea typeface="Cambria" pitchFamily="34" charset="-122"/>
                 <a:cs typeface="Cambria" pitchFamily="34" charset="-120"/>
               </a:rPr>
-              <a:t>≈33.700</a:t>
+              <a:t>≈33.900</a:t>
             </a:r>
             <a:endParaRPr lang="en-US" sz="3000" dirty="0"/>
           </a:p>
@@ -14022,7 +14022,7 @@
                 <a:ea typeface="Cambria" pitchFamily="34" charset="-122"/>
                 <a:cs typeface="Cambria" pitchFamily="34" charset="-120"/>
               </a:rPr>
-              <a:t>130</a:t>
+              <a:t>133</a:t>
             </a:r>
             <a:endParaRPr lang="en-US" sz="2400" dirty="0"/>
           </a:p>
@@ -14181,7 +14181,7 @@
                 <a:ea typeface="Cambria" pitchFamily="34" charset="-122"/>
                 <a:cs typeface="Cambria" pitchFamily="34" charset="-120"/>
               </a:rPr>
-              <a:t>≈33.700</a:t>
+              <a:t>≈33.900</a:t>
             </a:r>
             <a:endParaRPr lang="en-US" sz="2400" dirty="0"/>
           </a:p>
@@ -17942,7 +17942,7 @@
                   <a:schemeClr val="tx1"/>
                 </a:solidFill>
               </a:rPr>
-              <a:t>Backup: archivio completo e istruzioni di ripristino fatti (19/10); da attivare copie automatiche di database e file, ambiente di prova, monitoraggio errori</a:t>
+              <a:t>Backup automatico completo su Google Drive alle 13 e alle 21 (pronto dal 21/10, da installare) e istruzioni di ripristino provate; da fare ambiente di prova e monitoraggio errori</a:t>
             </a:r>
             <a:endParaRPr lang="en-US" sz="1350" dirty="0"/>
           </a:p>

</xml_diff>

<commit_message>
Simulatore: PDF ed Excel con tutti i dati della pagina, i costi e i grafici (ISS-035)
Il report scaricato da ogni simulazione riprende tutte le sezioni della
pagina: impostazioni e buffer del Capitolo 7, scenario di riferimento con
i rifiuti per tipologia, situazione attuale, obiettivi anno per anno,
risultati con il totale, parametri economici, costi del Caso 1 o 2 e
quattro grafici vettoriali. Excel: nuovo foglio «Dati inseriti».
Documentazione e registro issue aggiornati.

Co-Authored-By: Claude Opus 5.5 <noreply@anthropic.com>
Claude-Session: https://claude.ai/code/session_01E8XCbEeVHWVP3hntUZ6kZ1
</commit_message>
<xml_diff>
--- a/public/documentazione/Presentazione_Portale_CWP.pptx
+++ b/public/documentazione/Presentazione_Portale_CWP.pptx
@@ -120,39 +120,39 @@
   <p:extLst>
     <p:ext uri="{521415D9-36F7-43E2-AB2F-B90AF26B5E84}">
       <p14:sectionLst xmlns:p14="http://schemas.microsoft.com/office/powerpoint/2010/main">
-        <p14:section name="Apertura" id="{6202eb85-d8c3-ce69-b2e5-3f289672d84f}">
+        <p14:section name="Apertura" id="{87b6d574-915f-13af-8c85-ada9343d9c69}">
           <p14:sldIdLst>
             <p14:sldId id="256"/>
           </p14:sldIdLst>
         </p14:section>
-        <p14:section name="Metodologia" id="{bd24c1bc-173b-a2e8-ffde-fb8cae318fa9}">
+        <p14:section name="Metodologia" id="{b6654f39-dfd0-c9b9-1c38-1284a961a780}">
           <p14:sldIdLst>
             <p14:sldId id="257"/>
           </p14:sldIdLst>
         </p14:section>
-        <p14:section name="Analisi funzionale" id="{df2e04a7-02ec-d846-ef84-9fc4154153e7}">
+        <p14:section name="Analisi funzionale" id="{7bcafd94-acca-706a-b07d-6fc9306a2f54}">
           <p14:sldIdLst>
             <p14:sldId id="258"/>
             <p14:sldId id="259"/>
           </p14:sldIdLst>
         </p14:section>
-        <p14:section name="Già realtà" id="{2ae0751a-399c-447a-89ca-5155b5341819}">
+        <p14:section name="Già realtà" id="{e113a312-723a-cad1-ec84-5773ef8422ed}">
           <p14:sldIdLst>
             <p14:sldId id="260"/>
           </p14:sldIdLst>
         </p14:section>
-        <p14:section name="Architettura e ruoli" id="{9d864373-5df9-aab3-d0c4-6f5bbd212da5}">
+        <p14:section name="Architettura e ruoli" id="{c6186103-b632-987d-059b-3576da067abc}">
           <p14:sldIdLst>
             <p14:sldId id="261"/>
             <p14:sldId id="262"/>
           </p14:sldIdLst>
         </p14:section>
-        <p14:section name="Novità" id="{2f75082e-3656-a624-a4fa-eed0fb408a26}">
+        <p14:section name="Novità" id="{b5b2c17f-172b-55bf-23fd-3120716b3d9a}">
           <p14:sldIdLst>
             <p14:sldId id="263"/>
           </p14:sldIdLst>
         </p14:section>
-        <p14:section name="Punti aperti" id="{b417c3ce-90b3-5746-dc07-2b3b12952897}">
+        <p14:section name="Punti aperti" id="{4f087328-aa5e-45b0-64b4-70e70208df47}">
           <p14:sldIdLst>
             <p14:sldId id="264"/>
             <p14:sldId id="265"/>
@@ -161,7 +161,7 @@
             <p14:sldId id="268"/>
           </p14:sldIdLst>
         </p14:section>
-        <p14:section name="Scelte da prendere" id="{7ec79774-36da-2bd9-db7a-2d095fa8c686}">
+        <p14:section name="Scelte da prendere" id="{41e7538e-6cf0-c04f-b128-55ad44c66feb}">
           <p14:sldIdLst>
             <p14:sldId id="269"/>
           </p14:sldIdLst>
@@ -570,7 +570,7 @@
           <a:p>
             <a:r>
               <a:rPr lang="en-US" dirty="0"/>
-              <a:t>Presentazione di riepilogo del portale, aggiornata al 21 ottobre 2026 (revisione 3.0): metodologia, funzioni realizzate, novità, punti aperti di sviluppo e scelte ancora da prendere. Si rigenera a ogni rilascio insieme agli altri documenti ed è disponibile agli Amministratori nella pagina Documentazione del portale.</a:t>
+              <a:t>Presentazione di riepilogo del portale, aggiornata al 21 ottobre 2026 (revisione 3.1): metodologia, funzioni realizzate, novità, punti aperti di sviluppo e scelte ancora da prendere. Si rigenera a ogni rilascio insieme agli altri documenti ed è disponibile agli Amministratori nella pagina Documentazione del portale.</a:t>
             </a:r>
             <a:endParaRPr lang="en-US" dirty="0"/>
           </a:p>
@@ -1362,7 +1362,7 @@
           <a:p>
             <a:r>
               <a:rPr lang="en-US" dirty="0"/>
-              <a:t>Pagina «effetto sorpresa»: nessuno si aspetta che il portale sia già online. Il sistema è stato realizzato da Luca Moretti con l'ausilio di Claude Code ed è quasi terminato; i servizi sono già in produzione: GitHub (codice), Vercel (pubblicazione del portale), Supabase (database, utenti, documenti, funzioni) e Resend (email). Il portale è pubblicato su portale-cwp.vercel.app e funziona con dati di prova: si può aprire durante la presentazione (collegamento cliccabile) o inquadrare il codice QR con il telefono. La pagina pubblica /programma mostra già gli 8 documenti ufficiali del Programma, la Metodologia approvata, la PEC e il soggetto promotore. Lo sviluppo del portale vero è partito il 17 ottobre 2026: da allora sono state pubblicate 133 versioni, 35 script del database e 6 funzioni sul server. Restano i punti aperti delle prossime slide (servizi a pagamento, sicurezza, dati da inserire, collaudo con un Comune). Suggerimento: aprire il portale dal vivo con un utente di prova e mostrare la pagina pubblica.</a:t>
+              <a:t>Pagina «effetto sorpresa»: nessuno si aspetta che il portale sia già online. Il sistema è stato realizzato da Luca Moretti con l'ausilio di Claude Code ed è quasi terminato; i servizi sono già in produzione: GitHub (codice), Vercel (pubblicazione del portale), Supabase (database, utenti, documenti, funzioni) e Resend (email). Il portale è pubblicato su portale-cwp.vercel.app e funziona con dati di prova: si può aprire durante la presentazione (collegamento cliccabile) o inquadrare il codice QR con il telefono. La pagina pubblica /programma mostra già gli 8 documenti ufficiali del Programma, la Metodologia approvata, la PEC e il soggetto promotore. Lo sviluppo del portale vero è partito il 17 ottobre 2026: da allora sono state pubblicate 135 versioni, 35 script del database e 6 funzioni sul server. Restano i punti aperti delle prossime slide (servizi a pagamento, sicurezza, dati da inserire, collaudo con un Comune). Suggerimento: aprire il portale dal vivo con un utente di prova e mostrare la pagina pubblica.</a:t>
             </a:r>
             <a:endParaRPr lang="en-US" dirty="0"/>
           </a:p>
@@ -2073,7 +2073,7 @@
                   <a:schemeClr val="accent6"/>
                 </a:solidFill>
               </a:rPr>
-              <a:t>Portale Carbon WastePrint · Stato dei lavori e recap · 21 ottobre 2026 · rev. 3.0</a:t>
+              <a:t>Portale Carbon WastePrint · Stato dei lavori e recap · 21 ottobre 2026 · rev. 3.1</a:t>
             </a:r>
             <a:endParaRPr lang="en-US" sz="1000" dirty="0"/>
           </a:p>
@@ -2571,7 +2571,7 @@
                   <a:schemeClr val="accent3"/>
                 </a:solidFill>
               </a:rPr>
-              <a:t>Stato dei lavori e recap: metodologia, funzioni, novità, punti aperti e scelte da prendere · aggiornata al 21 ottobre 2026 · rev. 3.0</a:t>
+              <a:t>Stato dei lavori e recap: metodologia, funzioni, novità, punti aperti e scelte da prendere · aggiornata al 21 ottobre 2026 · rev. 3.1</a:t>
             </a:r>
             <a:endParaRPr lang="en-US" sz="1800" dirty="0"/>
           </a:p>
@@ -13235,7 +13235,7 @@
                 <a:ea typeface="Cambria" pitchFamily="34" charset="-122"/>
                 <a:cs typeface="Cambria" pitchFamily="34" charset="-120"/>
               </a:rPr>
-              <a:t>≈33.900</a:t>
+              <a:t>≈34.700</a:t>
             </a:r>
             <a:endParaRPr lang="en-US" sz="3000" dirty="0"/>
           </a:p>
@@ -14022,7 +14022,7 @@
                 <a:ea typeface="Cambria" pitchFamily="34" charset="-122"/>
                 <a:cs typeface="Cambria" pitchFamily="34" charset="-120"/>
               </a:rPr>
-              <a:t>133</a:t>
+              <a:t>135</a:t>
             </a:r>
             <a:endParaRPr lang="en-US" sz="2400" dirty="0"/>
           </a:p>
@@ -14181,7 +14181,7 @@
                 <a:ea typeface="Cambria" pitchFamily="34" charset="-122"/>
                 <a:cs typeface="Cambria" pitchFamily="34" charset="-120"/>
               </a:rPr>
-              <a:t>≈33.900</a:t>
+              <a:t>≈34.700</a:t>
             </a:r>
             <a:endParaRPr lang="en-US" sz="2400" dirty="0"/>
           </a:p>
@@ -17557,7 +17557,7 @@
                   <a:schemeClr val="tx1"/>
                 </a:solidFill>
               </a:rPr>
-              <a:t>metodo «per utenza, solo utenze virtuose» come nell'Allegato A EsaCom; dal 20/10 PDF impaginato ed export Excel</a:t>
+              <a:t>metodo «per utenza, solo utenze virtuose» come nell'Allegato A EsaCom; dal 20/10 PDF impaginato ed export Excel; dal 21/10 il PDF riporta tutti i dati inseriti, i costi e quattro grafici</a:t>
             </a:r>
             <a:endParaRPr lang="en-US" sz="1350" dirty="0"/>
           </a:p>

</xml_diff>

<commit_message>
News: osservatorio sui crediti di carbonio volontari per gli Amministratori
Script 36 (tabelle notizia e notizie_esecuzione, RLS solo Admin, limite di
frequenza, lavoro pg_cron ogni 2 ore), funzione del server «notizie»
(feed RSS, pre-filtro, valutazione di Claude con sintesi in italiano),
modulo src/lib/notizie.js, pagina /news e voce di menu. Prove
notizie.test.mjs e t36.sql. Manuali, Registro, Istruzioni di ripristino,
Registro issue e test e presentazione aggiornati.

Co-Authored-By: Claude Opus 5.5 <noreply@anthropic.com>
Claude-Session: https://claude.ai/code/session_01E8XCbEeVHWVP3hntUZ6kZ1
</commit_message>
<xml_diff>
--- a/public/documentazione/Presentazione_Portale_CWP.pptx
+++ b/public/documentazione/Presentazione_Portale_CWP.pptx
@@ -120,39 +120,39 @@
   <p:extLst>
     <p:ext uri="{521415D9-36F7-43E2-AB2F-B90AF26B5E84}">
       <p14:sectionLst xmlns:p14="http://schemas.microsoft.com/office/powerpoint/2010/main">
-        <p14:section name="Apertura" id="{87b6d574-915f-13af-8c85-ada9343d9c69}">
+        <p14:section name="Apertura" id="{6389c992-6cc9-d34d-778f-5e4370e25f31}">
           <p14:sldIdLst>
             <p14:sldId id="256"/>
           </p14:sldIdLst>
         </p14:section>
-        <p14:section name="Metodologia" id="{b6654f39-dfd0-c9b9-1c38-1284a961a780}">
+        <p14:section name="Metodologia" id="{8a64079c-436d-e523-2cd8-61fc500afe86}">
           <p14:sldIdLst>
             <p14:sldId id="257"/>
           </p14:sldIdLst>
         </p14:section>
-        <p14:section name="Analisi funzionale" id="{7bcafd94-acca-706a-b07d-6fc9306a2f54}">
+        <p14:section name="Analisi funzionale" id="{b7510797-6001-2773-eacb-9dd907ae4ea0}">
           <p14:sldIdLst>
             <p14:sldId id="258"/>
             <p14:sldId id="259"/>
           </p14:sldIdLst>
         </p14:section>
-        <p14:section name="Già realtà" id="{e113a312-723a-cad1-ec84-5773ef8422ed}">
+        <p14:section name="Già realtà" id="{3fff82dd-3c4d-7505-8c51-554cde44d35c}">
           <p14:sldIdLst>
             <p14:sldId id="260"/>
           </p14:sldIdLst>
         </p14:section>
-        <p14:section name="Architettura e ruoli" id="{c6186103-b632-987d-059b-3576da067abc}">
+        <p14:section name="Architettura e ruoli" id="{aa2fdb58-8960-7782-e6c1-10d0b6c334cb}">
           <p14:sldIdLst>
             <p14:sldId id="261"/>
             <p14:sldId id="262"/>
           </p14:sldIdLst>
         </p14:section>
-        <p14:section name="Novità" id="{b5b2c17f-172b-55bf-23fd-3120716b3d9a}">
+        <p14:section name="Novità" id="{2986b862-75d4-5f19-81e9-06b3814b90de}">
           <p14:sldIdLst>
             <p14:sldId id="263"/>
           </p14:sldIdLst>
         </p14:section>
-        <p14:section name="Punti aperti" id="{4f087328-aa5e-45b0-64b4-70e70208df47}">
+        <p14:section name="Punti aperti" id="{15fb2deb-a5ca-2361-14cb-46fd8a320fd5}">
           <p14:sldIdLst>
             <p14:sldId id="264"/>
             <p14:sldId id="265"/>
@@ -161,7 +161,7 @@
             <p14:sldId id="268"/>
           </p14:sldIdLst>
         </p14:section>
-        <p14:section name="Scelte da prendere" id="{41e7538e-6cf0-c04f-b128-55ad44c66feb}">
+        <p14:section name="Scelte da prendere" id="{4a283d3e-d59a-fc2f-5b51-e8cdbc984ba3}">
           <p14:sldIdLst>
             <p14:sldId id="269"/>
           </p14:sldIdLst>
@@ -570,7 +570,7 @@
           <a:p>
             <a:r>
               <a:rPr lang="en-US" dirty="0"/>
-              <a:t>Presentazione di riepilogo del portale, aggiornata al 21 ottobre 2026 (revisione 3.1): metodologia, funzioni realizzate, novità, punti aperti di sviluppo e scelte ancora da prendere. Si rigenera a ogni rilascio insieme agli altri documenti ed è disponibile agli Amministratori nella pagina Documentazione del portale.</a:t>
+              <a:t>Presentazione di riepilogo del portale, aggiornata al 21 ottobre 2026 (revisione 3.2): metodologia, funzioni realizzate, novità, punti aperti di sviluppo e scelte ancora da prendere. Si rigenera a ogni rilascio insieme agli altri documenti ed è disponibile agli Amministratori nella pagina Documentazione del portale.</a:t>
             </a:r>
             <a:endParaRPr lang="en-US" dirty="0"/>
           </a:p>
@@ -1362,7 +1362,7 @@
           <a:p>
             <a:r>
               <a:rPr lang="en-US" dirty="0"/>
-              <a:t>Pagina «effetto sorpresa»: nessuno si aspetta che il portale sia già online. Il sistema è stato realizzato da Luca Moretti con l'ausilio di Claude Code ed è quasi terminato; i servizi sono già in produzione: GitHub (codice), Vercel (pubblicazione del portale), Supabase (database, utenti, documenti, funzioni) e Resend (email). Il portale è pubblicato su portale-cwp.vercel.app e funziona con dati di prova: si può aprire durante la presentazione (collegamento cliccabile) o inquadrare il codice QR con il telefono. La pagina pubblica /programma mostra già gli 8 documenti ufficiali del Programma, la Metodologia approvata, la PEC e il soggetto promotore. Lo sviluppo del portale vero è partito il 17 ottobre 2026: da allora sono state pubblicate 135 versioni, 35 script del database e 6 funzioni sul server. Restano i punti aperti delle prossime slide (servizi a pagamento, sicurezza, dati da inserire, collaudo con un Comune). Suggerimento: aprire il portale dal vivo con un utente di prova e mostrare la pagina pubblica.</a:t>
+              <a:t>Pagina «effetto sorpresa»: nessuno si aspetta che il portale sia già online. Il sistema è stato realizzato da Luca Moretti con l'ausilio di Claude Code ed è quasi terminato; i servizi sono già in produzione: GitHub (codice), Vercel (pubblicazione del portale), Supabase (database, utenti, documenti, funzioni) e Resend (email). Il portale è pubblicato su portale-cwp.vercel.app e funziona con dati di prova: si può aprire durante la presentazione (collegamento cliccabile) o inquadrare il codice QR con il telefono. La pagina pubblica /programma mostra già gli 8 documenti ufficiali del Programma, la Metodologia approvata, la PEC e il soggetto promotore. Lo sviluppo del portale vero è partito il 17 ottobre 2026: da allora sono state pubblicate 138 versioni, 36 script del database e 7 funzioni sul server. Restano i punti aperti delle prossime slide (servizi a pagamento, sicurezza, dati da inserire, collaudo con un Comune). Suggerimento: aprire il portale dal vivo con un utente di prova e mostrare la pagina pubblica.</a:t>
             </a:r>
             <a:endParaRPr lang="en-US" dirty="0"/>
           </a:p>
@@ -2073,7 +2073,7 @@
                   <a:schemeClr val="accent6"/>
                 </a:solidFill>
               </a:rPr>
-              <a:t>Portale Carbon WastePrint · Stato dei lavori e recap · 21 ottobre 2026 · rev. 3.1</a:t>
+              <a:t>Portale Carbon WastePrint · Stato dei lavori e recap · 21 ottobre 2026 · rev. 3.2</a:t>
             </a:r>
             <a:endParaRPr lang="en-US" sz="1000" dirty="0"/>
           </a:p>
@@ -2571,7 +2571,7 @@
                   <a:schemeClr val="accent3"/>
                 </a:solidFill>
               </a:rPr>
-              <a:t>Stato dei lavori e recap: metodologia, funzioni, novità, punti aperti e scelte da prendere · aggiornata al 21 ottobre 2026 · rev. 3.1</a:t>
+              <a:t>Stato dei lavori e recap: metodologia, funzioni, novità, punti aperti e scelte da prendere · aggiornata al 21 ottobre 2026 · rev. 3.2</a:t>
             </a:r>
             <a:endParaRPr lang="en-US" sz="1800" dirty="0"/>
           </a:p>
@@ -12929,7 +12929,7 @@
                 <a:ea typeface="Cambria" pitchFamily="34" charset="-122"/>
                 <a:cs typeface="Cambria" pitchFamily="34" charset="-120"/>
               </a:rPr>
-              <a:t>35</a:t>
+              <a:t>36</a:t>
             </a:r>
             <a:endParaRPr lang="en-US" sz="3000" dirty="0"/>
           </a:p>
@@ -13031,7 +13031,7 @@
                 <a:ea typeface="Cambria" pitchFamily="34" charset="-122"/>
                 <a:cs typeface="Cambria" pitchFamily="34" charset="-120"/>
               </a:rPr>
-              <a:t>6</a:t>
+              <a:t>7</a:t>
             </a:r>
             <a:endParaRPr lang="en-US" sz="3000" dirty="0"/>
           </a:p>
@@ -13235,7 +13235,7 @@
                 <a:ea typeface="Cambria" pitchFamily="34" charset="-122"/>
                 <a:cs typeface="Cambria" pitchFamily="34" charset="-120"/>
               </a:rPr>
-              <a:t>≈34.700</a:t>
+              <a:t>≈36.000</a:t>
             </a:r>
             <a:endParaRPr lang="en-US" sz="3000" dirty="0"/>
           </a:p>
@@ -14022,7 +14022,7 @@
                 <a:ea typeface="Cambria" pitchFamily="34" charset="-122"/>
                 <a:cs typeface="Cambria" pitchFamily="34" charset="-120"/>
               </a:rPr>
-              <a:t>135</a:t>
+              <a:t>138</a:t>
             </a:r>
             <a:endParaRPr lang="en-US" sz="2400" dirty="0"/>
           </a:p>
@@ -14075,7 +14075,7 @@
                 <a:ea typeface="Cambria" pitchFamily="34" charset="-122"/>
                 <a:cs typeface="Cambria" pitchFamily="34" charset="-120"/>
               </a:rPr>
-              <a:t>35</a:t>
+              <a:t>36</a:t>
             </a:r>
             <a:endParaRPr lang="en-US" sz="2400" dirty="0"/>
           </a:p>
@@ -14128,7 +14128,7 @@
                 <a:ea typeface="Cambria" pitchFamily="34" charset="-122"/>
                 <a:cs typeface="Cambria" pitchFamily="34" charset="-120"/>
               </a:rPr>
-              <a:t>6</a:t>
+              <a:t>7</a:t>
             </a:r>
             <a:endParaRPr lang="en-US" sz="2400" dirty="0"/>
           </a:p>
@@ -14181,7 +14181,7 @@
                 <a:ea typeface="Cambria" pitchFamily="34" charset="-122"/>
                 <a:cs typeface="Cambria" pitchFamily="34" charset="-120"/>
               </a:rPr>
-              <a:t>≈34.700</a:t>
+              <a:t>≈36.000</a:t>
             </a:r>
             <a:endParaRPr lang="en-US" sz="2400" dirty="0"/>
           </a:p>
@@ -17007,7 +17007,7 @@
                 <a:ea typeface="Cambria" pitchFamily="34" charset="-122"/>
                 <a:cs typeface="Cambria" pitchFamily="34" charset="-120"/>
               </a:rPr>
-              <a:t>Novità del 19 e 20 ottobre</a:t>
+              <a:t>Novità dal 19 al 21 ottobre</a:t>
             </a:r>
             <a:endParaRPr lang="en-US" sz="3000" dirty="0"/>
           </a:p>
@@ -17591,7 +17591,7 @@
                   <a:schemeClr val="tx1"/>
                 </a:solidFill>
               </a:rPr>
-              <a:t>menu riordinati per ruolo, «Marketplaces» in arrivo; 8 documenti ufficiali v1.2 e questa presentazione per gli Amministratori</a:t>
+              <a:t>menu per ruolo; dal 21/10 «News», osservatorio sui crediti volontari aggiornato ogni 2 ore (Admin); «Marketplaces» in arrivo; 8 documenti ufficiali v1.2</a:t>
             </a:r>
             <a:endParaRPr lang="en-US" sz="1350" dirty="0"/>
           </a:p>

</xml_diff>

<commit_message>
Documenti rigenerati (Notizie CO2, barra a LED, loghi, ISS-036)
Co-Authored-By: Claude Opus 5.5 <noreply@anthropic.com>
Claude-Session: https://claude.ai/code/session_01E8XCbEeVHWVP3hntUZ6kZ1
</commit_message>
<xml_diff>
--- a/public/documentazione/Presentazione_Portale_CWP.pptx
+++ b/public/documentazione/Presentazione_Portale_CWP.pptx
@@ -120,39 +120,39 @@
   <p:extLst>
     <p:ext uri="{521415D9-36F7-43E2-AB2F-B90AF26B5E84}">
       <p14:sectionLst xmlns:p14="http://schemas.microsoft.com/office/powerpoint/2010/main">
-        <p14:section name="Apertura" id="{6389c992-6cc9-d34d-778f-5e4370e25f31}">
+        <p14:section name="Apertura" id="{8c186372-ac22-ff2b-dc4b-cf9d21190fd0}">
           <p14:sldIdLst>
             <p14:sldId id="256"/>
           </p14:sldIdLst>
         </p14:section>
-        <p14:section name="Metodologia" id="{8a64079c-436d-e523-2cd8-61fc500afe86}">
+        <p14:section name="Metodologia" id="{d2bb5d5b-f899-a864-a9d8-fcd1840de7d7}">
           <p14:sldIdLst>
             <p14:sldId id="257"/>
           </p14:sldIdLst>
         </p14:section>
-        <p14:section name="Analisi funzionale" id="{b7510797-6001-2773-eacb-9dd907ae4ea0}">
+        <p14:section name="Analisi funzionale" id="{6ec54255-d0b1-b40a-c6ff-e22088acb207}">
           <p14:sldIdLst>
             <p14:sldId id="258"/>
             <p14:sldId id="259"/>
           </p14:sldIdLst>
         </p14:section>
-        <p14:section name="Già realtà" id="{3fff82dd-3c4d-7505-8c51-554cde44d35c}">
+        <p14:section name="Già realtà" id="{2bdcd5a0-e4fc-5729-6e0e-78cb0ea5019e}">
           <p14:sldIdLst>
             <p14:sldId id="260"/>
           </p14:sldIdLst>
         </p14:section>
-        <p14:section name="Architettura e ruoli" id="{aa2fdb58-8960-7782-e6c1-10d0b6c334cb}">
+        <p14:section name="Architettura e ruoli" id="{6b1b5d48-6b27-830e-d810-a1a78aed5b70}">
           <p14:sldIdLst>
             <p14:sldId id="261"/>
             <p14:sldId id="262"/>
           </p14:sldIdLst>
         </p14:section>
-        <p14:section name="Novità" id="{2986b862-75d4-5f19-81e9-06b3814b90de}">
+        <p14:section name="Novità" id="{8d31823d-6079-a709-c411-eb9e91400385}">
           <p14:sldIdLst>
             <p14:sldId id="263"/>
           </p14:sldIdLst>
         </p14:section>
-        <p14:section name="Punti aperti" id="{15fb2deb-a5ca-2361-14cb-46fd8a320fd5}">
+        <p14:section name="Punti aperti" id="{97f1e8dd-1e32-6472-6057-4ff4becdfd6c}">
           <p14:sldIdLst>
             <p14:sldId id="264"/>
             <p14:sldId id="265"/>
@@ -161,7 +161,7 @@
             <p14:sldId id="268"/>
           </p14:sldIdLst>
         </p14:section>
-        <p14:section name="Scelte da prendere" id="{4a283d3e-d59a-fc2f-5b51-e8cdbc984ba3}">
+        <p14:section name="Scelte da prendere" id="{bfdb0f5f-3e0c-4cea-d213-b74ee28bf8a1}">
           <p14:sldIdLst>
             <p14:sldId id="269"/>
           </p14:sldIdLst>
@@ -570,7 +570,7 @@
           <a:p>
             <a:r>
               <a:rPr lang="en-US" dirty="0"/>
-              <a:t>Presentazione di riepilogo del portale, aggiornata al 21 ottobre 2026 (revisione 3.2): metodologia, funzioni realizzate, novità, punti aperti di sviluppo e scelte ancora da prendere. Si rigenera a ogni rilascio insieme agli altri documenti ed è disponibile agli Amministratori nella pagina Documentazione del portale.</a:t>
+              <a:t>Presentazione di riepilogo del portale, aggiornata al 21 ottobre 2026 (revisione 3.3): metodologia, funzioni realizzate, novità, punti aperti di sviluppo e scelte ancora da prendere. Si rigenera a ogni rilascio insieme agli altri documenti ed è disponibile agli Amministratori nella pagina Documentazione del portale.</a:t>
             </a:r>
             <a:endParaRPr lang="en-US" dirty="0"/>
           </a:p>
@@ -1362,7 +1362,7 @@
           <a:p>
             <a:r>
               <a:rPr lang="en-US" dirty="0"/>
-              <a:t>Pagina «effetto sorpresa»: nessuno si aspetta che il portale sia già online. Il sistema è stato realizzato da Luca Moretti con l'ausilio di Claude Code ed è quasi terminato; i servizi sono già in produzione: GitHub (codice), Vercel (pubblicazione del portale), Supabase (database, utenti, documenti, funzioni) e Resend (email). Il portale è pubblicato su portale-cwp.vercel.app e funziona con dati di prova: si può aprire durante la presentazione (collegamento cliccabile) o inquadrare il codice QR con il telefono. La pagina pubblica /programma mostra già gli 8 documenti ufficiali del Programma, la Metodologia approvata, la PEC e il soggetto promotore. Lo sviluppo del portale vero è partito il 17 ottobre 2026: da allora sono state pubblicate 138 versioni, 36 script del database e 7 funzioni sul server. Restano i punti aperti delle prossime slide (servizi a pagamento, sicurezza, dati da inserire, collaudo con un Comune). Suggerimento: aprire il portale dal vivo con un utente di prova e mostrare la pagina pubblica.</a:t>
+              <a:t>Pagina «effetto sorpresa»: nessuno si aspetta che il portale sia già online. Il sistema è stato realizzato da Luca Moretti con l'ausilio di Claude Code ed è quasi terminato; i servizi sono già in produzione: GitHub (codice), Vercel (pubblicazione del portale), Supabase (database, utenti, documenti, funzioni) e Resend (email). Il portale è pubblicato su portale-cwp.vercel.app e funziona con dati di prova: si può aprire durante la presentazione (collegamento cliccabile) o inquadrare il codice QR con il telefono. La pagina pubblica /programma mostra già gli 8 documenti ufficiali del Programma, la Metodologia approvata, la PEC e il soggetto promotore. Lo sviluppo del portale vero è partito il 17 ottobre 2026: da allora sono state pubblicate 143 versioni, 36 script del database e 7 funzioni sul server. Restano i punti aperti delle prossime slide (servizi a pagamento, sicurezza, dati da inserire, collaudo con un Comune). Suggerimento: aprire il portale dal vivo con un utente di prova e mostrare la pagina pubblica.</a:t>
             </a:r>
             <a:endParaRPr lang="en-US" dirty="0"/>
           </a:p>
@@ -2073,7 +2073,7 @@
                   <a:schemeClr val="accent6"/>
                 </a:solidFill>
               </a:rPr>
-              <a:t>Portale Carbon WastePrint · Stato dei lavori e recap · 21 ottobre 2026 · rev. 3.2</a:t>
+              <a:t>Portale Carbon WastePrint · Stato dei lavori e recap · 21 ottobre 2026 · rev. 3.3</a:t>
             </a:r>
             <a:endParaRPr lang="en-US" sz="1000" dirty="0"/>
           </a:p>
@@ -2571,7 +2571,7 @@
                   <a:schemeClr val="accent3"/>
                 </a:solidFill>
               </a:rPr>
-              <a:t>Stato dei lavori e recap: metodologia, funzioni, novità, punti aperti e scelte da prendere · aggiornata al 21 ottobre 2026 · rev. 3.2</a:t>
+              <a:t>Stato dei lavori e recap: metodologia, funzioni, novità, punti aperti e scelte da prendere · aggiornata al 21 ottobre 2026 · rev. 3.3</a:t>
             </a:r>
             <a:endParaRPr lang="en-US" sz="1800" dirty="0"/>
           </a:p>
@@ -13235,7 +13235,7 @@
                 <a:ea typeface="Cambria" pitchFamily="34" charset="-122"/>
                 <a:cs typeface="Cambria" pitchFamily="34" charset="-120"/>
               </a:rPr>
-              <a:t>≈36.000</a:t>
+              <a:t>≈36.300</a:t>
             </a:r>
             <a:endParaRPr lang="en-US" sz="3000" dirty="0"/>
           </a:p>
@@ -14022,7 +14022,7 @@
                 <a:ea typeface="Cambria" pitchFamily="34" charset="-122"/>
                 <a:cs typeface="Cambria" pitchFamily="34" charset="-120"/>
               </a:rPr>
-              <a:t>138</a:t>
+              <a:t>143</a:t>
             </a:r>
             <a:endParaRPr lang="en-US" sz="2400" dirty="0"/>
           </a:p>
@@ -14181,7 +14181,7 @@
                 <a:ea typeface="Cambria" pitchFamily="34" charset="-122"/>
                 <a:cs typeface="Cambria" pitchFamily="34" charset="-120"/>
               </a:rPr>
-              <a:t>≈36.000</a:t>
+              <a:t>≈36.300</a:t>
             </a:r>
             <a:endParaRPr lang="en-US" sz="2400" dirty="0"/>
           </a:p>
@@ -17591,7 +17591,7 @@
                   <a:schemeClr val="tx1"/>
                 </a:solidFill>
               </a:rPr>
-              <a:t>menu per ruolo; dal 21/10 «News», osservatorio sui crediti volontari aggiornato ogni 2 ore (Admin); «Marketplaces» in arrivo; 8 documenti ufficiali v1.2</a:t>
+              <a:t>menu per ruolo; dal 21/10 «Notizie CO2», osservatorio sui crediti volontari aggiornato ogni 2 ore (Admin); «Marketplaces» in arrivo; 8 documenti ufficiali v1.2</a:t>
             </a:r>
             <a:endParaRPr lang="en-US" sz="1350" dirty="0"/>
           </a:p>

</xml_diff>

<commit_message>
Documenti rigenerati (backup dal Mac)
Co-Authored-By: Claude Opus 5.5 <noreply@anthropic.com>
Claude-Session: https://claude.ai/code/session_01E8XCbEeVHWVP3hntUZ6kZ1
</commit_message>
<xml_diff>
--- a/public/documentazione/Presentazione_Portale_CWP.pptx
+++ b/public/documentazione/Presentazione_Portale_CWP.pptx
@@ -120,39 +120,39 @@
   <p:extLst>
     <p:ext uri="{521415D9-36F7-43E2-AB2F-B90AF26B5E84}">
       <p14:sectionLst xmlns:p14="http://schemas.microsoft.com/office/powerpoint/2010/main">
-        <p14:section name="Apertura" id="{8c186372-ac22-ff2b-dc4b-cf9d21190fd0}">
+        <p14:section name="Apertura" id="{4a212da7-d221-630e-7220-f1fee0c7da03}">
           <p14:sldIdLst>
             <p14:sldId id="256"/>
           </p14:sldIdLst>
         </p14:section>
-        <p14:section name="Metodologia" id="{d2bb5d5b-f899-a864-a9d8-fcd1840de7d7}">
+        <p14:section name="Metodologia" id="{5b9d2488-e8d7-70c1-76f6-951a56f1ba52}">
           <p14:sldIdLst>
             <p14:sldId id="257"/>
           </p14:sldIdLst>
         </p14:section>
-        <p14:section name="Analisi funzionale" id="{6ec54255-d0b1-b40a-c6ff-e22088acb207}">
+        <p14:section name="Analisi funzionale" id="{25a870c3-928c-a5f1-7e40-83c1518f59e7}">
           <p14:sldIdLst>
             <p14:sldId id="258"/>
             <p14:sldId id="259"/>
           </p14:sldIdLst>
         </p14:section>
-        <p14:section name="Già realtà" id="{2bdcd5a0-e4fc-5729-6e0e-78cb0ea5019e}">
+        <p14:section name="Già realtà" id="{62511de9-31fd-9504-1c98-06bdaff5e8ff}">
           <p14:sldIdLst>
             <p14:sldId id="260"/>
           </p14:sldIdLst>
         </p14:section>
-        <p14:section name="Architettura e ruoli" id="{6b1b5d48-6b27-830e-d810-a1a78aed5b70}">
+        <p14:section name="Architettura e ruoli" id="{9412beb7-1b98-adb4-f50c-776da49f49d4}">
           <p14:sldIdLst>
             <p14:sldId id="261"/>
             <p14:sldId id="262"/>
           </p14:sldIdLst>
         </p14:section>
-        <p14:section name="Novità" id="{8d31823d-6079-a709-c411-eb9e91400385}">
+        <p14:section name="Novità" id="{c9a5a7f7-8fe8-9150-65e8-659fa4f040da}">
           <p14:sldIdLst>
             <p14:sldId id="263"/>
           </p14:sldIdLst>
         </p14:section>
-        <p14:section name="Punti aperti" id="{97f1e8dd-1e32-6472-6057-4ff4becdfd6c}">
+        <p14:section name="Punti aperti" id="{b71b4f52-6662-e2e7-0efd-648c6cd7445d}">
           <p14:sldIdLst>
             <p14:sldId id="264"/>
             <p14:sldId id="265"/>
@@ -161,7 +161,7 @@
             <p14:sldId id="268"/>
           </p14:sldIdLst>
         </p14:section>
-        <p14:section name="Scelte da prendere" id="{bfdb0f5f-3e0c-4cea-d213-b74ee28bf8a1}">
+        <p14:section name="Scelte da prendere" id="{54164ed9-bca7-fa62-3b73-f5d0259fa0a4}">
           <p14:sldIdLst>
             <p14:sldId id="269"/>
           </p14:sldIdLst>
@@ -570,7 +570,7 @@
           <a:p>
             <a:r>
               <a:rPr lang="en-US" dirty="0"/>
-              <a:t>Presentazione di riepilogo del portale, aggiornata al 21 ottobre 2026 (revisione 3.3): metodologia, funzioni realizzate, novità, punti aperti di sviluppo e scelte ancora da prendere. Si rigenera a ogni rilascio insieme agli altri documenti ed è disponibile agli Amministratori nella pagina Documentazione del portale.</a:t>
+              <a:t>Presentazione di riepilogo del portale, aggiornata al 21 ottobre 2026 (revisione 3.4): metodologia, funzioni realizzate, novità, punti aperti di sviluppo e scelte ancora da prendere. Si rigenera a ogni rilascio insieme agli altri documenti ed è disponibile agli Amministratori nella pagina Documentazione del portale.</a:t>
             </a:r>
             <a:endParaRPr lang="en-US" dirty="0"/>
           </a:p>
@@ -1362,7 +1362,7 @@
           <a:p>
             <a:r>
               <a:rPr lang="en-US" dirty="0"/>
-              <a:t>Pagina «effetto sorpresa»: nessuno si aspetta che il portale sia già online. Il sistema è stato realizzato da Luca Moretti con l'ausilio di Claude Code ed è quasi terminato; i servizi sono già in produzione: GitHub (codice), Vercel (pubblicazione del portale), Supabase (database, utenti, documenti, funzioni) e Resend (email). Il portale è pubblicato su portale-cwp.vercel.app e funziona con dati di prova: si può aprire durante la presentazione (collegamento cliccabile) o inquadrare il codice QR con il telefono. La pagina pubblica /programma mostra già gli 8 documenti ufficiali del Programma, la Metodologia approvata, la PEC e il soggetto promotore. Lo sviluppo del portale vero è partito il 17 ottobre 2026: da allora sono state pubblicate 143 versioni, 36 script del database e 7 funzioni sul server. Restano i punti aperti delle prossime slide (servizi a pagamento, sicurezza, dati da inserire, collaudo con un Comune). Suggerimento: aprire il portale dal vivo con un utente di prova e mostrare la pagina pubblica.</a:t>
+              <a:t>Pagina «effetto sorpresa»: nessuno si aspetta che il portale sia già online. Il sistema è stato realizzato da Luca Moretti con l'ausilio di Claude Code ed è quasi terminato; i servizi sono già in produzione: GitHub (codice), Vercel (pubblicazione del portale), Supabase (database, utenti, documenti, funzioni) e Resend (email). Il portale è pubblicato su portale-cwp.vercel.app e funziona con dati di prova: si può aprire durante la presentazione (collegamento cliccabile) o inquadrare il codice QR con il telefono. La pagina pubblica /programma mostra già gli 8 documenti ufficiali del Programma, la Metodologia approvata, la PEC e il soggetto promotore. Lo sviluppo del portale vero è partito il 17 ottobre 2026: da allora sono state pubblicate 154 versioni, 38 script del database e 7 funzioni sul server. Restano i punti aperti delle prossime slide (servizi a pagamento, sicurezza, dati da inserire, collaudo con un Comune). Suggerimento: aprire il portale dal vivo con un utente di prova e mostrare la pagina pubblica.</a:t>
             </a:r>
             <a:endParaRPr lang="en-US" dirty="0"/>
           </a:p>
@@ -2073,7 +2073,7 @@
                   <a:schemeClr val="accent6"/>
                 </a:solidFill>
               </a:rPr>
-              <a:t>Portale Carbon WastePrint · Stato dei lavori e recap · 21 ottobre 2026 · rev. 3.3</a:t>
+              <a:t>Portale Carbon WastePrint · Stato dei lavori e recap · 21 ottobre 2026 · rev. 3.4</a:t>
             </a:r>
             <a:endParaRPr lang="en-US" sz="1000" dirty="0"/>
           </a:p>
@@ -2571,7 +2571,7 @@
                   <a:schemeClr val="accent3"/>
                 </a:solidFill>
               </a:rPr>
-              <a:t>Stato dei lavori e recap: metodologia, funzioni, novità, punti aperti e scelte da prendere · aggiornata al 21 ottobre 2026 · rev. 3.3</a:t>
+              <a:t>Stato dei lavori e recap: metodologia, funzioni, novità, punti aperti e scelte da prendere · aggiornata al 21 ottobre 2026 · rev. 3.4</a:t>
             </a:r>
             <a:endParaRPr lang="en-US" sz="1800" dirty="0"/>
           </a:p>
@@ -12929,7 +12929,7 @@
                 <a:ea typeface="Cambria" pitchFamily="34" charset="-122"/>
                 <a:cs typeface="Cambria" pitchFamily="34" charset="-120"/>
               </a:rPr>
-              <a:t>36</a:t>
+              <a:t>38</a:t>
             </a:r>
             <a:endParaRPr lang="en-US" sz="3000" dirty="0"/>
           </a:p>
@@ -13235,7 +13235,7 @@
                 <a:ea typeface="Cambria" pitchFamily="34" charset="-122"/>
                 <a:cs typeface="Cambria" pitchFamily="34" charset="-120"/>
               </a:rPr>
-              <a:t>≈36.300</a:t>
+              <a:t>≈36.500</a:t>
             </a:r>
             <a:endParaRPr lang="en-US" sz="3000" dirty="0"/>
           </a:p>
@@ -14022,7 +14022,7 @@
                 <a:ea typeface="Cambria" pitchFamily="34" charset="-122"/>
                 <a:cs typeface="Cambria" pitchFamily="34" charset="-120"/>
               </a:rPr>
-              <a:t>143</a:t>
+              <a:t>154</a:t>
             </a:r>
             <a:endParaRPr lang="en-US" sz="2400" dirty="0"/>
           </a:p>
@@ -14075,7 +14075,7 @@
                 <a:ea typeface="Cambria" pitchFamily="34" charset="-122"/>
                 <a:cs typeface="Cambria" pitchFamily="34" charset="-120"/>
               </a:rPr>
-              <a:t>36</a:t>
+              <a:t>38</a:t>
             </a:r>
             <a:endParaRPr lang="en-US" sz="2400" dirty="0"/>
           </a:p>
@@ -14181,7 +14181,7 @@
                 <a:ea typeface="Cambria" pitchFamily="34" charset="-122"/>
                 <a:cs typeface="Cambria" pitchFamily="34" charset="-120"/>
               </a:rPr>
-              <a:t>≈36.300</a:t>
+              <a:t>≈36.500</a:t>
             </a:r>
             <a:endParaRPr lang="en-US" sz="2400" dirty="0"/>
           </a:p>
@@ -17942,7 +17942,7 @@
                   <a:schemeClr val="tx1"/>
                 </a:solidFill>
               </a:rPr>
-              <a:t>Backup automatico completo su Google Drive alle 13 e alle 21 (pronto dal 21/10, da installare) e istruzioni di ripristino provate; da fare ambiente di prova e monitoraggio errori</a:t>
+              <a:t>Backup automatico completo ogni giorno alle 20 dal Mac nella cartella Drive Cwp › backup (Google blocca Apps Script) e istruzioni di ripristino provate; da fare ambiente di prova e monitoraggio errori</a:t>
             </a:r>
             <a:endParaRPr lang="en-US" sz="1350" dirty="0"/>
           </a:p>

</xml_diff>

<commit_message>
Rilievi N01-N06: risposte nel documento del collaudo, manuali, registri, istruzioni di ripristino, base di conoscenza e presentazione aggiornati
Co-Authored-By: Claude Opus 5.5 <noreply@anthropic.com>
Claude-Session: https://claude.ai/code/session_01E8XCbEeVHWVP3hntUZ6kZ1
</commit_message>
<xml_diff>
--- a/public/documentazione/Presentazione_Portale_CWP.pptx
+++ b/public/documentazione/Presentazione_Portale_CWP.pptx
@@ -120,39 +120,39 @@
   <p:extLst>
     <p:ext uri="{521415D9-36F7-43E2-AB2F-B90AF26B5E84}">
       <p14:sectionLst xmlns:p14="http://schemas.microsoft.com/office/powerpoint/2010/main">
-        <p14:section name="Apertura" id="{4a212da7-d221-630e-7220-f1fee0c7da03}">
+        <p14:section name="Apertura" id="{47daa843-f69f-22aa-f7f7-0848da1ad14d}">
           <p14:sldIdLst>
             <p14:sldId id="256"/>
           </p14:sldIdLst>
         </p14:section>
-        <p14:section name="Metodologia" id="{5b9d2488-e8d7-70c1-76f6-951a56f1ba52}">
+        <p14:section name="Metodologia" id="{b60a9904-f983-0acb-fff8-c4e7b9e025e4}">
           <p14:sldIdLst>
             <p14:sldId id="257"/>
           </p14:sldIdLst>
         </p14:section>
-        <p14:section name="Analisi funzionale" id="{25a870c3-928c-a5f1-7e40-83c1518f59e7}">
+        <p14:section name="Analisi funzionale" id="{eb8bda65-fc9a-eade-0826-4215074b7768}">
           <p14:sldIdLst>
             <p14:sldId id="258"/>
             <p14:sldId id="259"/>
           </p14:sldIdLst>
         </p14:section>
-        <p14:section name="Già realtà" id="{62511de9-31fd-9504-1c98-06bdaff5e8ff}">
+        <p14:section name="Già realtà" id="{c8457c7b-bb06-e627-456c-f32fd4086dfa}">
           <p14:sldIdLst>
             <p14:sldId id="260"/>
           </p14:sldIdLst>
         </p14:section>
-        <p14:section name="Architettura e ruoli" id="{9412beb7-1b98-adb4-f50c-776da49f49d4}">
+        <p14:section name="Architettura e ruoli" id="{ff2c561e-367d-9676-a552-6dce728c617c}">
           <p14:sldIdLst>
             <p14:sldId id="261"/>
             <p14:sldId id="262"/>
           </p14:sldIdLst>
         </p14:section>
-        <p14:section name="Novità" id="{c9a5a7f7-8fe8-9150-65e8-659fa4f040da}">
+        <p14:section name="Novità" id="{c4aa8a66-57ab-ef8c-0859-ebdcab55f222}">
           <p14:sldIdLst>
             <p14:sldId id="263"/>
           </p14:sldIdLst>
         </p14:section>
-        <p14:section name="Punti aperti" id="{b71b4f52-6662-e2e7-0efd-648c6cd7445d}">
+        <p14:section name="Punti aperti" id="{6280b062-8f54-ea35-3473-c1aaa3db0928}">
           <p14:sldIdLst>
             <p14:sldId id="264"/>
             <p14:sldId id="265"/>
@@ -161,7 +161,7 @@
             <p14:sldId id="268"/>
           </p14:sldIdLst>
         </p14:section>
-        <p14:section name="Scelte da prendere" id="{54164ed9-bca7-fa62-3b73-f5d0259fa0a4}">
+        <p14:section name="Scelte da prendere" id="{cfb92953-455b-ee86-4f74-996429d80801}">
           <p14:sldIdLst>
             <p14:sldId id="269"/>
           </p14:sldIdLst>
@@ -570,7 +570,7 @@
           <a:p>
             <a:r>
               <a:rPr lang="en-US" dirty="0"/>
-              <a:t>Presentazione di riepilogo del portale, aggiornata al 21 ottobre 2026 (revisione 3.4): metodologia, funzioni realizzate, novità, punti aperti di sviluppo e scelte ancora da prendere. Si rigenera a ogni rilascio insieme agli altri documenti ed è disponibile agli Amministratori nella pagina Documentazione del portale.</a:t>
+              <a:t>Presentazione di riepilogo del portale, aggiornata al 22 ottobre 2026 (revisione 3.5): metodologia, funzioni realizzate, novità, punti aperti di sviluppo e scelte ancora da prendere. Si rigenera a ogni rilascio insieme agli altri documenti ed è disponibile agli Amministratori nella pagina Documentazione del portale.</a:t>
             </a:r>
             <a:endParaRPr lang="en-US" dirty="0"/>
           </a:p>
@@ -1362,7 +1362,7 @@
           <a:p>
             <a:r>
               <a:rPr lang="en-US" dirty="0"/>
-              <a:t>Pagina «effetto sorpresa»: nessuno si aspetta che il portale sia già online. Il sistema è stato realizzato da Luca Moretti con l'ausilio di Claude Code ed è quasi terminato; i servizi sono già in produzione: GitHub (codice), Vercel (pubblicazione del portale), Supabase (database, utenti, documenti, funzioni) e Resend (email). Il portale è pubblicato su portale-cwp.vercel.app e funziona con dati di prova: si può aprire durante la presentazione (collegamento cliccabile) o inquadrare il codice QR con il telefono. La pagina pubblica /programma mostra già gli 8 documenti ufficiali del Programma, la Metodologia approvata, la PEC e il soggetto promotore. Lo sviluppo del portale vero è partito il 17 ottobre 2026: da allora sono state pubblicate 154 versioni, 38 script del database e 7 funzioni sul server. Restano i punti aperti delle prossime slide (servizi a pagamento, sicurezza, dati da inserire, collaudo con un Comune). Suggerimento: aprire il portale dal vivo con un utente di prova e mostrare la pagina pubblica.</a:t>
+              <a:t>Pagina «effetto sorpresa»: nessuno si aspetta che il portale sia già online. Il sistema è stato realizzato da Luca Moretti con l'ausilio di Claude Code ed è quasi terminato; i servizi sono già in produzione: GitHub (codice), Vercel (pubblicazione del portale), Supabase (database, utenti, documenti, funzioni) e Resend (email). Il portale è pubblicato su portale-cwp.vercel.app e funziona con dati di prova: si può aprire durante la presentazione (collegamento cliccabile) o inquadrare il codice QR con il telefono. La pagina pubblica /programma mostra già gli 8 documenti ufficiali del Programma, la Metodologia approvata, la PEC e il soggetto promotore. Lo sviluppo del portale vero è partito il 17 ottobre 2026: da allora sono state pubblicate 156 versioni, 39 script del database e 7 funzioni sul server. Restano i punti aperti delle prossime slide (servizi a pagamento, sicurezza, dati da inserire, collaudo con un Comune). Suggerimento: aprire il portale dal vivo con un utente di prova e mostrare la pagina pubblica.</a:t>
             </a:r>
             <a:endParaRPr lang="en-US" dirty="0"/>
           </a:p>
@@ -2073,7 +2073,7 @@
                   <a:schemeClr val="accent6"/>
                 </a:solidFill>
               </a:rPr>
-              <a:t>Portale Carbon WastePrint · Stato dei lavori e recap · 21 ottobre 2026 · rev. 3.4</a:t>
+              <a:t>Portale Carbon WastePrint · Stato dei lavori e recap · 22 ottobre 2026 · rev. 3.5</a:t>
             </a:r>
             <a:endParaRPr lang="en-US" sz="1000" dirty="0"/>
           </a:p>
@@ -2571,7 +2571,7 @@
                   <a:schemeClr val="accent3"/>
                 </a:solidFill>
               </a:rPr>
-              <a:t>Stato dei lavori e recap: metodologia, funzioni, novità, punti aperti e scelte da prendere · aggiornata al 21 ottobre 2026 · rev. 3.4</a:t>
+              <a:t>Stato dei lavori e recap: metodologia, funzioni, novità, punti aperti e scelte da prendere · aggiornata al 22 ottobre 2026 · rev. 3.5</a:t>
             </a:r>
             <a:endParaRPr lang="en-US" sz="1800" dirty="0"/>
           </a:p>
@@ -12929,7 +12929,7 @@
                 <a:ea typeface="Cambria" pitchFamily="34" charset="-122"/>
                 <a:cs typeface="Cambria" pitchFamily="34" charset="-120"/>
               </a:rPr>
-              <a:t>38</a:t>
+              <a:t>39</a:t>
             </a:r>
             <a:endParaRPr lang="en-US" sz="3000" dirty="0"/>
           </a:p>
@@ -13235,7 +13235,7 @@
                 <a:ea typeface="Cambria" pitchFamily="34" charset="-122"/>
                 <a:cs typeface="Cambria" pitchFamily="34" charset="-120"/>
               </a:rPr>
-              <a:t>≈36.500</a:t>
+              <a:t>≈37.100</a:t>
             </a:r>
             <a:endParaRPr lang="en-US" sz="3000" dirty="0"/>
           </a:p>
@@ -14022,7 +14022,7 @@
                 <a:ea typeface="Cambria" pitchFamily="34" charset="-122"/>
                 <a:cs typeface="Cambria" pitchFamily="34" charset="-120"/>
               </a:rPr>
-              <a:t>154</a:t>
+              <a:t>156</a:t>
             </a:r>
             <a:endParaRPr lang="en-US" sz="2400" dirty="0"/>
           </a:p>
@@ -14075,7 +14075,7 @@
                 <a:ea typeface="Cambria" pitchFamily="34" charset="-122"/>
                 <a:cs typeface="Cambria" pitchFamily="34" charset="-120"/>
               </a:rPr>
-              <a:t>38</a:t>
+              <a:t>39</a:t>
             </a:r>
             <a:endParaRPr lang="en-US" sz="2400" dirty="0"/>
           </a:p>
@@ -14181,7 +14181,7 @@
                 <a:ea typeface="Cambria" pitchFamily="34" charset="-122"/>
                 <a:cs typeface="Cambria" pitchFamily="34" charset="-120"/>
               </a:rPr>
-              <a:t>≈36.500</a:t>
+              <a:t>≈37.100</a:t>
             </a:r>
             <a:endParaRPr lang="en-US" sz="2400" dirty="0"/>
           </a:p>
@@ -18184,7 +18184,7 @@
                   <a:schemeClr val="tx1"/>
                 </a:solidFill>
               </a:rPr>
-              <a:t>Collaudo in corso con 5 Amministratori: correzioni dei rapporti V01 e V05 in produzione il 20-21/10; restano le regole metodologiche da confermare</a:t>
+              <a:t>Collaudo in corso con 5 Amministratori: correzioni dei rapporti V01 e V05 in produzione il 20-21/10; rilievi N01-N06 (22/10) corretti su un ramo da rilasciare; restano le regole metodologiche da confermare</a:t>
             </a:r>
             <a:endParaRPr lang="en-US" sz="1350" dirty="0"/>
           </a:p>

</xml_diff>

<commit_message>
Documentazione aggiornata al 22/10: funzionalità per area, uso da telefono, stato del backup, presentazione, PDF e Word rigenerati, base di conoscenza
Co-Authored-By: Claude Opus 5.5 <noreply@anthropic.com>
Claude-Session: https://claude.ai/code/session_01E8XCbEeVHWVP3hntUZ6kZ1
</commit_message>
<xml_diff>
--- a/public/documentazione/Presentazione_Portale_CWP.pptx
+++ b/public/documentazione/Presentazione_Portale_CWP.pptx
@@ -120,39 +120,39 @@
   <p:extLst>
     <p:ext uri="{521415D9-36F7-43E2-AB2F-B90AF26B5E84}">
       <p14:sectionLst xmlns:p14="http://schemas.microsoft.com/office/powerpoint/2010/main">
-        <p14:section name="Apertura" id="{47daa843-f69f-22aa-f7f7-0848da1ad14d}">
+        <p14:section name="Apertura" id="{85e9868b-e0b4-7885-80df-cd364c70f8df}">
           <p14:sldIdLst>
             <p14:sldId id="256"/>
           </p14:sldIdLst>
         </p14:section>
-        <p14:section name="Metodologia" id="{b60a9904-f983-0acb-fff8-c4e7b9e025e4}">
+        <p14:section name="Metodologia" id="{1d8b734c-9c96-2e9b-2dd6-1d4b2da01bf2}">
           <p14:sldIdLst>
             <p14:sldId id="257"/>
           </p14:sldIdLst>
         </p14:section>
-        <p14:section name="Analisi funzionale" id="{eb8bda65-fc9a-eade-0826-4215074b7768}">
+        <p14:section name="Analisi funzionale" id="{755e2a8a-37f9-7fe0-9cdc-25d2a78a1602}">
           <p14:sldIdLst>
             <p14:sldId id="258"/>
             <p14:sldId id="259"/>
           </p14:sldIdLst>
         </p14:section>
-        <p14:section name="Già realtà" id="{c8457c7b-bb06-e627-456c-f32fd4086dfa}">
+        <p14:section name="Già realtà" id="{9f5e08a2-a28f-d1fb-bdd7-6a4ea925fdfe}">
           <p14:sldIdLst>
             <p14:sldId id="260"/>
           </p14:sldIdLst>
         </p14:section>
-        <p14:section name="Architettura e ruoli" id="{ff2c561e-367d-9676-a552-6dce728c617c}">
+        <p14:section name="Architettura e ruoli" id="{33fce3fb-f9a4-7bfb-a39b-59fe5a6ffa39}">
           <p14:sldIdLst>
             <p14:sldId id="261"/>
             <p14:sldId id="262"/>
           </p14:sldIdLst>
         </p14:section>
-        <p14:section name="Novità" id="{c4aa8a66-57ab-ef8c-0859-ebdcab55f222}">
+        <p14:section name="Novità" id="{06331929-8cc5-7233-e1ee-18f41cd60402}">
           <p14:sldIdLst>
             <p14:sldId id="263"/>
           </p14:sldIdLst>
         </p14:section>
-        <p14:section name="Punti aperti" id="{6280b062-8f54-ea35-3473-c1aaa3db0928}">
+        <p14:section name="Punti aperti" id="{9cc28a90-d165-2951-5877-409913f9e3d8}">
           <p14:sldIdLst>
             <p14:sldId id="264"/>
             <p14:sldId id="265"/>
@@ -161,7 +161,7 @@
             <p14:sldId id="268"/>
           </p14:sldIdLst>
         </p14:section>
-        <p14:section name="Scelte da prendere" id="{cfb92953-455b-ee86-4f74-996429d80801}">
+        <p14:section name="Scelte da prendere" id="{210268a0-f5c2-6777-6f7b-136941cb713a}">
           <p14:sldIdLst>
             <p14:sldId id="269"/>
           </p14:sldIdLst>
@@ -570,7 +570,7 @@
           <a:p>
             <a:r>
               <a:rPr lang="en-US" dirty="0"/>
-              <a:t>Presentazione di riepilogo del portale, aggiornata al 22 ottobre 2026 (revisione 3.5): metodologia, funzioni realizzate, novità, punti aperti di sviluppo e scelte ancora da prendere. Si rigenera a ogni rilascio insieme agli altri documenti ed è disponibile agli Amministratori nella pagina Documentazione del portale.</a:t>
+              <a:t>Presentazione di riepilogo del portale, aggiornata al 22 ottobre 2026 (revisione 3.6): metodologia, funzioni realizzate, novità, punti aperti di sviluppo e scelte ancora da prendere. Si rigenera a ogni rilascio insieme agli altri documenti ed è disponibile agli Amministratori nella pagina Documentazione del portale.</a:t>
             </a:r>
             <a:endParaRPr lang="en-US" dirty="0"/>
           </a:p>
@@ -1362,7 +1362,7 @@
           <a:p>
             <a:r>
               <a:rPr lang="en-US" dirty="0"/>
-              <a:t>Pagina «effetto sorpresa»: nessuno si aspetta che il portale sia già online. Il sistema è stato realizzato da Luca Moretti con l'ausilio di Claude Code ed è quasi terminato; i servizi sono già in produzione: GitHub (codice), Vercel (pubblicazione del portale), Supabase (database, utenti, documenti, funzioni) e Resend (email). Il portale è pubblicato su portale-cwp.vercel.app e funziona con dati di prova: si può aprire durante la presentazione (collegamento cliccabile) o inquadrare il codice QR con il telefono. La pagina pubblica /programma mostra già gli 8 documenti ufficiali del Programma, la Metodologia approvata, la PEC e il soggetto promotore. Lo sviluppo del portale vero è partito il 17 ottobre 2026: da allora sono state pubblicate 156 versioni, 39 script del database e 7 funzioni sul server. Restano i punti aperti delle prossime slide (servizi a pagamento, sicurezza, dati da inserire, collaudo con un Comune). Suggerimento: aprire il portale dal vivo con un utente di prova e mostrare la pagina pubblica.</a:t>
+              <a:t>Pagina «effetto sorpresa»: nessuno si aspetta che il portale sia già online. Il sistema è stato realizzato da Luca Moretti con l'ausilio di Claude Code ed è quasi terminato; i servizi sono già in produzione: GitHub (codice), Vercel (pubblicazione del portale), Supabase (database, utenti, documenti, funzioni) e Resend (email). Il portale è pubblicato su portale-cwp.vercel.app e funziona con dati di prova: si può aprire durante la presentazione (collegamento cliccabile) o inquadrare il codice QR con il telefono. La pagina pubblica /programma mostra già gli 8 documenti ufficiali del Programma, la Metodologia approvata, la PEC e il soggetto promotore. Lo sviluppo del portale vero è partito il 17 ottobre 2026: da allora sono state pubblicate 162 versioni, 39 script del database e 7 funzioni sul server. Restano i punti aperti delle prossime slide (servizi a pagamento, sicurezza, dati da inserire, collaudo con un Comune). Suggerimento: aprire il portale dal vivo con un utente di prova e mostrare la pagina pubblica.</a:t>
             </a:r>
             <a:endParaRPr lang="en-US" dirty="0"/>
           </a:p>
@@ -2073,7 +2073,7 @@
                   <a:schemeClr val="accent6"/>
                 </a:solidFill>
               </a:rPr>
-              <a:t>Portale Carbon WastePrint · Stato dei lavori e recap · 22 ottobre 2026 · rev. 3.5</a:t>
+              <a:t>Portale Carbon WastePrint · Stato dei lavori e recap · 22 ottobre 2026 · rev. 3.6</a:t>
             </a:r>
             <a:endParaRPr lang="en-US" sz="1000" dirty="0"/>
           </a:p>
@@ -2571,7 +2571,7 @@
                   <a:schemeClr val="accent3"/>
                 </a:solidFill>
               </a:rPr>
-              <a:t>Stato dei lavori e recap: metodologia, funzioni, novità, punti aperti e scelte da prendere · aggiornata al 22 ottobre 2026 · rev. 3.5</a:t>
+              <a:t>Stato dei lavori e recap: metodologia, funzioni, novità, punti aperti e scelte da prendere · aggiornata al 22 ottobre 2026 · rev. 3.6</a:t>
             </a:r>
             <a:endParaRPr lang="en-US" sz="1800" dirty="0"/>
           </a:p>
@@ -13235,7 +13235,7 @@
                 <a:ea typeface="Cambria" pitchFamily="34" charset="-122"/>
                 <a:cs typeface="Cambria" pitchFamily="34" charset="-120"/>
               </a:rPr>
-              <a:t>≈37.100</a:t>
+              <a:t>≈37.300</a:t>
             </a:r>
             <a:endParaRPr lang="en-US" sz="3000" dirty="0"/>
           </a:p>
@@ -14022,7 +14022,7 @@
                 <a:ea typeface="Cambria" pitchFamily="34" charset="-122"/>
                 <a:cs typeface="Cambria" pitchFamily="34" charset="-120"/>
               </a:rPr>
-              <a:t>156</a:t>
+              <a:t>162</a:t>
             </a:r>
             <a:endParaRPr lang="en-US" sz="2400" dirty="0"/>
           </a:p>
@@ -14181,7 +14181,7 @@
                 <a:ea typeface="Cambria" pitchFamily="34" charset="-122"/>
                 <a:cs typeface="Cambria" pitchFamily="34" charset="-120"/>
               </a:rPr>
-              <a:t>≈37.100</a:t>
+              <a:t>≈37.300</a:t>
             </a:r>
             <a:endParaRPr lang="en-US" sz="2400" dirty="0"/>
           </a:p>
@@ -17942,7 +17942,7 @@
                   <a:schemeClr val="tx1"/>
                 </a:solidFill>
               </a:rPr>
-              <a:t>Backup automatico completo ogni giorno alle 20 dal Mac nella cartella Drive Cwp › backup (Google blocca Apps Script) e istruzioni di ripristino provate; da fare ambiente di prova e monitoraggio errori</a:t>
+              <a:t>Backup automatico completo ogni giorno alle 20 dal Mac nella cartella Drive Cwp › backup (pronto, da installare sul Mac) e istruzioni di ripristino provate; da fare ambiente di prova e monitoraggio errori</a:t>
             </a:r>
             <a:endParaRPr lang="en-US" sz="1350" dirty="0"/>
           </a:p>
@@ -18184,7 +18184,7 @@
                   <a:schemeClr val="tx1"/>
                 </a:solidFill>
               </a:rPr>
-              <a:t>Collaudo in corso con 5 Amministratori: correzioni dei rapporti V01 e V05 in produzione il 20-21/10; rilievi N01-N06 (22/10) corretti su un ramo da rilasciare; restano le regole metodologiche da confermare</a:t>
+              <a:t>Collaudo in corso con 5 Amministratori: correzioni dei rapporti V01 e V05 in produzione il 20-21/10; rilievi N01-N06 (22/10) corretti e in produzione; restano le regole metodologiche da confermare</a:t>
             </a:r>
             <a:endParaRPr lang="en-US" sz="1350" dirty="0"/>
           </a:p>
@@ -18408,7 +18408,7 @@
                   <a:schemeClr val="tx1"/>
                 </a:solidFill>
               </a:rPr>
-              <a:t>Nuovi moduli: simulatore con PDF ed Excel, assistente virtuale (poi Operatori e aiuto sulla pratica), Audit User e utenti online (fatti il 20/10); Marketplaces da definire</a:t>
+              <a:t>Nuovi moduli: simulatore con PDF ed Excel, assistente virtuale (poi Operatori e aiuto sulla pratica), Audit User e utenti online (fatti il 20/10); navigazione da smartphone (22/10); Marketplaces da definire</a:t>
             </a:r>
             <a:endParaRPr lang="en-US" sz="1350" dirty="0"/>
           </a:p>

</xml_diff>

<commit_message>
Documentazione: utenze del passo 5a nel calcolo (manuali, test, registri, ripristino 01-41, presentazione, base di conoscenza)
Co-Authored-By: Claude Opus 5.5 <noreply@anthropic.com>
Claude-Session: https://claude.ai/code/session_01E8XCbEeVHWVP3hntUZ6kZ1
</commit_message>
<xml_diff>
--- a/public/documentazione/Presentazione_Portale_CWP.pptx
+++ b/public/documentazione/Presentazione_Portale_CWP.pptx
@@ -120,39 +120,39 @@
   <p:extLst>
     <p:ext uri="{521415D9-36F7-43E2-AB2F-B90AF26B5E84}">
       <p14:sectionLst xmlns:p14="http://schemas.microsoft.com/office/powerpoint/2010/main">
-        <p14:section name="Apertura" id="{85e9868b-e0b4-7885-80df-cd364c70f8df}">
+        <p14:section name="Apertura" id="{00d9e01a-b2a9-5dbc-cce0-782323e649ee}">
           <p14:sldIdLst>
             <p14:sldId id="256"/>
           </p14:sldIdLst>
         </p14:section>
-        <p14:section name="Metodologia" id="{1d8b734c-9c96-2e9b-2dd6-1d4b2da01bf2}">
+        <p14:section name="Metodologia" id="{31b25c3f-281e-41e6-63c8-58de32924162}">
           <p14:sldIdLst>
             <p14:sldId id="257"/>
           </p14:sldIdLst>
         </p14:section>
-        <p14:section name="Analisi funzionale" id="{755e2a8a-37f9-7fe0-9cdc-25d2a78a1602}">
+        <p14:section name="Analisi funzionale" id="{03598c86-10c2-a810-35bb-83a9ac1ed199}">
           <p14:sldIdLst>
             <p14:sldId id="258"/>
             <p14:sldId id="259"/>
           </p14:sldIdLst>
         </p14:section>
-        <p14:section name="Già realtà" id="{9f5e08a2-a28f-d1fb-bdd7-6a4ea925fdfe}">
+        <p14:section name="Già realtà" id="{a47f6021-85b7-3b84-6eec-6a3b93ef03c9}">
           <p14:sldIdLst>
             <p14:sldId id="260"/>
           </p14:sldIdLst>
         </p14:section>
-        <p14:section name="Architettura e ruoli" id="{33fce3fb-f9a4-7bfb-a39b-59fe5a6ffa39}">
+        <p14:section name="Architettura e ruoli" id="{c84ca814-bc87-14e9-e05e-d568e61a1e0d}">
           <p14:sldIdLst>
             <p14:sldId id="261"/>
             <p14:sldId id="262"/>
           </p14:sldIdLst>
         </p14:section>
-        <p14:section name="Novità" id="{06331929-8cc5-7233-e1ee-18f41cd60402}">
+        <p14:section name="Novità" id="{f669aacf-977b-a789-ceae-e5a4a5d99b3c}">
           <p14:sldIdLst>
             <p14:sldId id="263"/>
           </p14:sldIdLst>
         </p14:section>
-        <p14:section name="Punti aperti" id="{9cc28a90-d165-2951-5877-409913f9e3d8}">
+        <p14:section name="Punti aperti" id="{62e6af7d-d6d0-5dbb-3a02-93a2c5813e78}">
           <p14:sldIdLst>
             <p14:sldId id="264"/>
             <p14:sldId id="265"/>
@@ -161,7 +161,7 @@
             <p14:sldId id="268"/>
           </p14:sldIdLst>
         </p14:section>
-        <p14:section name="Scelte da prendere" id="{210268a0-f5c2-6777-6f7b-136941cb713a}">
+        <p14:section name="Scelte da prendere" id="{7529474b-85b4-b1ae-a7e0-3ab9b9833f12}">
           <p14:sldIdLst>
             <p14:sldId id="269"/>
           </p14:sldIdLst>
@@ -570,7 +570,7 @@
           <a:p>
             <a:r>
               <a:rPr lang="en-US" dirty="0"/>
-              <a:t>Presentazione di riepilogo del portale, aggiornata al 22 ottobre 2026 (revisione 3.6): metodologia, funzioni realizzate, novità, punti aperti di sviluppo e scelte ancora da prendere. Si rigenera a ogni rilascio insieme agli altri documenti ed è disponibile agli Amministratori nella pagina Documentazione del portale.</a:t>
+              <a:t>Presentazione di riepilogo del portale, aggiornata al 23 ottobre 2026 (revisione 3.7): metodologia, funzioni realizzate, novità, punti aperti di sviluppo e scelte ancora da prendere. Si rigenera a ogni rilascio insieme agli altri documenti ed è disponibile agli Amministratori nella pagina Documentazione del portale.</a:t>
             </a:r>
             <a:endParaRPr lang="en-US" dirty="0"/>
           </a:p>
@@ -1362,7 +1362,7 @@
           <a:p>
             <a:r>
               <a:rPr lang="en-US" dirty="0"/>
-              <a:t>Pagina «effetto sorpresa»: nessuno si aspetta che il portale sia già online. Il sistema è stato realizzato da Luca Moretti con l'ausilio di Claude Code ed è quasi terminato; i servizi sono già in produzione: GitHub (codice), Vercel (pubblicazione del portale), Supabase (database, utenti, documenti, funzioni) e Resend (email). Il portale è pubblicato su portale-cwp.vercel.app e funziona con dati di prova: si può aprire durante la presentazione (collegamento cliccabile) o inquadrare il codice QR con il telefono. La pagina pubblica /programma mostra già gli 8 documenti ufficiali del Programma, la Metodologia approvata, la PEC e il soggetto promotore. Lo sviluppo del portale vero è partito il 17 ottobre 2026: da allora sono state pubblicate 162 versioni, 39 script del database e 7 funzioni sul server. Restano i punti aperti delle prossime slide (servizi a pagamento, sicurezza, dati da inserire, collaudo con un Comune). Suggerimento: aprire il portale dal vivo con un utente di prova e mostrare la pagina pubblica.</a:t>
+              <a:t>Pagina «effetto sorpresa»: nessuno si aspetta che il portale sia già online. Il sistema è stato realizzato da Luca Moretti con l'ausilio di Claude Code ed è quasi terminato; i servizi sono già in produzione: GitHub (codice), Vercel (pubblicazione del portale), Supabase (database, utenti, documenti, funzioni) e Resend (email). Il portale è pubblicato su portale-cwp.vercel.app e funziona con dati di prova: si può aprire durante la presentazione (collegamento cliccabile) o inquadrare il codice QR con il telefono. La pagina pubblica /programma mostra già gli 8 documenti ufficiali del Programma, la Metodologia approvata, la PEC e il soggetto promotore. Lo sviluppo del portale vero è partito il 17 ottobre 2026: da allora sono state pubblicate 168 versioni, 41 script del database e 7 funzioni sul server. Restano i punti aperti delle prossime slide (servizi a pagamento, sicurezza, dati da inserire, collaudo con un Comune). Suggerimento: aprire il portale dal vivo con un utente di prova e mostrare la pagina pubblica.</a:t>
             </a:r>
             <a:endParaRPr lang="en-US" dirty="0"/>
           </a:p>
@@ -2073,7 +2073,7 @@
                   <a:schemeClr val="accent6"/>
                 </a:solidFill>
               </a:rPr>
-              <a:t>Portale Carbon WastePrint · Stato dei lavori e recap · 22 ottobre 2026 · rev. 3.6</a:t>
+              <a:t>Portale Carbon WastePrint · Stato dei lavori e recap · 23 ottobre 2026 · rev. 3.7</a:t>
             </a:r>
             <a:endParaRPr lang="en-US" sz="1000" dirty="0"/>
           </a:p>
@@ -2571,7 +2571,7 @@
                   <a:schemeClr val="accent3"/>
                 </a:solidFill>
               </a:rPr>
-              <a:t>Stato dei lavori e recap: metodologia, funzioni, novità, punti aperti e scelte da prendere · aggiornata al 22 ottobre 2026 · rev. 3.6</a:t>
+              <a:t>Stato dei lavori e recap: metodologia, funzioni, novità, punti aperti e scelte da prendere · aggiornata al 23 ottobre 2026 · rev. 3.7</a:t>
             </a:r>
             <a:endParaRPr lang="en-US" sz="1800" dirty="0"/>
           </a:p>
@@ -9250,7 +9250,7 @@
                   <a:schemeClr val="tx1"/>
                 </a:solidFill>
               </a:rPr>
-              <a:t>Dai conferimenti misurati di ogni utenza (Banca Dati Utenze), ex post</a:t>
+              <a:t>Dai kg misurati di ogni utenza (Banca Dati Utenze dell'anno), ex post</a:t>
             </a:r>
             <a:endParaRPr lang="en-US" sz="1800" dirty="0"/>
           </a:p>
@@ -12929,7 +12929,7 @@
                 <a:ea typeface="Cambria" pitchFamily="34" charset="-122"/>
                 <a:cs typeface="Cambria" pitchFamily="34" charset="-120"/>
               </a:rPr>
-              <a:t>39</a:t>
+              <a:t>41</a:t>
             </a:r>
             <a:endParaRPr lang="en-US" sz="3000" dirty="0"/>
           </a:p>
@@ -13235,7 +13235,7 @@
                 <a:ea typeface="Cambria" pitchFamily="34" charset="-122"/>
                 <a:cs typeface="Cambria" pitchFamily="34" charset="-120"/>
               </a:rPr>
-              <a:t>≈37.300</a:t>
+              <a:t>≈39.500</a:t>
             </a:r>
             <a:endParaRPr lang="en-US" sz="3000" dirty="0"/>
           </a:p>
@@ -14022,7 +14022,7 @@
                 <a:ea typeface="Cambria" pitchFamily="34" charset="-122"/>
                 <a:cs typeface="Cambria" pitchFamily="34" charset="-120"/>
               </a:rPr>
-              <a:t>162</a:t>
+              <a:t>168</a:t>
             </a:r>
             <a:endParaRPr lang="en-US" sz="2400" dirty="0"/>
           </a:p>
@@ -14075,7 +14075,7 @@
                 <a:ea typeface="Cambria" pitchFamily="34" charset="-122"/>
                 <a:cs typeface="Cambria" pitchFamily="34" charset="-120"/>
               </a:rPr>
-              <a:t>39</a:t>
+              <a:t>41</a:t>
             </a:r>
             <a:endParaRPr lang="en-US" sz="2400" dirty="0"/>
           </a:p>
@@ -14181,7 +14181,7 @@
                 <a:ea typeface="Cambria" pitchFamily="34" charset="-122"/>
                 <a:cs typeface="Cambria" pitchFamily="34" charset="-120"/>
               </a:rPr>
-              <a:t>≈37.300</a:t>
+              <a:t>≈39.500</a:t>
             </a:r>
             <a:endParaRPr lang="en-US" sz="2400" dirty="0"/>
           </a:p>
@@ -15590,7 +15590,7 @@
                   <a:schemeClr val="tx1"/>
                 </a:solidFill>
               </a:rPr>
-              <a:t>Banca Dati Utenze solo con codici anonimi</a:t>
+              <a:t>Banca Dati Utenze: nomi visibili solo allo staff, ogni consultazione nell'audit</a:t>
             </a:r>
             <a:endParaRPr lang="en-US" sz="1200" dirty="0"/>
           </a:p>
@@ -18408,7 +18408,7 @@
                   <a:schemeClr val="tx1"/>
                 </a:solidFill>
               </a:rPr>
-              <a:t>Nuovi moduli: simulatore con PDF ed Excel, assistente virtuale (poi Operatori e aiuto sulla pratica), Audit User e utenti online (fatti il 20/10); navigazione da smartphone (22/10); Marketplaces da definire</a:t>
+              <a:t>Nuovi moduli: simulatore con PDF ed Excel, assistente virtuale (poi Operatori e aiuto sulla pratica), Audit User e utenti online (fatti il 20/10); navigazione da smartphone (22/10); Banca Dati Utenze per utenza nel calcolo (22-23/10); Marketplaces da definire</a:t>
             </a:r>
             <a:endParaRPr lang="en-US" sz="1350" dirty="0"/>
           </a:p>

</xml_diff>

<commit_message>
Documentazione: valore dei crediti nella Dashboard (manuali, test 10.10m-p, registri, ripristino 01-42, presentazione)
Co-Authored-By: Claude Opus 5.5 <noreply@anthropic.com>
Claude-Session: https://claude.ai/code/session_01E8XCbEeVHWVP3hntUZ6kZ1
</commit_message>
<xml_diff>
--- a/public/documentazione/Presentazione_Portale_CWP.pptx
+++ b/public/documentazione/Presentazione_Portale_CWP.pptx
@@ -120,39 +120,39 @@
   <p:extLst>
     <p:ext uri="{521415D9-36F7-43E2-AB2F-B90AF26B5E84}">
       <p14:sectionLst xmlns:p14="http://schemas.microsoft.com/office/powerpoint/2010/main">
-        <p14:section name="Apertura" id="{00d9e01a-b2a9-5dbc-cce0-782323e649ee}">
+        <p14:section name="Apertura" id="{2f10fc11-3f19-a0fd-2fae-7751656cb15a}">
           <p14:sldIdLst>
             <p14:sldId id="256"/>
           </p14:sldIdLst>
         </p14:section>
-        <p14:section name="Metodologia" id="{31b25c3f-281e-41e6-63c8-58de32924162}">
+        <p14:section name="Metodologia" id="{65d0dc4b-f875-12e2-c0c9-5cc299a1027e}">
           <p14:sldIdLst>
             <p14:sldId id="257"/>
           </p14:sldIdLst>
         </p14:section>
-        <p14:section name="Analisi funzionale" id="{03598c86-10c2-a810-35bb-83a9ac1ed199}">
+        <p14:section name="Analisi funzionale" id="{42d85fcd-c7ef-9c32-039c-5dbff3bbe675}">
           <p14:sldIdLst>
             <p14:sldId id="258"/>
             <p14:sldId id="259"/>
           </p14:sldIdLst>
         </p14:section>
-        <p14:section name="Già realtà" id="{a47f6021-85b7-3b84-6eec-6a3b93ef03c9}">
+        <p14:section name="Già realtà" id="{a393900a-0a23-1111-4766-57a69911a0e9}">
           <p14:sldIdLst>
             <p14:sldId id="260"/>
           </p14:sldIdLst>
         </p14:section>
-        <p14:section name="Architettura e ruoli" id="{c84ca814-bc87-14e9-e05e-d568e61a1e0d}">
+        <p14:section name="Architettura e ruoli" id="{c131fd75-63c1-f8c9-ef25-a2f383bdaf16}">
           <p14:sldIdLst>
             <p14:sldId id="261"/>
             <p14:sldId id="262"/>
           </p14:sldIdLst>
         </p14:section>
-        <p14:section name="Novità" id="{f669aacf-977b-a789-ceae-e5a4a5d99b3c}">
+        <p14:section name="Novità" id="{86497412-54fc-7955-90be-c3e6a6b0fc94}">
           <p14:sldIdLst>
             <p14:sldId id="263"/>
           </p14:sldIdLst>
         </p14:section>
-        <p14:section name="Punti aperti" id="{62e6af7d-d6d0-5dbb-3a02-93a2c5813e78}">
+        <p14:section name="Punti aperti" id="{e73e0be0-ee22-5dfd-0bc1-1ac11e9858df}">
           <p14:sldIdLst>
             <p14:sldId id="264"/>
             <p14:sldId id="265"/>
@@ -161,7 +161,7 @@
             <p14:sldId id="268"/>
           </p14:sldIdLst>
         </p14:section>
-        <p14:section name="Scelte da prendere" id="{7529474b-85b4-b1ae-a7e0-3ab9b9833f12}">
+        <p14:section name="Scelte da prendere" id="{d43f38ea-4fbf-427d-414e-d2651163f101}">
           <p14:sldIdLst>
             <p14:sldId id="269"/>
           </p14:sldIdLst>
@@ -570,7 +570,7 @@
           <a:p>
             <a:r>
               <a:rPr lang="en-US" dirty="0"/>
-              <a:t>Presentazione di riepilogo del portale, aggiornata al 23 ottobre 2026 (revisione 3.7): metodologia, funzioni realizzate, novità, punti aperti di sviluppo e scelte ancora da prendere. Si rigenera a ogni rilascio insieme agli altri documenti ed è disponibile agli Amministratori nella pagina Documentazione del portale.</a:t>
+              <a:t>Presentazione di riepilogo del portale, aggiornata al 23 ottobre 2026 (revisione 3.8): metodologia, funzioni realizzate, novità, punti aperti di sviluppo e scelte ancora da prendere. Si rigenera a ogni rilascio insieme agli altri documenti ed è disponibile agli Amministratori nella pagina Documentazione del portale.</a:t>
             </a:r>
             <a:endParaRPr lang="en-US" dirty="0"/>
           </a:p>
@@ -1362,7 +1362,7 @@
           <a:p>
             <a:r>
               <a:rPr lang="en-US" dirty="0"/>
-              <a:t>Pagina «effetto sorpresa»: nessuno si aspetta che il portale sia già online. Il sistema è stato realizzato da Luca Moretti con l'ausilio di Claude Code ed è quasi terminato; i servizi sono già in produzione: GitHub (codice), Vercel (pubblicazione del portale), Supabase (database, utenti, documenti, funzioni) e Resend (email). Il portale è pubblicato su portale-cwp.vercel.app e funziona con dati di prova: si può aprire durante la presentazione (collegamento cliccabile) o inquadrare il codice QR con il telefono. La pagina pubblica /programma mostra già gli 8 documenti ufficiali del Programma, la Metodologia approvata, la PEC e il soggetto promotore. Lo sviluppo del portale vero è partito il 17 ottobre 2026: da allora sono state pubblicate 168 versioni, 41 script del database e 7 funzioni sul server. Restano i punti aperti delle prossime slide (servizi a pagamento, sicurezza, dati da inserire, collaudo con un Comune). Suggerimento: aprire il portale dal vivo con un utente di prova e mostrare la pagina pubblica.</a:t>
+              <a:t>Pagina «effetto sorpresa»: nessuno si aspetta che il portale sia già online. Il sistema è stato realizzato da Luca Moretti con l'ausilio di Claude Code ed è quasi terminato; i servizi sono già in produzione: GitHub (codice), Vercel (pubblicazione del portale), Supabase (database, utenti, documenti, funzioni) e Resend (email). Il portale è pubblicato su portale-cwp.vercel.app e funziona con dati di prova: si può aprire durante la presentazione (collegamento cliccabile) o inquadrare il codice QR con il telefono. La pagina pubblica /programma mostra già gli 8 documenti ufficiali del Programma, la Metodologia approvata, la PEC e il soggetto promotore. Lo sviluppo del portale vero è partito il 17 ottobre 2026: da allora sono state pubblicate 172 versioni, 42 script del database e 7 funzioni sul server. Restano i punti aperti delle prossime slide (servizi a pagamento, sicurezza, dati da inserire, collaudo con un Comune). Suggerimento: aprire il portale dal vivo con un utente di prova e mostrare la pagina pubblica.</a:t>
             </a:r>
             <a:endParaRPr lang="en-US" dirty="0"/>
           </a:p>
@@ -2073,7 +2073,7 @@
                   <a:schemeClr val="accent6"/>
                 </a:solidFill>
               </a:rPr>
-              <a:t>Portale Carbon WastePrint · Stato dei lavori e recap · 23 ottobre 2026 · rev. 3.7</a:t>
+              <a:t>Portale Carbon WastePrint · Stato dei lavori e recap · 23 ottobre 2026 · rev. 3.8</a:t>
             </a:r>
             <a:endParaRPr lang="en-US" sz="1000" dirty="0"/>
           </a:p>
@@ -2571,7 +2571,7 @@
                   <a:schemeClr val="accent3"/>
                 </a:solidFill>
               </a:rPr>
-              <a:t>Stato dei lavori e recap: metodologia, funzioni, novità, punti aperti e scelte da prendere · aggiornata al 23 ottobre 2026 · rev. 3.7</a:t>
+              <a:t>Stato dei lavori e recap: metodologia, funzioni, novità, punti aperti e scelte da prendere · aggiornata al 23 ottobre 2026 · rev. 3.8</a:t>
             </a:r>
             <a:endParaRPr lang="en-US" sz="1800" dirty="0"/>
           </a:p>
@@ -12929,7 +12929,7 @@
                 <a:ea typeface="Cambria" pitchFamily="34" charset="-122"/>
                 <a:cs typeface="Cambria" pitchFamily="34" charset="-120"/>
               </a:rPr>
-              <a:t>41</a:t>
+              <a:t>42</a:t>
             </a:r>
             <a:endParaRPr lang="en-US" sz="3000" dirty="0"/>
           </a:p>
@@ -13235,7 +13235,7 @@
                 <a:ea typeface="Cambria" pitchFamily="34" charset="-122"/>
                 <a:cs typeface="Cambria" pitchFamily="34" charset="-120"/>
               </a:rPr>
-              <a:t>≈39.500</a:t>
+              <a:t>≈39.900</a:t>
             </a:r>
             <a:endParaRPr lang="en-US" sz="3000" dirty="0"/>
           </a:p>
@@ -14022,7 +14022,7 @@
                 <a:ea typeface="Cambria" pitchFamily="34" charset="-122"/>
                 <a:cs typeface="Cambria" pitchFamily="34" charset="-120"/>
               </a:rPr>
-              <a:t>168</a:t>
+              <a:t>172</a:t>
             </a:r>
             <a:endParaRPr lang="en-US" sz="2400" dirty="0"/>
           </a:p>
@@ -14075,7 +14075,7 @@
                 <a:ea typeface="Cambria" pitchFamily="34" charset="-122"/>
                 <a:cs typeface="Cambria" pitchFamily="34" charset="-120"/>
               </a:rPr>
-              <a:t>41</a:t>
+              <a:t>42</a:t>
             </a:r>
             <a:endParaRPr lang="en-US" sz="2400" dirty="0"/>
           </a:p>
@@ -14181,7 +14181,7 @@
                 <a:ea typeface="Cambria" pitchFamily="34" charset="-122"/>
                 <a:cs typeface="Cambria" pitchFamily="34" charset="-120"/>
               </a:rPr>
-              <a:t>≈39.500</a:t>
+              <a:t>≈39.900</a:t>
             </a:r>
             <a:endParaRPr lang="en-US" sz="2400" dirty="0"/>
           </a:p>
@@ -18408,7 +18408,7 @@
                   <a:schemeClr val="tx1"/>
                 </a:solidFill>
               </a:rPr>
-              <a:t>Nuovi moduli: simulatore con PDF ed Excel, assistente virtuale (poi Operatori e aiuto sulla pratica), Audit User e utenti online (fatti il 20/10); navigazione da smartphone (22/10); Banca Dati Utenze per utenza nel calcolo (22-23/10); Marketplaces da definire</a:t>
+              <a:t>Nuovi moduli: simulatore con PDF ed Excel, assistente virtuale (poi Operatori e aiuto sulla pratica), Audit User e utenti online (fatti il 20/10); navigazione da smartphone (22/10); Banca Dati Utenze per utenza nel calcolo (22-23/10); valore dei crediti in Dashboard (23/10); Marketplaces da definire</a:t>
             </a:r>
             <a:endParaRPr lang="en-US" sz="1350" dirty="0"/>
           </a:p>

</xml_diff>

<commit_message>
Documentazione: valore dei progetti e listino Caso 1 / Caso 2 (manuali, test 10.10q-s, registri, ripristino 01-43, presentazione)
Co-Authored-By: Claude Opus 5.5 <noreply@anthropic.com>
Claude-Session: https://claude.ai/code/session_01E8XCbEeVHWVP3hntUZ6kZ1
</commit_message>
<xml_diff>
--- a/public/documentazione/Presentazione_Portale_CWP.pptx
+++ b/public/documentazione/Presentazione_Portale_CWP.pptx
@@ -121,40 +121,40 @@
   <p:extLst>
     <p:ext uri="{521415D9-36F7-43E2-AB2F-B90AF26B5E84}">
       <p14:sectionLst xmlns:p14="http://schemas.microsoft.com/office/powerpoint/2010/main">
-        <p14:section name="Apertura" id="{c764f858-4a5a-cbcf-bbff-53ca1659af27}">
+        <p14:section name="Apertura" id="{72dcf85d-d1b3-032d-7c76-5762c9d9b1f2}">
           <p14:sldIdLst>
             <p14:sldId id="256"/>
           </p14:sldIdLst>
         </p14:section>
-        <p14:section name="Metodologia" id="{3ca88c82-d409-4ff8-8c0b-c0ecb883c577}">
+        <p14:section name="Metodologia" id="{704cd747-cd24-4d94-fc55-a5156337ede7}">
           <p14:sldIdLst>
             <p14:sldId id="257"/>
           </p14:sldIdLst>
         </p14:section>
-        <p14:section name="Analisi funzionale" id="{bbcfda94-a260-b3d0-505b-ee8a3d6d6090}">
+        <p14:section name="Analisi funzionale" id="{7aea13a9-ba6d-b47b-7275-2fbdacd2e1a8}">
           <p14:sldIdLst>
             <p14:sldId id="258"/>
             <p14:sldId id="259"/>
           </p14:sldIdLst>
         </p14:section>
-        <p14:section name="Già realtà" id="{43986d8e-6acf-ed87-8fcc-2a110d69635b}">
+        <p14:section name="Già realtà" id="{f8fa33dd-19da-1cb8-c46b-644204232470}">
           <p14:sldIdLst>
             <p14:sldId id="260"/>
           </p14:sldIdLst>
         </p14:section>
-        <p14:section name="Architettura e ruoli" id="{0d8cd8b9-9e97-a6ef-7cc5-ed3579b81464}">
+        <p14:section name="Architettura e ruoli" id="{c391fc6a-bae1-76c8-05c0-3d7eab2e638b}">
           <p14:sldIdLst>
             <p14:sldId id="261"/>
             <p14:sldId id="262"/>
           </p14:sldIdLst>
         </p14:section>
-        <p14:section name="Novità" id="{39a78928-7fc8-384a-90d6-d3b0de56b63c}">
+        <p14:section name="Novità" id="{e8151675-4c11-0eda-fb5b-a4fe0bb7e986}">
           <p14:sldIdLst>
             <p14:sldId id="263"/>
             <p14:sldId id="264"/>
           </p14:sldIdLst>
         </p14:section>
-        <p14:section name="Punti aperti" id="{86fb6a3f-d7cd-7057-ae3e-fde3dd5ab4e1}">
+        <p14:section name="Punti aperti" id="{23d060e4-995d-e197-4ee6-318309b81da3}">
           <p14:sldIdLst>
             <p14:sldId id="265"/>
             <p14:sldId id="266"/>
@@ -163,7 +163,7 @@
             <p14:sldId id="269"/>
           </p14:sldIdLst>
         </p14:section>
-        <p14:section name="Scelte da prendere" id="{d21a8fa7-dcda-c6be-5f4e-588fc6abe770}">
+        <p14:section name="Scelte da prendere" id="{f234ab9a-4333-25d8-2094-c4a115f64894}">
           <p14:sldIdLst>
             <p14:sldId id="270"/>
           </p14:sldIdLst>
@@ -572,7 +572,7 @@
           <a:p>
             <a:r>
               <a:rPr lang="en-US" dirty="0"/>
-              <a:t>Presentazione di riepilogo del portale, aggiornata al 23 ottobre 2026 (revisione 3.9): metodologia, funzioni realizzate, novità, punti aperti di sviluppo e scelte ancora da prendere. Si rigenera a ogni rilascio insieme agli altri documenti ed è disponibile agli Amministratori nella pagina Documentazione del portale.</a:t>
+              <a:t>Presentazione di riepilogo del portale, aggiornata al 23 ottobre 2026 (revisione 4.0): metodologia, funzioni realizzate, novità, punti aperti di sviluppo e scelte ancora da prendere. Si rigenera a ogni rilascio insieme agli altri documenti ed è disponibile agli Amministratori nella pagina Documentazione del portale.</a:t>
             </a:r>
             <a:endParaRPr lang="en-US" dirty="0"/>
           </a:p>
@@ -1452,7 +1452,7 @@
           <a:p>
             <a:r>
               <a:rPr lang="en-US" dirty="0"/>
-              <a:t>Pagina «effetto sorpresa»: nessuno si aspetta che il portale sia già online. Il sistema è stato realizzato da Luca Moretti con l'ausilio di Claude Code ed è quasi terminato; i servizi sono già in produzione: GitHub (codice), Vercel (pubblicazione del portale), Supabase (database, utenti, documenti, funzioni) e Resend (email). Il portale è pubblicato su portale-cwp.vercel.app e funziona con dati di prova: si può aprire durante la presentazione (collegamento cliccabile) o inquadrare il codice QR con il telefono. La pagina pubblica /programma mostra già gli 8 documenti ufficiali del Programma, la Metodologia approvata, la PEC e il soggetto promotore. Lo sviluppo del portale vero è partito il 17 ottobre 2026: da allora sono state pubblicate 175 versioni, 42 script del database e 7 funzioni sul server. Restano i punti aperti delle prossime slide (servizi a pagamento, sicurezza, dati da inserire, collaudo con un Comune). Suggerimento: aprire il portale dal vivo con un utente di prova e mostrare la pagina pubblica.</a:t>
+              <a:t>Pagina «effetto sorpresa»: nessuno si aspetta che il portale sia già online. Il sistema è stato realizzato da Luca Moretti con l'ausilio di Claude Code ed è quasi terminato; i servizi sono già in produzione: GitHub (codice), Vercel (pubblicazione del portale), Supabase (database, utenti, documenti, funzioni) e Resend (email). Il portale è pubblicato su portale-cwp.vercel.app e funziona con dati di prova: si può aprire durante la presentazione (collegamento cliccabile) o inquadrare il codice QR con il telefono. La pagina pubblica /programma mostra già gli 8 documenti ufficiali del Programma, la Metodologia approvata, la PEC e il soggetto promotore. Lo sviluppo del portale vero è partito il 17 ottobre 2026: da allora sono state pubblicate 177 versioni, 43 script del database e 7 funzioni sul server. Restano i punti aperti delle prossime slide (servizi a pagamento, sicurezza, dati da inserire, collaudo con un Comune). Suggerimento: aprire il portale dal vivo con un utente di prova e mostrare la pagina pubblica.</a:t>
             </a:r>
             <a:endParaRPr lang="en-US" dirty="0"/>
           </a:p>
@@ -2163,7 +2163,7 @@
                   <a:schemeClr val="accent6"/>
                 </a:solidFill>
               </a:rPr>
-              <a:t>Portale Carbon WastePrint · Stato dei lavori e recap · 23 ottobre 2026 · rev. 3.9</a:t>
+              <a:t>Portale Carbon WastePrint · Stato dei lavori e recap · 23 ottobre 2026 · rev. 4.0</a:t>
             </a:r>
             <a:endParaRPr lang="en-US" sz="1000" dirty="0"/>
           </a:p>
@@ -2661,7 +2661,7 @@
                   <a:schemeClr val="accent3"/>
                 </a:solidFill>
               </a:rPr>
-              <a:t>Stato dei lavori e recap: metodologia, funzioni, novità, punti aperti e scelte da prendere · aggiornata al 23 ottobre 2026 · rev. 3.9</a:t>
+              <a:t>Stato dei lavori e recap: metodologia, funzioni, novità, punti aperti e scelte da prendere · aggiornata al 23 ottobre 2026 · rev. 4.0</a:t>
             </a:r>
             <a:endParaRPr lang="en-US" sz="1800" dirty="0"/>
           </a:p>
@@ -13802,7 +13802,7 @@
                 <a:ea typeface="Cambria" pitchFamily="34" charset="-122"/>
                 <a:cs typeface="Cambria" pitchFamily="34" charset="-120"/>
               </a:rPr>
-              <a:t>42</a:t>
+              <a:t>43</a:t>
             </a:r>
             <a:endParaRPr lang="en-US" sz="3000" dirty="0"/>
           </a:p>
@@ -14108,7 +14108,7 @@
                 <a:ea typeface="Cambria" pitchFamily="34" charset="-122"/>
                 <a:cs typeface="Cambria" pitchFamily="34" charset="-120"/>
               </a:rPr>
-              <a:t>≈40.000</a:t>
+              <a:t>≈40.400</a:t>
             </a:r>
             <a:endParaRPr lang="en-US" sz="3000" dirty="0"/>
           </a:p>
@@ -14895,7 +14895,7 @@
                 <a:ea typeface="Cambria" pitchFamily="34" charset="-122"/>
                 <a:cs typeface="Cambria" pitchFamily="34" charset="-120"/>
               </a:rPr>
-              <a:t>175</a:t>
+              <a:t>177</a:t>
             </a:r>
             <a:endParaRPr lang="en-US" sz="2400" dirty="0"/>
           </a:p>
@@ -14948,7 +14948,7 @@
                 <a:ea typeface="Cambria" pitchFamily="34" charset="-122"/>
                 <a:cs typeface="Cambria" pitchFamily="34" charset="-120"/>
               </a:rPr>
-              <a:t>42</a:t>
+              <a:t>43</a:t>
             </a:r>
             <a:endParaRPr lang="en-US" sz="2400" dirty="0"/>
           </a:p>
@@ -15054,7 +15054,7 @@
                 <a:ea typeface="Cambria" pitchFamily="34" charset="-122"/>
                 <a:cs typeface="Cambria" pitchFamily="34" charset="-120"/>
               </a:rPr>
-              <a:t>≈40.000</a:t>
+              <a:t>≈40.400</a:t>
             </a:r>
             <a:endParaRPr lang="en-US" sz="2400" dirty="0"/>
           </a:p>
@@ -18831,7 +18831,7 @@
       </p:sp>
       <p:sp>
         <p:nvSpPr>
-          <p:cNvPr id="9" name="Valore crediti Chi vede"/>
+          <p:cNvPr id="9" name="Valore crediti Valore progetti"/>
           <p:cNvSpPr/>
           <p:nvPr/>
         </p:nvSpPr>
@@ -18886,7 +18886,7 @@
                   <a:schemeClr val="tx2"/>
                 </a:solidFill>
               </a:rPr>
-              <a:t>Chi vede</a:t>
+              <a:t>Valore progetti</a:t>
             </a:r>
             <a:endParaRPr lang="en-US" sz="1300" dirty="0"/>
           </a:p>
@@ -18900,7 +18900,7 @@
                   <a:schemeClr val="tx1"/>
                 </a:solidFill>
               </a:rPr>
-              <a:t>staff: tutto; Comuni: solo i propri dati</a:t>
+              <a:t>quanto paga il cliente, listino Caso 1 o Caso 2 scelto sul Progetto</a:t>
             </a:r>
             <a:endParaRPr lang="en-US" sz="1300" dirty="0"/>
           </a:p>
@@ -19128,7 +19128,7 @@
                   <a:schemeClr val="tx1"/>
                 </a:solidFill>
               </a:rPr>
-              <a:t>fasi aperte senza scadenza (22/10); valore dei crediti in simulazione e in fase esecutiva, anche per i Comuni (23/10)</a:t>
+              <a:t>fasi aperte senza scadenza (22/10); valore dei crediti in simulazione e in fase esecutiva e valore dei progetti per il cliente (Caso 1 / Caso 2), anche per i Comuni (23/10)</a:t>
             </a:r>
             <a:endParaRPr lang="en-US" sz="1350" dirty="0"/>
           </a:p>

</xml_diff>

<commit_message>
Registro: script 34 (avvisi di sicurezza e rinforzi del database) eseguito in produzione
Co-Authored-By: Claude Opus 5.5 <noreply@anthropic.com>
Claude-Session: https://claude.ai/code/session_01E8XCbEeVHWVP3hntUZ6kZ1
</commit_message>
<xml_diff>
--- a/public/documentazione/Presentazione_Portale_CWP.pptx
+++ b/public/documentazione/Presentazione_Portale_CWP.pptx
@@ -121,40 +121,40 @@
   <p:extLst>
     <p:ext uri="{521415D9-36F7-43E2-AB2F-B90AF26B5E84}">
       <p14:sectionLst xmlns:p14="http://schemas.microsoft.com/office/powerpoint/2010/main">
-        <p14:section name="Apertura" id="{72dcf85d-d1b3-032d-7c76-5762c9d9b1f2}">
+        <p14:section name="Apertura" id="{ab7f772b-eaa9-c682-a236-5bf276f299e1}">
           <p14:sldIdLst>
             <p14:sldId id="256"/>
           </p14:sldIdLst>
         </p14:section>
-        <p14:section name="Metodologia" id="{704cd747-cd24-4d94-fc55-a5156337ede7}">
+        <p14:section name="Metodologia" id="{db415f9e-c6ef-3617-8ea1-15d7a68210d0}">
           <p14:sldIdLst>
             <p14:sldId id="257"/>
           </p14:sldIdLst>
         </p14:section>
-        <p14:section name="Analisi funzionale" id="{7aea13a9-ba6d-b47b-7275-2fbdacd2e1a8}">
+        <p14:section name="Analisi funzionale" id="{fd7457d8-2871-2021-c028-e33cb683b963}">
           <p14:sldIdLst>
             <p14:sldId id="258"/>
             <p14:sldId id="259"/>
           </p14:sldIdLst>
         </p14:section>
-        <p14:section name="Già realtà" id="{f8fa33dd-19da-1cb8-c46b-644204232470}">
+        <p14:section name="Già realtà" id="{483d5720-a03f-6822-61aa-be8002a18705}">
           <p14:sldIdLst>
             <p14:sldId id="260"/>
           </p14:sldIdLst>
         </p14:section>
-        <p14:section name="Architettura e ruoli" id="{c391fc6a-bae1-76c8-05c0-3d7eab2e638b}">
+        <p14:section name="Architettura e ruoli" id="{622658ce-dfb4-d77d-0d88-4d5cf0c943ce}">
           <p14:sldIdLst>
             <p14:sldId id="261"/>
             <p14:sldId id="262"/>
           </p14:sldIdLst>
         </p14:section>
-        <p14:section name="Novità" id="{e8151675-4c11-0eda-fb5b-a4fe0bb7e986}">
+        <p14:section name="Novità" id="{e7ed4f45-2a0d-1eec-3955-d5b8be70ee41}">
           <p14:sldIdLst>
             <p14:sldId id="263"/>
             <p14:sldId id="264"/>
           </p14:sldIdLst>
         </p14:section>
-        <p14:section name="Punti aperti" id="{23d060e4-995d-e197-4ee6-318309b81da3}">
+        <p14:section name="Punti aperti" id="{8fca7313-d2cc-8321-10de-3d8f603bdbf0}">
           <p14:sldIdLst>
             <p14:sldId id="265"/>
             <p14:sldId id="266"/>
@@ -163,7 +163,7 @@
             <p14:sldId id="269"/>
           </p14:sldIdLst>
         </p14:section>
-        <p14:section name="Scelte da prendere" id="{f234ab9a-4333-25d8-2094-c4a115f64894}">
+        <p14:section name="Scelte da prendere" id="{31621a20-137b-afe1-dc45-c04d392925ad}">
           <p14:sldIdLst>
             <p14:sldId id="270"/>
           </p14:sldIdLst>
@@ -1452,7 +1452,7 @@
           <a:p>
             <a:r>
               <a:rPr lang="en-US" dirty="0"/>
-              <a:t>Pagina «effetto sorpresa»: nessuno si aspetta che il portale sia già online. Il sistema è stato realizzato da Luca Moretti con l'ausilio di Claude Code ed è quasi terminato; i servizi sono già in produzione: GitHub (codice), Vercel (pubblicazione del portale), Supabase (database, utenti, documenti, funzioni) e Resend (email). Il portale è pubblicato su portale-cwp.vercel.app e funziona con dati di prova: si può aprire durante la presentazione (collegamento cliccabile) o inquadrare il codice QR con il telefono. La pagina pubblica /programma mostra già gli 8 documenti ufficiali del Programma, la Metodologia approvata, la PEC e il soggetto promotore. Lo sviluppo del portale vero è partito il 17 ottobre 2026: da allora sono state pubblicate 177 versioni, 43 script del database e 7 funzioni sul server. Restano i punti aperti delle prossime slide (servizi a pagamento, sicurezza, dati da inserire, collaudo con un Comune). Suggerimento: aprire il portale dal vivo con un utente di prova e mostrare la pagina pubblica.</a:t>
+              <a:t>Pagina «effetto sorpresa»: nessuno si aspetta che il portale sia già online. Il sistema è stato realizzato da Luca Moretti con l'ausilio di Claude Code ed è quasi terminato; i servizi sono già in produzione: GitHub (codice), Vercel (pubblicazione del portale), Supabase (database, utenti, documenti, funzioni) e Resend (email). Il portale è pubblicato su portale-cwp.vercel.app e funziona con dati di prova: si può aprire durante la presentazione (collegamento cliccabile) o inquadrare il codice QR con il telefono. La pagina pubblica /programma mostra già gli 8 documenti ufficiali del Programma, la Metodologia approvata, la PEC e il soggetto promotore. Lo sviluppo del portale vero è partito il 17 ottobre 2026: da allora sono state pubblicate 182 versioni, 43 script del database e 7 funzioni sul server. Restano i punti aperti delle prossime slide (servizi a pagamento, sicurezza, dati da inserire, collaudo con un Comune). Suggerimento: aprire il portale dal vivo con un utente di prova e mostrare la pagina pubblica.</a:t>
             </a:r>
             <a:endParaRPr lang="en-US" dirty="0"/>
           </a:p>
@@ -14895,7 +14895,7 @@
                 <a:ea typeface="Cambria" pitchFamily="34" charset="-122"/>
                 <a:cs typeface="Cambria" pitchFamily="34" charset="-120"/>
               </a:rPr>
-              <a:t>177</a:t>
+              <a:t>182</a:t>
             </a:r>
             <a:endParaRPr lang="en-US" sz="2400" dirty="0"/>
           </a:p>

</xml_diff>

<commit_message>
Documenti: lettore dei siti (script 46) e secondo lotto di gestori
Co-Authored-By: Claude Opus 5.5 <noreply@anthropic.com>
Claude-Session: https://claude.ai/code/session_01E8XCbEeVHWVP3hntUZ6kZ1
</commit_message>
<xml_diff>
--- a/public/documentazione/Presentazione_Portale_CWP.pptx
+++ b/public/documentazione/Presentazione_Portale_CWP.pptx
@@ -122,41 +122,41 @@
   <p:extLst>
     <p:ext uri="{521415D9-36F7-43E2-AB2F-B90AF26B5E84}">
       <p14:sectionLst xmlns:p14="http://schemas.microsoft.com/office/powerpoint/2010/main">
-        <p14:section name="Apertura" id="{f103ac4f-330f-8b9a-6a33-6bf452a07465}">
+        <p14:section name="Apertura" id="{ffc84a41-0759-46c6-cfb0-e646a4743456}">
           <p14:sldIdLst>
             <p14:sldId id="256"/>
           </p14:sldIdLst>
         </p14:section>
-        <p14:section name="Metodologia" id="{bb27aa64-3b49-3a30-d8b8-47b0b77dd9a0}">
+        <p14:section name="Metodologia" id="{86a7953c-9bf7-6359-6ae0-ac8f5fc69c79}">
           <p14:sldIdLst>
             <p14:sldId id="257"/>
           </p14:sldIdLst>
         </p14:section>
-        <p14:section name="Analisi funzionale" id="{23e48304-e601-6c43-a5da-16576dc01039}">
+        <p14:section name="Analisi funzionale" id="{09b1036f-fe66-5ea3-4ca0-b6acbd336499}">
           <p14:sldIdLst>
             <p14:sldId id="258"/>
             <p14:sldId id="259"/>
           </p14:sldIdLst>
         </p14:section>
-        <p14:section name="Già realtà" id="{f6af8de7-3c6a-c460-0512-f6d8dca2b699}">
+        <p14:section name="Già realtà" id="{2f735003-5174-9e82-df6c-e87b764d6476}">
           <p14:sldIdLst>
             <p14:sldId id="260"/>
           </p14:sldIdLst>
         </p14:section>
-        <p14:section name="Architettura e ruoli" id="{e99a87d7-9d68-2c42-a284-9388b3179635}">
+        <p14:section name="Architettura e ruoli" id="{c1337424-0e3b-529c-518d-b7e24061ef5b}">
           <p14:sldIdLst>
             <p14:sldId id="261"/>
             <p14:sldId id="262"/>
           </p14:sldIdLst>
         </p14:section>
-        <p14:section name="Novità" id="{6c762d9e-0e45-61c9-c5a5-8ae9aff5ecfa}">
+        <p14:section name="Novità" id="{0dbbb492-fb8f-ba6c-9932-e492b9995047}">
           <p14:sldIdLst>
             <p14:sldId id="263"/>
             <p14:sldId id="264"/>
             <p14:sldId id="265"/>
           </p14:sldIdLst>
         </p14:section>
-        <p14:section name="Punti aperti" id="{117c4e4a-8f3b-c2bd-5126-b6675b037cf7}">
+        <p14:section name="Punti aperti" id="{f70e330d-7b20-31a9-631c-185d2e099f7b}">
           <p14:sldIdLst>
             <p14:sldId id="266"/>
             <p14:sldId id="267"/>
@@ -165,7 +165,7 @@
             <p14:sldId id="270"/>
           </p14:sldIdLst>
         </p14:section>
-        <p14:section name="Scelte da prendere" id="{a64c973e-abd3-e1a4-989f-28d492098501}">
+        <p14:section name="Scelte da prendere" id="{ab9ef203-faad-135c-47f6-2e14a39efa46}">
           <p14:sldIdLst>
             <p14:sldId id="271"/>
           </p14:sldIdLst>
@@ -574,7 +574,7 @@
           <a:p>
             <a:r>
               <a:rPr lang="en-US" dirty="0"/>
-              <a:t>Presentazione di riepilogo del portale, aggiornata al 23 ottobre 2026 (revisione 4.1): metodologia, funzioni realizzate, novità, punti aperti di sviluppo e scelte ancora da prendere. Si rigenera a ogni rilascio insieme agli altri documenti ed è disponibile agli Amministratori nella pagina Documentazione del portale.</a:t>
+              <a:t>Presentazione di riepilogo del portale, aggiornata al 25 ottobre 2026 (revisione 4.2): metodologia, funzioni realizzate, novità, punti aperti di sviluppo e scelte ancora da prendere. Si rigenera a ogni rilascio insieme agli altri documenti ed è disponibile agli Amministratori nella pagina Documentazione del portale.</a:t>
             </a:r>
             <a:endParaRPr lang="en-US" dirty="0"/>
           </a:p>
@@ -662,7 +662,7 @@
           <a:p>
             <a:r>
               <a:rPr lang="en-US" dirty="0"/>
-              <a:t>Sezione Marketing, richiesta di Luca del 23 ottobre 2026, solo Amministratori. Banche dati: tutti i Comuni italiani (elenco ISTAT con abitanti, poi dall'Indice dei domicili digitali della PA, IndicePA, PEC, email generica, sito, sindaco e responsabili degli uffici tributi, ambiente, finanziario e tecnico) e i gestori iscritti all'Albo Nazionale Gestori Ambientali in categoria 1 ordinaria, sezione per sezione, con verifica sui siti delle attività di raccolta e di gestione della tariffa e dei referenti. Campagne: testo con grafica, invito a scoprire le risorse economiche per 7, 10 o 21 anni; per ogni campagna si scelgono i destinatari (Comuni e gestori, regioni, abitanti, attività); invio solo agli indirizzi email generici, mai alle PEC, con informativa e collegamento per non ricevere altre comunicazioni. Il pulsante «Approfondisci» porta alla pagina pubblica /scopri: il Comune inserisce abitanti, rifiuti totali e secco residuo, durata e listino e vede crediti, ricavi, costi e margine anno per anno con il motore del simulatore; può scaricare il fascicolo informativo e chiedere la registrazione, che arriva a tutti gli Amministratori. Prima degli invii reali: dominio email verificato su Resend e verifica legale delle comunicazioni promozionali via email.</a:t>
+              <a:t>Sezione Marketing, richiesta di Luca del 23 ottobre 2026, solo Amministratori. Banche dati: tutti i Comuni italiani (elenco ISTAT con abitanti, poi dall'Indice dei domicili digitali della PA, IndicePA, PEC, email generica, sito, sindaco e responsabili degli uffici tributi, ambiente, finanziario e tecnico) e i gestori iscritti all'Albo Nazionale Gestori Ambientali in categoria 1 ordinaria, sezione per sezione, con verifica sui siti delle attività di raccolta e di gestione della tariffa e dei referenti. Campagne: testo con grafica, invito a scoprire le risorse economiche per 7, 10 o 21 anni; per ogni campagna si scelgono i destinatari (Comuni e gestori, regioni, abitanti, attività); invio solo agli indirizzi email generici, mai alle PEC, con informativa e collegamento per non ricevere altre comunicazioni. Il pulsante «Approfondisci» porta alla pagina pubblica /scopri: il Comune inserisce abitanti, rifiuti totali e secco residuo, durata e listino e vede crediti, ricavi, costi e margine anno per anno con il motore del simulatore; può scaricare il fascicolo informativo e chiedere la registrazione, che arriva a tutti gli Amministratori. Dal 25 ottobre il portale legge da solo i siti di Comuni e gestori (contatti, uffici, amministrazione trasparente, organigramma) e completa email generica, PEC, telefono, uffici tributi e ambiente e amministratori, con la pagina di provenienza: regole fisse nel codice, nessun servizio a pagamento. Prima degli invii reali: dominio email verificato su Resend e verifica legale delle comunicazioni promozionali via email.</a:t>
             </a:r>
             <a:endParaRPr lang="en-US" dirty="0"/>
           </a:p>
@@ -1542,7 +1542,7 @@
           <a:p>
             <a:r>
               <a:rPr lang="en-US" dirty="0"/>
-              <a:t>Pagina «effetto sorpresa»: nessuno si aspetta che il portale sia già online. Il sistema è stato realizzato da Luca Moretti con l'ausilio di Claude Code ed è quasi terminato; i servizi sono già in produzione: GitHub (codice), Vercel (pubblicazione del portale), Supabase (database, utenti, documenti, funzioni) e Resend (email). Il portale è pubblicato su portale-cwp.vercel.app e funziona con dati di prova: si può aprire durante la presentazione (collegamento cliccabile) o inquadrare il codice QR con il telefono. La pagina pubblica /programma mostra già gli 8 documenti ufficiali del Programma, la Metodologia approvata, la PEC e il soggetto promotore. Lo sviluppo del portale vero è partito il 17 ottobre 2026: da allora sono state pubblicate 184 versioni, 44 script del database e 8 funzioni sul server. Restano i punti aperti delle prossime slide (servizi a pagamento, sicurezza, dati da inserire, collaudo con un Comune). Suggerimento: aprire il portale dal vivo con un utente di prova e mostrare la pagina pubblica.</a:t>
+              <a:t>Pagina «effetto sorpresa»: nessuno si aspetta che il portale sia già online. Il sistema è stato realizzato da Luca Moretti con l'ausilio di Claude Code ed è quasi terminato; i servizi sono già in produzione: GitHub (codice), Vercel (pubblicazione del portale), Supabase (database, utenti, documenti, funzioni) e Resend (email). Il portale è pubblicato su portale-cwp.vercel.app e funziona con dati di prova: si può aprire durante la presentazione (collegamento cliccabile) o inquadrare il codice QR con il telefono. La pagina pubblica /programma mostra già gli 8 documenti ufficiali del Programma, la Metodologia approvata, la PEC e il soggetto promotore. Lo sviluppo del portale vero è partito il 17 ottobre 2026: da allora sono state pubblicate 204 versioni, 46 script del database e 8 funzioni sul server. Restano i punti aperti delle prossime slide (servizi a pagamento, sicurezza, dati da inserire, collaudo con un Comune). Suggerimento: aprire il portale dal vivo con un utente di prova e mostrare la pagina pubblica.</a:t>
             </a:r>
             <a:endParaRPr lang="en-US" dirty="0"/>
           </a:p>
@@ -2253,7 +2253,7 @@
                   <a:schemeClr val="accent6"/>
                 </a:solidFill>
               </a:rPr>
-              <a:t>Portale Carbon WastePrint · Stato dei lavori e recap · 23 ottobre 2026 · rev. 4.1</a:t>
+              <a:t>Portale Carbon WastePrint · Stato dei lavori e recap · 25 ottobre 2026 · rev. 4.2</a:t>
             </a:r>
             <a:endParaRPr lang="en-US" sz="1000" dirty="0"/>
           </a:p>
@@ -2751,7 +2751,7 @@
                   <a:schemeClr val="accent3"/>
                 </a:solidFill>
               </a:rPr>
-              <a:t>Stato dei lavori e recap: metodologia, funzioni, novità, punti aperti e scelte da prendere · aggiornata al 23 ottobre 2026 · rev. 4.1</a:t>
+              <a:t>Stato dei lavori e recap: metodologia, funzioni, novità, punti aperti e scelte da prendere · aggiornata al 25 ottobre 2026 · rev. 4.2</a:t>
             </a:r>
             <a:endParaRPr lang="en-US" sz="1800" dirty="0"/>
           </a:p>
@@ -3079,6 +3079,40 @@
                 </a:solidFill>
               </a:rPr>
               <a:t>imprese dell'Albo Gestori Ambientali in categoria 1, con attività di raccolta e tariffa, PEC, email e referenti</a:t>
+            </a:r>
+            <a:endParaRPr lang="en-US" sz="1350" dirty="0"/>
+          </a:p>
+          <a:p>
+            <a:pPr indent="0" marL="0">
+              <a:spcAft>
+                <a:spcPts val="500"/>
+              </a:spcAft>
+              <a:buNone/>
+            </a:pPr>
+            <a:r>
+              <a:rPr lang="en-US" sz="1350" b="1" dirty="0">
+                <a:solidFill>
+                  <a:schemeClr val="tx2"/>
+                </a:solidFill>
+              </a:rPr>
+              <a:t>Lettura dei siti</a:t>
+            </a:r>
+            <a:endParaRPr lang="en-US" sz="1350" dirty="0"/>
+          </a:p>
+          <a:p>
+            <a:pPr indent="0" marL="0">
+              <a:spcAft>
+                <a:spcPts val="500"/>
+              </a:spcAft>
+              <a:buNone/>
+            </a:pPr>
+            <a:r>
+              <a:rPr lang="en-US" sz="1200" dirty="0">
+                <a:solidFill>
+                  <a:schemeClr val="tx1"/>
+                </a:solidFill>
+              </a:rPr>
+              <a:t>il portale legge da solo i siti di Comuni e gestori e completa recapiti e uffici, con la fonte (regole fisse, gratuito)</a:t>
             </a:r>
             <a:endParaRPr lang="en-US" sz="1350" dirty="0"/>
           </a:p>
@@ -14248,7 +14282,7 @@
                 <a:ea typeface="Cambria" pitchFamily="34" charset="-122"/>
                 <a:cs typeface="Cambria" pitchFamily="34" charset="-120"/>
               </a:rPr>
-              <a:t>44</a:t>
+              <a:t>46</a:t>
             </a:r>
             <a:endParaRPr lang="en-US" sz="3000" dirty="0"/>
           </a:p>
@@ -14554,7 +14588,7 @@
                 <a:ea typeface="Cambria" pitchFamily="34" charset="-122"/>
                 <a:cs typeface="Cambria" pitchFamily="34" charset="-120"/>
               </a:rPr>
-              <a:t>≈42.900</a:t>
+              <a:t>≈44.400</a:t>
             </a:r>
             <a:endParaRPr lang="en-US" sz="3000" dirty="0"/>
           </a:p>
@@ -15341,7 +15375,7 @@
                 <a:ea typeface="Cambria" pitchFamily="34" charset="-122"/>
                 <a:cs typeface="Cambria" pitchFamily="34" charset="-120"/>
               </a:rPr>
-              <a:t>184</a:t>
+              <a:t>204</a:t>
             </a:r>
             <a:endParaRPr lang="en-US" sz="2400" dirty="0"/>
           </a:p>
@@ -15394,7 +15428,7 @@
                 <a:ea typeface="Cambria" pitchFamily="34" charset="-122"/>
                 <a:cs typeface="Cambria" pitchFamily="34" charset="-120"/>
               </a:rPr>
-              <a:t>44</a:t>
+              <a:t>46</a:t>
             </a:r>
             <a:endParaRPr lang="en-US" sz="2400" dirty="0"/>
           </a:p>
@@ -15500,7 +15534,7 @@
                 <a:ea typeface="Cambria" pitchFamily="34" charset="-122"/>
                 <a:cs typeface="Cambria" pitchFamily="34" charset="-120"/>
               </a:rPr>
-              <a:t>≈42.900</a:t>
+              <a:t>≈44.400</a:t>
             </a:r>
             <a:endParaRPr lang="en-US" sz="2400" dirty="0"/>
           </a:p>

</xml_diff>

<commit_message>
Rilascio del 31/10: script 48 in produzione, pulizia del simulatore, documenti aggiornati
- Registro 8.5 (versione 0.48, script 01-48), Registro issue 1.29 (rilievi T in produzione)
- simulatore: tolta taraVariabilita e commenti EsaCom; crediti-cwp.md allineato a T10
- manuali (Utente 4.7, Amministratore 6.10, Test 3.30), DPIA 1.2, presentazione 4.5, base di conoscenza

Co-Authored-By: Claude Opus 5.5 <noreply@anthropic.com>
Claude-Session: https://claude.ai/code/session_01E8XCbEeVHWVP3hntUZ6kZ1
</commit_message>
<xml_diff>
--- a/public/documentazione/Presentazione_Portale_CWP.pptx
+++ b/public/documentazione/Presentazione_Portale_CWP.pptx
@@ -124,34 +124,34 @@
   <p:extLst>
     <p:ext uri="{521415D9-36F7-43E2-AB2F-B90AF26B5E84}">
       <p14:sectionLst xmlns:p14="http://schemas.microsoft.com/office/powerpoint/2010/main">
-        <p14:section name="Apertura" id="{5df3e669-5760-4431-8a7a-13d8d7ae2771}">
+        <p14:section name="Apertura" id="{4097bff3-ffd0-a800-26ab-c2aec0ef800f}">
           <p14:sldIdLst>
             <p14:sldId id="256"/>
           </p14:sldIdLst>
         </p14:section>
-        <p14:section name="Metodologia" id="{b65c0d2f-9cfb-9ab4-f46d-8cc59c353aab}">
+        <p14:section name="Metodologia" id="{c03c48fb-8016-2551-96c4-b926b8849f03}">
           <p14:sldIdLst>
             <p14:sldId id="257"/>
           </p14:sldIdLst>
         </p14:section>
-        <p14:section name="Analisi funzionale" id="{a8cd118c-b5cb-4664-2626-58cf929fe683}">
+        <p14:section name="Analisi funzionale" id="{7911148b-c0f8-a6b2-02b1-6b7f4faed3a1}">
           <p14:sldIdLst>
             <p14:sldId id="258"/>
             <p14:sldId id="259"/>
           </p14:sldIdLst>
         </p14:section>
-        <p14:section name="Già realtà" id="{49326b14-7be2-8c74-b825-6e6fda482018}">
+        <p14:section name="Già realtà" id="{2dafcbcc-29c7-933b-de9d-1abc22c2f59a}">
           <p14:sldIdLst>
             <p14:sldId id="260"/>
           </p14:sldIdLst>
         </p14:section>
-        <p14:section name="Architettura e ruoli" id="{5866044f-8d7c-3622-3971-5c553b57ecf5}">
+        <p14:section name="Architettura e ruoli" id="{feb215ab-7c50-aab1-5321-d07be921c271}">
           <p14:sldIdLst>
             <p14:sldId id="261"/>
             <p14:sldId id="262"/>
           </p14:sldIdLst>
         </p14:section>
-        <p14:section name="Novità" id="{575ce25c-73a7-252e-7a5a-f08895450098}">
+        <p14:section name="Novità" id="{fbb62ef2-9983-ede1-e779-732b75b1bd36}">
           <p14:sldIdLst>
             <p14:sldId id="263"/>
             <p14:sldId id="264"/>
@@ -160,7 +160,7 @@
             <p14:sldId id="267"/>
           </p14:sldIdLst>
         </p14:section>
-        <p14:section name="Punti aperti" id="{8d82e651-f979-e24c-7272-26f4fcda3381}">
+        <p14:section name="Punti aperti" id="{c4bce8b3-8bad-33da-53db-8cc4f0ffeb02}">
           <p14:sldIdLst>
             <p14:sldId id="268"/>
             <p14:sldId id="269"/>
@@ -169,7 +169,7 @@
             <p14:sldId id="272"/>
           </p14:sldIdLst>
         </p14:section>
-        <p14:section name="Scelte da prendere" id="{41db2b14-78ee-a47b-6e40-63fd8193f5e3}">
+        <p14:section name="Scelte da prendere" id="{9cfa58dd-a88c-03a0-087b-71ac4633e3e6}">
           <p14:sldIdLst>
             <p14:sldId id="273"/>
           </p14:sldIdLst>
@@ -578,7 +578,7 @@
           <a:p>
             <a:r>
               <a:rPr lang="en-US" dirty="0"/>
-              <a:t>Presentazione di riepilogo del portale, aggiornata al 30 ottobre 2026 (revisione 4.4): metodologia, funzioni realizzate, novità, punti aperti di sviluppo e scelte ancora da prendere. Si rigenera a ogni rilascio insieme agli altri documenti ed è disponibile agli Amministratori nella pagina Documentazione del portale.</a:t>
+              <a:t>Presentazione di riepilogo del portale, aggiornata al 31 ottobre 2026 (revisione 4.5): metodologia, funzioni realizzate, novità, punti aperti di sviluppo e scelte ancora da prendere. Si rigenera a ogni rilascio insieme agli altri documenti ed è disponibile agli Amministratori nella pagina Documentazione del portale.</a:t>
             </a:r>
             <a:endParaRPr lang="en-US" dirty="0"/>
           </a:p>
@@ -842,7 +842,7 @@
           <a:p>
             <a:r>
               <a:rPr lang="en-US" dirty="0"/>
-              <a:t>Rilievi del documento TEST_PORTALE_CWP del 29 ottobre 2026: 31 punti verificati su portale, codice, database e documenti del Programma. Scelte di Luca del 30 ottobre: correggere tutto tranne il Marketing. Correzioni (script 48 e pagine, da pubblicare con l'OK di Luca): nomi delle fasi come nella Guida; Dashboard con lo stato nel Programma, l'ente di validazione, le fatture scadute e in scadenza e le dichiarazioni di cancellazione dei crediti venduti da ricevere; controllo di codice fiscale e partita IVA e data di approvazione degli enti; verifiche documentali (fasi 2 e 6) solo con i documenti obbligatori e con i codici ISTAT, con deroga motivata dell'Amministratore; codice della pratica sempre automatico; ricorso e costi dei reclami; nel calcolo anno di monitoraggio e anno di riferimento dello Standard 4.8.1, ex post solo per anni conclusi e Progetti registrati, avviso dei risultati non aggiornati; simulatore con il riferimento come da Standard, senza taratura e senza riferimenti EsaCom, valore ipotetico del credito; CSV dell'Audit; Banca Dati Utenze senza nomi e indirizzi. Domande alla Fondazione: fase 7, valore del credito, tipologie di promotori, listino ufficiale, iter del ricorso, paniere del secco, accesso degli enti, invio degli 8 moduli.</a:t>
+              <a:t>Rilievi del documento TEST_PORTALE_CWP del 29 ottobre 2026: 31 punti verificati su portale, codice, database e documenti del Programma. Scelte di Luca del 30 ottobre: correggere tutto tranne il Marketing. Correzioni (script 48 e pagine, in produzione dal 31 ottobre 2026 alle 09:12, da ritestare con i collaudatori): nomi delle fasi come nella Guida; Dashboard con lo stato nel Programma, l'ente di validazione, le fatture scadute e in scadenza e le dichiarazioni di cancellazione dei crediti venduti da ricevere; controllo di codice fiscale e partita IVA e data di approvazione degli enti; verifiche documentali (fasi 2 e 6) solo con i documenti obbligatori e con i codici ISTAT, con deroga motivata dell'Amministratore; codice della pratica sempre automatico; ricorso e costi dei reclami; nel calcolo anno di monitoraggio e anno di riferimento dello Standard 4.8.1, ex post solo per anni conclusi e Progetti registrati, avviso dei risultati non aggiornati; simulatore con il riferimento come da Standard, senza taratura e senza riferimenti EsaCom, valore ipotetico del credito; CSV dell'Audit; Banca Dati Utenze senza nomi e indirizzi. Domande alla Fondazione: fase 7, valore del credito, tipologie di promotori, listino ufficiale, iter del ricorso, paniere del secco, accesso degli enti, invio degli 8 moduli.</a:t>
             </a:r>
             <a:endParaRPr lang="en-US" dirty="0"/>
           </a:p>
@@ -1722,7 +1722,7 @@
           <a:p>
             <a:r>
               <a:rPr lang="en-US" dirty="0"/>
-              <a:t>Pagina «effetto sorpresa»: nessuno si aspetta che il portale sia già online. Il sistema è stato realizzato da Luca Moretti con l'ausilio di Claude Code ed è quasi terminato; i servizi sono già in produzione: GitHub (codice), Vercel (pubblicazione del portale), Supabase (database, utenti, documenti, funzioni) e Resend (email). Il portale è pubblicato su portale-cwp.vercel.app e funziona con dati di prova: si può aprire durante la presentazione (collegamento cliccabile) o inquadrare il codice QR con il telefono. La pagina pubblica /programma mostra già gli 8 documenti ufficiali del Programma, la Metodologia approvata, la PEC e il soggetto promotore. Lo sviluppo del portale vero è partito il 17 ottobre 2026: da allora sono state pubblicate 225 versioni, 48 script del database e 8 funzioni sul server. Restano i punti aperti delle prossime slide (servizi a pagamento, sicurezza, dati da inserire, collaudo con un Comune). Suggerimento: aprire il portale dal vivo con un utente di prova e mostrare la pagina pubblica.</a:t>
+              <a:t>Pagina «effetto sorpresa»: nessuno si aspetta che il portale sia già online. Il sistema è stato realizzato da Luca Moretti con l'ausilio di Claude Code ed è quasi terminato; i servizi sono già in produzione: GitHub (codice), Vercel (pubblicazione del portale), Supabase (database, utenti, documenti, funzioni) e Resend (email). Il portale è pubblicato su portale-cwp.vercel.app e funziona con dati di prova: si può aprire durante la presentazione (collegamento cliccabile) o inquadrare il codice QR con il telefono. La pagina pubblica /programma mostra già gli 8 documenti ufficiali del Programma, la Metodologia approvata, la PEC e il soggetto promotore. Lo sviluppo del portale vero è partito il 17 ottobre 2026: da allora sono state pubblicate 228 versioni, 48 script del database e 8 funzioni sul server. Restano i punti aperti delle prossime slide (servizi a pagamento, sicurezza, dati da inserire, collaudo con un Comune). Suggerimento: aprire il portale dal vivo con un utente di prova e mostrare la pagina pubblica.</a:t>
             </a:r>
             <a:endParaRPr lang="en-US" dirty="0"/>
           </a:p>
@@ -2433,7 +2433,7 @@
                   <a:schemeClr val="accent6"/>
                 </a:solidFill>
               </a:rPr>
-              <a:t>Portale Carbon WastePrint · Stato dei lavori e recap · 30 ottobre 2026 · rev. 4.4</a:t>
+              <a:t>Portale Carbon WastePrint · Stato dei lavori e recap · 31 ottobre 2026 · rev. 4.5</a:t>
             </a:r>
             <a:endParaRPr lang="en-US" sz="1000" dirty="0"/>
           </a:p>
@@ -2931,7 +2931,7 @@
                   <a:schemeClr val="accent3"/>
                 </a:solidFill>
               </a:rPr>
-              <a:t>Stato dei lavori e recap: metodologia, funzioni, novità, punti aperti e scelte da prendere · aggiornata al 30 ottobre 2026 · rev. 4.4</a:t>
+              <a:t>Stato dei lavori e recap: metodologia, funzioni, novità, punti aperti e scelte da prendere · aggiornata al 31 ottobre 2026 · rev. 4.5</a:t>
             </a:r>
             <a:endParaRPr lang="en-US" sz="1800" dirty="0"/>
           </a:p>
@@ -4216,7 +4216,7 @@
       </p:sp>
       <p:sp>
         <p:nvSpPr>
-          <p:cNvPr id="5" name="Numero correzioni pronte"/>
+          <p:cNvPr id="5" name="Numero correzioni in produzione"/>
           <p:cNvSpPr/>
           <p:nvPr/>
         </p:nvSpPr>
@@ -4285,7 +4285,7 @@
                   <a:schemeClr val="tx1"/>
                 </a:solidFill>
               </a:rPr>
-              <a:t>correzioni pronte</a:t>
+              <a:t>correzioni in produzione</a:t>
             </a:r>
             <a:endParaRPr lang="en-US" sz="2600" dirty="0"/>
           </a:p>
@@ -4299,7 +4299,7 @@
                   <a:schemeClr val="tx1"/>
                 </a:solidFill>
               </a:rPr>
-              <a:t>script 48 e pagine, da pubblicare</a:t>
+              <a:t>dal 31 ottobre (script 48)</a:t>
             </a:r>
             <a:endParaRPr lang="en-US" sz="2600" dirty="0"/>
           </a:p>
@@ -16094,7 +16094,7 @@
                 <a:ea typeface="Cambria" pitchFamily="34" charset="-122"/>
                 <a:cs typeface="Cambria" pitchFamily="34" charset="-120"/>
               </a:rPr>
-              <a:t>≈44.700</a:t>
+              <a:t>≈45.700</a:t>
             </a:r>
             <a:endParaRPr lang="en-US" sz="3000" dirty="0"/>
           </a:p>
@@ -16881,7 +16881,7 @@
                 <a:ea typeface="Cambria" pitchFamily="34" charset="-122"/>
                 <a:cs typeface="Cambria" pitchFamily="34" charset="-120"/>
               </a:rPr>
-              <a:t>225</a:t>
+              <a:t>228</a:t>
             </a:r>
             <a:endParaRPr lang="en-US" sz="2400" dirty="0"/>
           </a:p>
@@ -17040,7 +17040,7 @@
                 <a:ea typeface="Cambria" pitchFamily="34" charset="-122"/>
                 <a:cs typeface="Cambria" pitchFamily="34" charset="-120"/>
               </a:rPr>
-              <a:t>≈44.700</a:t>
+              <a:t>≈45.700</a:t>
             </a:r>
             <a:endParaRPr lang="en-US" sz="2400" dirty="0"/>
           </a:p>

</xml_diff>